<commit_message>
Add MBB and Big Four competitor page with official links to manager brief
Co-Authored-By: Claude Opus 5.5 <noreply@anthropic.com>
Claude-Session: https://claude.ai/code/session_01GwCwwmQUjvhTXeuyRaxofg
</commit_message>
<xml_diff>
--- a/research/insurtech-2026/保險科技服務優先順序_主管精簡版.pptx
+++ b/research/insurtech-2026/保險科技服務優先順序_主管精簡版.pptx
@@ -16,6 +16,7 @@
     <p:sldId id="256" r:id="rId17"/>
     <p:sldId id="257" r:id="rId18"/>
     <p:sldId id="258" r:id="rId19"/>
+    <p:sldId id="259" r:id="rId20"/>
   </p:sldIdLst>
   <p:sldSz cx="12192000" cy="6858000"/>
   <p:notesSz cx="6858000" cy="9144000"/>
@@ -47069,6 +47070,2639 @@
 </file>
 
 <file path=ppt/slides/slide3.xml><?xml version="1.0" encoding="utf-8"?>
+<p:sld xmlns:a="http://schemas.openxmlformats.org/drawingml/2006/main" xmlns:p="http://schemas.openxmlformats.org/presentationml/2006/main" xmlns:r="http://schemas.openxmlformats.org/officeDocument/2006/relationships">
+  <p:cSld>
+    <p:spTree>
+      <p:nvGrpSpPr>
+        <p:cNvPr id="1" name=""/>
+        <p:cNvGrpSpPr/>
+        <p:nvPr/>
+      </p:nvGrpSpPr>
+      <p:grpSpPr/>
+      <p:sp>
+        <p:nvSpPr>
+          <p:cNvPr id="2" name="Title 1"/>
+          <p:cNvSpPr>
+            <a:spLocks noGrp="1"/>
+          </p:cNvSpPr>
+          <p:nvPr>
+            <p:ph type="title"/>
+          </p:nvPr>
+        </p:nvSpPr>
+        <p:spPr/>
+        <p:txBody>
+          <a:bodyPr/>
+          <a:lstStyle/>
+          <a:p>
+            <a:r>
+              <a:rPr sz="2000">
+                <a:latin typeface="Microsoft JhengHei"/>
+              </a:rPr>
+              <a:t>MBB 與四大都在推代理型 AI 藍圖或平台；我們的空間在在地確信、IFRS 17 資料與駐點人力</a:t>
+            </a:r>
+          </a:p>
+        </p:txBody>
+      </p:sp>
+      <p:sp>
+        <p:nvSpPr>
+          <p:cNvPr id="3" name="Rectangle 2"/>
+          <p:cNvSpPr/>
+          <p:nvPr/>
+        </p:nvSpPr>
+        <p:spPr>
+          <a:xfrm>
+            <a:off x="411480" y="1280160"/>
+            <a:ext cx="1289304" cy="347472"/>
+          </a:xfrm>
+          <a:prstGeom prst="rect">
+            <a:avLst/>
+          </a:prstGeom>
+          <a:solidFill>
+            <a:srgbClr val="FD5108"/>
+          </a:solidFill>
+          <a:ln>
+            <a:noFill/>
+          </a:ln>
+          <a:effectLst/>
+        </p:spPr>
+        <p:style>
+          <a:lnRef idx="1">
+            <a:schemeClr val="accent1"/>
+          </a:lnRef>
+          <a:fillRef idx="3">
+            <a:schemeClr val="accent1"/>
+          </a:fillRef>
+          <a:effectRef idx="2">
+            <a:schemeClr val="accent1"/>
+          </a:effectRef>
+          <a:fontRef idx="minor">
+            <a:schemeClr val="lt1"/>
+          </a:fontRef>
+        </p:style>
+        <p:txBody>
+          <a:bodyPr rtlCol="0" anchor="ctr" wrap="square" lIns="73152" rIns="73152" tIns="73152" bIns="73152"/>
+          <a:lstStyle/>
+          <a:p>
+            <a:pPr algn="l">
+              <a:spcAft>
+                <a:spcPts val="200"/>
+              </a:spcAft>
+            </a:pPr>
+            <a:r>
+              <a:rPr sz="1100" b="1">
+                <a:solidFill>
+                  <a:srgbClr val="FFFFFF"/>
+                </a:solidFill>
+                <a:latin typeface="Microsoft JhengHei"/>
+              </a:rPr>
+              <a:t>機構</a:t>
+            </a:r>
+          </a:p>
+        </p:txBody>
+      </p:sp>
+      <p:sp>
+        <p:nvSpPr>
+          <p:cNvPr id="4" name="Rectangle 3"/>
+          <p:cNvSpPr/>
+          <p:nvPr/>
+        </p:nvSpPr>
+        <p:spPr>
+          <a:xfrm>
+            <a:off x="1737360" y="1280160"/>
+            <a:ext cx="4169663" cy="347472"/>
+          </a:xfrm>
+          <a:prstGeom prst="rect">
+            <a:avLst/>
+          </a:prstGeom>
+          <a:solidFill>
+            <a:srgbClr val="FD5108"/>
+          </a:solidFill>
+          <a:ln>
+            <a:noFill/>
+          </a:ln>
+          <a:effectLst/>
+        </p:spPr>
+        <p:style>
+          <a:lnRef idx="1">
+            <a:schemeClr val="accent1"/>
+          </a:lnRef>
+          <a:fillRef idx="3">
+            <a:schemeClr val="accent1"/>
+          </a:fillRef>
+          <a:effectRef idx="2">
+            <a:schemeClr val="accent1"/>
+          </a:effectRef>
+          <a:fontRef idx="minor">
+            <a:schemeClr val="lt1"/>
+          </a:fontRef>
+        </p:style>
+        <p:txBody>
+          <a:bodyPr rtlCol="0" anchor="ctr" wrap="square" lIns="73152" rIns="73152" tIns="73152" bIns="73152"/>
+          <a:lstStyle/>
+          <a:p>
+            <a:pPr algn="l">
+              <a:spcAft>
+                <a:spcPts val="200"/>
+              </a:spcAft>
+            </a:pPr>
+            <a:r>
+              <a:rPr sz="1100" b="1">
+                <a:solidFill>
+                  <a:srgbClr val="FFFFFF"/>
+                </a:solidFill>
+                <a:latin typeface="Microsoft JhengHei"/>
+              </a:rPr>
+              <a:t>保險 AI 主力產品／方法</a:t>
+            </a:r>
+          </a:p>
+        </p:txBody>
+      </p:sp>
+      <p:sp>
+        <p:nvSpPr>
+          <p:cNvPr id="5" name="Rectangle 4"/>
+          <p:cNvSpPr/>
+          <p:nvPr/>
+        </p:nvSpPr>
+        <p:spPr>
+          <a:xfrm>
+            <a:off x="5943600" y="1280160"/>
+            <a:ext cx="1837943" cy="347472"/>
+          </a:xfrm>
+          <a:prstGeom prst="rect">
+            <a:avLst/>
+          </a:prstGeom>
+          <a:solidFill>
+            <a:srgbClr val="FD5108"/>
+          </a:solidFill>
+          <a:ln>
+            <a:noFill/>
+          </a:ln>
+          <a:effectLst/>
+        </p:spPr>
+        <p:style>
+          <a:lnRef idx="1">
+            <a:schemeClr val="accent1"/>
+          </a:lnRef>
+          <a:fillRef idx="3">
+            <a:schemeClr val="accent1"/>
+          </a:fillRef>
+          <a:effectRef idx="2">
+            <a:schemeClr val="accent1"/>
+          </a:effectRef>
+          <a:fontRef idx="minor">
+            <a:schemeClr val="lt1"/>
+          </a:fontRef>
+        </p:style>
+        <p:txBody>
+          <a:bodyPr rtlCol="0" anchor="ctr" wrap="square" lIns="73152" rIns="73152" tIns="73152" bIns="73152"/>
+          <a:lstStyle/>
+          <a:p>
+            <a:pPr algn="l">
+              <a:spcAft>
+                <a:spcPts val="200"/>
+              </a:spcAft>
+            </a:pPr>
+            <a:r>
+              <a:rPr sz="1100" b="1">
+                <a:solidFill>
+                  <a:srgbClr val="FFFFFF"/>
+                </a:solidFill>
+                <a:latin typeface="Microsoft JhengHei"/>
+              </a:rPr>
+              <a:t>主攻</a:t>
+            </a:r>
+          </a:p>
+        </p:txBody>
+      </p:sp>
+      <p:sp>
+        <p:nvSpPr>
+          <p:cNvPr id="6" name="Rectangle 5"/>
+          <p:cNvSpPr/>
+          <p:nvPr/>
+        </p:nvSpPr>
+        <p:spPr>
+          <a:xfrm>
+            <a:off x="7818120" y="1280160"/>
+            <a:ext cx="2478024" cy="347472"/>
+          </a:xfrm>
+          <a:prstGeom prst="rect">
+            <a:avLst/>
+          </a:prstGeom>
+          <a:solidFill>
+            <a:srgbClr val="FD5108"/>
+          </a:solidFill>
+          <a:ln>
+            <a:noFill/>
+          </a:ln>
+          <a:effectLst/>
+        </p:spPr>
+        <p:style>
+          <a:lnRef idx="1">
+            <a:schemeClr val="accent1"/>
+          </a:lnRef>
+          <a:fillRef idx="3">
+            <a:schemeClr val="accent1"/>
+          </a:fillRef>
+          <a:effectRef idx="2">
+            <a:schemeClr val="accent1"/>
+          </a:effectRef>
+          <a:fontRef idx="minor">
+            <a:schemeClr val="lt1"/>
+          </a:fontRef>
+        </p:style>
+        <p:txBody>
+          <a:bodyPr rtlCol="0" anchor="ctr" wrap="square" lIns="73152" rIns="73152" tIns="73152" bIns="73152"/>
+          <a:lstStyle/>
+          <a:p>
+            <a:pPr algn="l">
+              <a:spcAft>
+                <a:spcPts val="200"/>
+              </a:spcAft>
+            </a:pPr>
+            <a:r>
+              <a:rPr sz="1100" b="1">
+                <a:solidFill>
+                  <a:srgbClr val="FFFFFF"/>
+                </a:solidFill>
+                <a:latin typeface="Microsoft JhengHei"/>
+              </a:rPr>
+              <a:t>可能侷限（推論）</a:t>
+            </a:r>
+          </a:p>
+        </p:txBody>
+      </p:sp>
+      <p:sp>
+        <p:nvSpPr>
+          <p:cNvPr id="7" name="Rectangle 6"/>
+          <p:cNvSpPr/>
+          <p:nvPr/>
+        </p:nvSpPr>
+        <p:spPr>
+          <a:xfrm>
+            <a:off x="10332720" y="1280160"/>
+            <a:ext cx="1426464" cy="347472"/>
+          </a:xfrm>
+          <a:prstGeom prst="rect">
+            <a:avLst/>
+          </a:prstGeom>
+          <a:solidFill>
+            <a:srgbClr val="FD5108"/>
+          </a:solidFill>
+          <a:ln>
+            <a:noFill/>
+          </a:ln>
+          <a:effectLst/>
+        </p:spPr>
+        <p:style>
+          <a:lnRef idx="1">
+            <a:schemeClr val="accent1"/>
+          </a:lnRef>
+          <a:fillRef idx="3">
+            <a:schemeClr val="accent1"/>
+          </a:fillRef>
+          <a:effectRef idx="2">
+            <a:schemeClr val="accent1"/>
+          </a:effectRef>
+          <a:fontRef idx="minor">
+            <a:schemeClr val="lt1"/>
+          </a:fontRef>
+        </p:style>
+        <p:txBody>
+          <a:bodyPr rtlCol="0" anchor="ctr" wrap="square" lIns="73152" rIns="73152" tIns="73152" bIns="73152"/>
+          <a:lstStyle/>
+          <a:p>
+            <a:pPr algn="l">
+              <a:spcAft>
+                <a:spcPts val="200"/>
+              </a:spcAft>
+            </a:pPr>
+            <a:r>
+              <a:rPr sz="1100" b="1">
+                <a:solidFill>
+                  <a:srgbClr val="FFFFFF"/>
+                </a:solidFill>
+                <a:latin typeface="Microsoft JhengHei"/>
+              </a:rPr>
+              <a:t>官網／原文</a:t>
+            </a:r>
+          </a:p>
+        </p:txBody>
+      </p:sp>
+      <p:sp>
+        <p:nvSpPr>
+          <p:cNvPr id="8" name="Rectangle 7"/>
+          <p:cNvSpPr/>
+          <p:nvPr/>
+        </p:nvSpPr>
+        <p:spPr>
+          <a:xfrm>
+            <a:off x="411480" y="1664207"/>
+            <a:ext cx="1289304" cy="566928"/>
+          </a:xfrm>
+          <a:prstGeom prst="rect">
+            <a:avLst/>
+          </a:prstGeom>
+          <a:solidFill>
+            <a:srgbClr val="F3F3F3"/>
+          </a:solidFill>
+          <a:ln>
+            <a:noFill/>
+          </a:ln>
+          <a:effectLst/>
+        </p:spPr>
+        <p:style>
+          <a:lnRef idx="1">
+            <a:schemeClr val="accent1"/>
+          </a:lnRef>
+          <a:fillRef idx="3">
+            <a:schemeClr val="accent1"/>
+          </a:fillRef>
+          <a:effectRef idx="2">
+            <a:schemeClr val="accent1"/>
+          </a:effectRef>
+          <a:fontRef idx="minor">
+            <a:schemeClr val="lt1"/>
+          </a:fontRef>
+        </p:style>
+        <p:txBody>
+          <a:bodyPr rtlCol="0" anchor="ctr" wrap="square" lIns="64008" rIns="64008" tIns="64008" bIns="64008"/>
+          <a:lstStyle/>
+          <a:p>
+            <a:pPr algn="l">
+              <a:spcAft>
+                <a:spcPts val="200"/>
+              </a:spcAft>
+            </a:pPr>
+            <a:r>
+              <a:rPr sz="1150" b="1">
+                <a:solidFill>
+                  <a:srgbClr val="1E1E1E"/>
+                </a:solidFill>
+                <a:latin typeface="Microsoft JhengHei"/>
+              </a:rPr>
+              <a:t>McKinsey</a:t>
+            </a:r>
+          </a:p>
+          <a:p>
+            <a:pPr algn="l">
+              <a:spcAft>
+                <a:spcPts val="200"/>
+              </a:spcAft>
+            </a:pPr>
+            <a:r>
+              <a:rPr sz="900" b="0">
+                <a:solidFill>
+                  <a:srgbClr val="6B6B6B"/>
+                </a:solidFill>
+                <a:latin typeface="Microsoft JhengHei"/>
+              </a:rPr>
+              <a:t>MBB</a:t>
+            </a:r>
+          </a:p>
+        </p:txBody>
+      </p:sp>
+      <p:sp>
+        <p:nvSpPr>
+          <p:cNvPr id="9" name="Rectangle 8"/>
+          <p:cNvSpPr/>
+          <p:nvPr/>
+        </p:nvSpPr>
+        <p:spPr>
+          <a:xfrm>
+            <a:off x="1737360" y="1664207"/>
+            <a:ext cx="4169663" cy="566928"/>
+          </a:xfrm>
+          <a:prstGeom prst="rect">
+            <a:avLst/>
+          </a:prstGeom>
+          <a:solidFill>
+            <a:srgbClr val="F3F3F3"/>
+          </a:solidFill>
+          <a:ln>
+            <a:noFill/>
+          </a:ln>
+          <a:effectLst/>
+        </p:spPr>
+        <p:style>
+          <a:lnRef idx="1">
+            <a:schemeClr val="accent1"/>
+          </a:lnRef>
+          <a:fillRef idx="3">
+            <a:schemeClr val="accent1"/>
+          </a:fillRef>
+          <a:effectRef idx="2">
+            <a:schemeClr val="accent1"/>
+          </a:effectRef>
+          <a:fontRef idx="minor">
+            <a:schemeClr val="lt1"/>
+          </a:fontRef>
+        </p:style>
+        <p:txBody>
+          <a:bodyPr rtlCol="0" anchor="ctr" wrap="square" lIns="64008" rIns="64008" tIns="64008" bIns="64008"/>
+          <a:lstStyle/>
+          <a:p>
+            <a:pPr algn="l">
+              <a:spcAft>
+                <a:spcPts val="200"/>
+              </a:spcAft>
+            </a:pPr>
+            <a:r>
+              <a:rPr sz="1000" b="0">
+                <a:solidFill>
+                  <a:srgbClr val="1E1E1E"/>
+                </a:solidFill>
+                <a:latin typeface="Microsoft JhengHei"/>
+              </a:rPr>
+              <a:t>核保作業系統 UWOS：45 項能力、6 大領域；代理型 AI 核心現代化（原子化代理能力庫）</a:t>
+            </a:r>
+          </a:p>
+        </p:txBody>
+      </p:sp>
+      <p:sp>
+        <p:nvSpPr>
+          <p:cNvPr id="10" name="Rectangle 9"/>
+          <p:cNvSpPr/>
+          <p:nvPr/>
+        </p:nvSpPr>
+        <p:spPr>
+          <a:xfrm>
+            <a:off x="5943600" y="1664207"/>
+            <a:ext cx="1837943" cy="566928"/>
+          </a:xfrm>
+          <a:prstGeom prst="rect">
+            <a:avLst/>
+          </a:prstGeom>
+          <a:solidFill>
+            <a:srgbClr val="F3F3F3"/>
+          </a:solidFill>
+          <a:ln>
+            <a:noFill/>
+          </a:ln>
+          <a:effectLst/>
+        </p:spPr>
+        <p:style>
+          <a:lnRef idx="1">
+            <a:schemeClr val="accent1"/>
+          </a:lnRef>
+          <a:fillRef idx="3">
+            <a:schemeClr val="accent1"/>
+          </a:fillRef>
+          <a:effectRef idx="2">
+            <a:schemeClr val="accent1"/>
+          </a:effectRef>
+          <a:fontRef idx="minor">
+            <a:schemeClr val="lt1"/>
+          </a:fontRef>
+        </p:style>
+        <p:txBody>
+          <a:bodyPr rtlCol="0" anchor="ctr" wrap="square" lIns="64008" rIns="64008" tIns="64008" bIns="64008"/>
+          <a:lstStyle/>
+          <a:p>
+            <a:pPr algn="l">
+              <a:spcAft>
+                <a:spcPts val="200"/>
+              </a:spcAft>
+            </a:pPr>
+            <a:r>
+              <a:rPr sz="1000" b="0">
+                <a:solidFill>
+                  <a:srgbClr val="1E1E1E"/>
+                </a:solidFill>
+                <a:latin typeface="Microsoft JhengHei"/>
+              </a:rPr>
+              <a:t>商業與專業險核保、核心重寫</a:t>
+            </a:r>
+          </a:p>
+        </p:txBody>
+      </p:sp>
+      <p:sp>
+        <p:nvSpPr>
+          <p:cNvPr id="11" name="Rectangle 10"/>
+          <p:cNvSpPr/>
+          <p:nvPr/>
+        </p:nvSpPr>
+        <p:spPr>
+          <a:xfrm>
+            <a:off x="7818120" y="1664207"/>
+            <a:ext cx="2478024" cy="566928"/>
+          </a:xfrm>
+          <a:prstGeom prst="rect">
+            <a:avLst/>
+          </a:prstGeom>
+          <a:solidFill>
+            <a:srgbClr val="F3F3F3"/>
+          </a:solidFill>
+          <a:ln>
+            <a:noFill/>
+          </a:ln>
+          <a:effectLst/>
+        </p:spPr>
+        <p:style>
+          <a:lnRef idx="1">
+            <a:schemeClr val="accent1"/>
+          </a:lnRef>
+          <a:fillRef idx="3">
+            <a:schemeClr val="accent1"/>
+          </a:fillRef>
+          <a:effectRef idx="2">
+            <a:schemeClr val="accent1"/>
+          </a:effectRef>
+          <a:fontRef idx="minor">
+            <a:schemeClr val="lt1"/>
+          </a:fontRef>
+        </p:style>
+        <p:txBody>
+          <a:bodyPr rtlCol="0" anchor="ctr" wrap="square" lIns="64008" rIns="64008" tIns="64008" bIns="64008"/>
+          <a:lstStyle/>
+          <a:p>
+            <a:pPr algn="l">
+              <a:spcAft>
+                <a:spcPts val="200"/>
+              </a:spcAft>
+            </a:pPr>
+            <a:r>
+              <a:rPr sz="1000" b="0">
+                <a:solidFill>
+                  <a:srgbClr val="1E1E1E"/>
+                </a:solidFill>
+                <a:latin typeface="Microsoft JhengHei"/>
+              </a:rPr>
+              <a:t>在台缺在地法規確信與長期駐點人力</a:t>
+            </a:r>
+          </a:p>
+        </p:txBody>
+      </p:sp>
+      <p:sp>
+        <p:nvSpPr>
+          <p:cNvPr id="12" name="Rectangle 11"/>
+          <p:cNvSpPr/>
+          <p:nvPr/>
+        </p:nvSpPr>
+        <p:spPr>
+          <a:xfrm>
+            <a:off x="10332720" y="1664207"/>
+            <a:ext cx="1426464" cy="566928"/>
+          </a:xfrm>
+          <a:prstGeom prst="rect">
+            <a:avLst/>
+          </a:prstGeom>
+          <a:solidFill>
+            <a:srgbClr val="F3F3F3"/>
+          </a:solidFill>
+          <a:ln>
+            <a:noFill/>
+          </a:ln>
+          <a:effectLst/>
+        </p:spPr>
+        <p:style>
+          <a:lnRef idx="1">
+            <a:schemeClr val="accent1"/>
+          </a:lnRef>
+          <a:fillRef idx="3">
+            <a:schemeClr val="accent1"/>
+          </a:fillRef>
+          <a:effectRef idx="2">
+            <a:schemeClr val="accent1"/>
+          </a:effectRef>
+          <a:fontRef idx="minor">
+            <a:schemeClr val="lt1"/>
+          </a:fontRef>
+        </p:style>
+        <p:txBody>
+          <a:bodyPr rtlCol="0" anchor="ctr" wrap="square" lIns="64008" rIns="64008" tIns="64008" bIns="64008"/>
+          <a:lstStyle/>
+          <a:p>
+            <a:pPr algn="l">
+              <a:spcAft>
+                <a:spcPts val="200"/>
+              </a:spcAft>
+            </a:pPr>
+            <a:r>
+              <a:rPr sz="950" b="0" u="sng">
+                <a:solidFill>
+                  <a:srgbClr val="1F5FBF"/>
+                </a:solidFill>
+                <a:latin typeface="Microsoft JhengHei"/>
+                <a:hlinkClick r:id="rId2"/>
+              </a:rPr>
+              <a:t>UWOS</a:t>
+            </a:r>
+          </a:p>
+          <a:p>
+            <a:pPr algn="l">
+              <a:spcAft>
+                <a:spcPts val="200"/>
+              </a:spcAft>
+            </a:pPr>
+            <a:r>
+              <a:rPr sz="950" b="0" u="sng">
+                <a:solidFill>
+                  <a:srgbClr val="1F5FBF"/>
+                </a:solidFill>
+                <a:latin typeface="Microsoft JhengHei"/>
+                <a:hlinkClick r:id="rId3"/>
+              </a:rPr>
+              <a:t>核心現代化</a:t>
+            </a:r>
+          </a:p>
+        </p:txBody>
+      </p:sp>
+      <p:sp>
+        <p:nvSpPr>
+          <p:cNvPr id="13" name="Rectangle 12"/>
+          <p:cNvSpPr/>
+          <p:nvPr/>
+        </p:nvSpPr>
+        <p:spPr>
+          <a:xfrm>
+            <a:off x="411480" y="2267712"/>
+            <a:ext cx="1289304" cy="566928"/>
+          </a:xfrm>
+          <a:prstGeom prst="rect">
+            <a:avLst/>
+          </a:prstGeom>
+          <a:solidFill>
+            <a:srgbClr val="FFFFFF"/>
+          </a:solidFill>
+          <a:ln>
+            <a:noFill/>
+          </a:ln>
+          <a:effectLst/>
+        </p:spPr>
+        <p:style>
+          <a:lnRef idx="1">
+            <a:schemeClr val="accent1"/>
+          </a:lnRef>
+          <a:fillRef idx="3">
+            <a:schemeClr val="accent1"/>
+          </a:fillRef>
+          <a:effectRef idx="2">
+            <a:schemeClr val="accent1"/>
+          </a:effectRef>
+          <a:fontRef idx="minor">
+            <a:schemeClr val="lt1"/>
+          </a:fontRef>
+        </p:style>
+        <p:txBody>
+          <a:bodyPr rtlCol="0" anchor="ctr" wrap="square" lIns="64008" rIns="64008" tIns="64008" bIns="64008"/>
+          <a:lstStyle/>
+          <a:p>
+            <a:pPr algn="l">
+              <a:spcAft>
+                <a:spcPts val="200"/>
+              </a:spcAft>
+            </a:pPr>
+            <a:r>
+              <a:rPr sz="1150" b="1">
+                <a:solidFill>
+                  <a:srgbClr val="1E1E1E"/>
+                </a:solidFill>
+                <a:latin typeface="Microsoft JhengHei"/>
+              </a:rPr>
+              <a:t>BCG</a:t>
+            </a:r>
+          </a:p>
+          <a:p>
+            <a:pPr algn="l">
+              <a:spcAft>
+                <a:spcPts val="200"/>
+              </a:spcAft>
+            </a:pPr>
+            <a:r>
+              <a:rPr sz="900" b="0">
+                <a:solidFill>
+                  <a:srgbClr val="6B6B6B"/>
+                </a:solidFill>
+                <a:latin typeface="Microsoft JhengHei"/>
+              </a:rPr>
+              <a:t>MBB</a:t>
+            </a:r>
+          </a:p>
+        </p:txBody>
+      </p:sp>
+      <p:sp>
+        <p:nvSpPr>
+          <p:cNvPr id="14" name="Rectangle 13"/>
+          <p:cNvSpPr/>
+          <p:nvPr/>
+        </p:nvSpPr>
+        <p:spPr>
+          <a:xfrm>
+            <a:off x="1737360" y="2267712"/>
+            <a:ext cx="4169663" cy="566928"/>
+          </a:xfrm>
+          <a:prstGeom prst="rect">
+            <a:avLst/>
+          </a:prstGeom>
+          <a:solidFill>
+            <a:srgbClr val="FFFFFF"/>
+          </a:solidFill>
+          <a:ln>
+            <a:noFill/>
+          </a:ln>
+          <a:effectLst/>
+        </p:spPr>
+        <p:style>
+          <a:lnRef idx="1">
+            <a:schemeClr val="accent1"/>
+          </a:lnRef>
+          <a:fillRef idx="3">
+            <a:schemeClr val="accent1"/>
+          </a:fillRef>
+          <a:effectRef idx="2">
+            <a:schemeClr val="accent1"/>
+          </a:effectRef>
+          <a:fontRef idx="minor">
+            <a:schemeClr val="lt1"/>
+          </a:fontRef>
+        </p:style>
+        <p:txBody>
+          <a:bodyPr rtlCol="0" anchor="ctr" wrap="square" lIns="64008" rIns="64008" tIns="64008" bIns="64008"/>
+          <a:lstStyle/>
+          <a:p>
+            <a:pPr algn="l">
+              <a:spcAft>
+                <a:spcPts val="200"/>
+              </a:spcAft>
+            </a:pPr>
+            <a:r>
+              <a:rPr sz="1000" b="0">
+                <a:solidFill>
+                  <a:srgbClr val="1E1E1E"/>
+                </a:solidFill>
+                <a:latin typeface="Microsoft JhengHei"/>
+              </a:rPr>
+              <a:t>「AI-First 產險公司」三階段藍圖；亞太保險代理型 AI 白皮書（資源 70% 放在人與變革）</a:t>
+            </a:r>
+          </a:p>
+        </p:txBody>
+      </p:sp>
+      <p:sp>
+        <p:nvSpPr>
+          <p:cNvPr id="15" name="Rectangle 14"/>
+          <p:cNvSpPr/>
+          <p:nvPr/>
+        </p:nvSpPr>
+        <p:spPr>
+          <a:xfrm>
+            <a:off x="5943600" y="2267712"/>
+            <a:ext cx="1837943" cy="566928"/>
+          </a:xfrm>
+          <a:prstGeom prst="rect">
+            <a:avLst/>
+          </a:prstGeom>
+          <a:solidFill>
+            <a:srgbClr val="FFFFFF"/>
+          </a:solidFill>
+          <a:ln>
+            <a:noFill/>
+          </a:ln>
+          <a:effectLst/>
+        </p:spPr>
+        <p:style>
+          <a:lnRef idx="1">
+            <a:schemeClr val="accent1"/>
+          </a:lnRef>
+          <a:fillRef idx="3">
+            <a:schemeClr val="accent1"/>
+          </a:fillRef>
+          <a:effectRef idx="2">
+            <a:schemeClr val="accent1"/>
+          </a:effectRef>
+          <a:fontRef idx="minor">
+            <a:schemeClr val="lt1"/>
+          </a:fontRef>
+        </p:style>
+        <p:txBody>
+          <a:bodyPr rtlCol="0" anchor="ctr" wrap="square" lIns="64008" rIns="64008" tIns="64008" bIns="64008"/>
+          <a:lstStyle/>
+          <a:p>
+            <a:pPr algn="l">
+              <a:spcAft>
+                <a:spcPts val="200"/>
+              </a:spcAft>
+            </a:pPr>
+            <a:r>
+              <a:rPr sz="1000" b="0">
+                <a:solidFill>
+                  <a:srgbClr val="1E1E1E"/>
+                </a:solidFill>
+                <a:latin typeface="Microsoft JhengHei"/>
+              </a:rPr>
+              <a:t>策略藍圖、組織變革</a:t>
+            </a:r>
+          </a:p>
+        </p:txBody>
+      </p:sp>
+      <p:sp>
+        <p:nvSpPr>
+          <p:cNvPr id="16" name="Rectangle 15"/>
+          <p:cNvSpPr/>
+          <p:nvPr/>
+        </p:nvSpPr>
+        <p:spPr>
+          <a:xfrm>
+            <a:off x="7818120" y="2267712"/>
+            <a:ext cx="2478024" cy="566928"/>
+          </a:xfrm>
+          <a:prstGeom prst="rect">
+            <a:avLst/>
+          </a:prstGeom>
+          <a:solidFill>
+            <a:srgbClr val="FFFFFF"/>
+          </a:solidFill>
+          <a:ln>
+            <a:noFill/>
+          </a:ln>
+          <a:effectLst/>
+        </p:spPr>
+        <p:style>
+          <a:lnRef idx="1">
+            <a:schemeClr val="accent1"/>
+          </a:lnRef>
+          <a:fillRef idx="3">
+            <a:schemeClr val="accent1"/>
+          </a:fillRef>
+          <a:effectRef idx="2">
+            <a:schemeClr val="accent1"/>
+          </a:effectRef>
+          <a:fontRef idx="minor">
+            <a:schemeClr val="lt1"/>
+          </a:fontRef>
+        </p:style>
+        <p:txBody>
+          <a:bodyPr rtlCol="0" anchor="ctr" wrap="square" lIns="64008" rIns="64008" tIns="64008" bIns="64008"/>
+          <a:lstStyle/>
+          <a:p>
+            <a:pPr algn="l">
+              <a:spcAft>
+                <a:spcPts val="200"/>
+              </a:spcAft>
+            </a:pPr>
+            <a:r>
+              <a:rPr sz="1000" b="0">
+                <a:solidFill>
+                  <a:srgbClr val="1E1E1E"/>
+                </a:solidFill>
+                <a:latin typeface="Microsoft JhengHei"/>
+              </a:rPr>
+              <a:t>偏策略與變革設計，系統落地多需另找夥伴</a:t>
+            </a:r>
+          </a:p>
+        </p:txBody>
+      </p:sp>
+      <p:sp>
+        <p:nvSpPr>
+          <p:cNvPr id="17" name="Rectangle 16"/>
+          <p:cNvSpPr/>
+          <p:nvPr/>
+        </p:nvSpPr>
+        <p:spPr>
+          <a:xfrm>
+            <a:off x="10332720" y="2267712"/>
+            <a:ext cx="1426464" cy="566928"/>
+          </a:xfrm>
+          <a:prstGeom prst="rect">
+            <a:avLst/>
+          </a:prstGeom>
+          <a:solidFill>
+            <a:srgbClr val="FFFFFF"/>
+          </a:solidFill>
+          <a:ln>
+            <a:noFill/>
+          </a:ln>
+          <a:effectLst/>
+        </p:spPr>
+        <p:style>
+          <a:lnRef idx="1">
+            <a:schemeClr val="accent1"/>
+          </a:lnRef>
+          <a:fillRef idx="3">
+            <a:schemeClr val="accent1"/>
+          </a:fillRef>
+          <a:effectRef idx="2">
+            <a:schemeClr val="accent1"/>
+          </a:effectRef>
+          <a:fontRef idx="minor">
+            <a:schemeClr val="lt1"/>
+          </a:fontRef>
+        </p:style>
+        <p:txBody>
+          <a:bodyPr rtlCol="0" anchor="ctr" wrap="square" lIns="64008" rIns="64008" tIns="64008" bIns="64008"/>
+          <a:lstStyle/>
+          <a:p>
+            <a:pPr algn="l">
+              <a:spcAft>
+                <a:spcPts val="200"/>
+              </a:spcAft>
+            </a:pPr>
+            <a:r>
+              <a:rPr sz="950" b="0" u="sng">
+                <a:solidFill>
+                  <a:srgbClr val="1F5FBF"/>
+                </a:solidFill>
+                <a:latin typeface="Microsoft JhengHei"/>
+                <a:hlinkClick r:id="rId4"/>
+              </a:rPr>
+              <a:t>亞太白皮書</a:t>
+            </a:r>
+          </a:p>
+          <a:p>
+            <a:pPr algn="l">
+              <a:spcAft>
+                <a:spcPts val="200"/>
+              </a:spcAft>
+            </a:pPr>
+            <a:r>
+              <a:rPr sz="950" b="0" u="sng">
+                <a:solidFill>
+                  <a:srgbClr val="1F5FBF"/>
+                </a:solidFill>
+                <a:latin typeface="Microsoft JhengHei"/>
+                <a:hlinkClick r:id="rId5"/>
+              </a:rPr>
+              <a:t>產險藍圖</a:t>
+            </a:r>
+          </a:p>
+        </p:txBody>
+      </p:sp>
+      <p:sp>
+        <p:nvSpPr>
+          <p:cNvPr id="18" name="Rectangle 17"/>
+          <p:cNvSpPr/>
+          <p:nvPr/>
+        </p:nvSpPr>
+        <p:spPr>
+          <a:xfrm>
+            <a:off x="411480" y="2871215"/>
+            <a:ext cx="1289304" cy="566928"/>
+          </a:xfrm>
+          <a:prstGeom prst="rect">
+            <a:avLst/>
+          </a:prstGeom>
+          <a:solidFill>
+            <a:srgbClr val="F3F3F3"/>
+          </a:solidFill>
+          <a:ln>
+            <a:noFill/>
+          </a:ln>
+          <a:effectLst/>
+        </p:spPr>
+        <p:style>
+          <a:lnRef idx="1">
+            <a:schemeClr val="accent1"/>
+          </a:lnRef>
+          <a:fillRef idx="3">
+            <a:schemeClr val="accent1"/>
+          </a:fillRef>
+          <a:effectRef idx="2">
+            <a:schemeClr val="accent1"/>
+          </a:effectRef>
+          <a:fontRef idx="minor">
+            <a:schemeClr val="lt1"/>
+          </a:fontRef>
+        </p:style>
+        <p:txBody>
+          <a:bodyPr rtlCol="0" anchor="ctr" wrap="square" lIns="64008" rIns="64008" tIns="64008" bIns="64008"/>
+          <a:lstStyle/>
+          <a:p>
+            <a:pPr algn="l">
+              <a:spcAft>
+                <a:spcPts val="200"/>
+              </a:spcAft>
+            </a:pPr>
+            <a:r>
+              <a:rPr sz="1150" b="1">
+                <a:solidFill>
+                  <a:srgbClr val="1E1E1E"/>
+                </a:solidFill>
+                <a:latin typeface="Microsoft JhengHei"/>
+              </a:rPr>
+              <a:t>Bain</a:t>
+            </a:r>
+          </a:p>
+          <a:p>
+            <a:pPr algn="l">
+              <a:spcAft>
+                <a:spcPts val="200"/>
+              </a:spcAft>
+            </a:pPr>
+            <a:r>
+              <a:rPr sz="900" b="0">
+                <a:solidFill>
+                  <a:srgbClr val="6B6B6B"/>
+                </a:solidFill>
+                <a:latin typeface="Microsoft JhengHei"/>
+              </a:rPr>
+              <a:t>MBB</a:t>
+            </a:r>
+          </a:p>
+        </p:txBody>
+      </p:sp>
+      <p:sp>
+        <p:nvSpPr>
+          <p:cNvPr id="19" name="Rectangle 18"/>
+          <p:cNvSpPr/>
+          <p:nvPr/>
+        </p:nvSpPr>
+        <p:spPr>
+          <a:xfrm>
+            <a:off x="1737360" y="2871215"/>
+            <a:ext cx="4169663" cy="566928"/>
+          </a:xfrm>
+          <a:prstGeom prst="rect">
+            <a:avLst/>
+          </a:prstGeom>
+          <a:solidFill>
+            <a:srgbClr val="F3F3F3"/>
+          </a:solidFill>
+          <a:ln>
+            <a:noFill/>
+          </a:ln>
+          <a:effectLst/>
+        </p:spPr>
+        <p:style>
+          <a:lnRef idx="1">
+            <a:schemeClr val="accent1"/>
+          </a:lnRef>
+          <a:fillRef idx="3">
+            <a:schemeClr val="accent1"/>
+          </a:fillRef>
+          <a:effectRef idx="2">
+            <a:schemeClr val="accent1"/>
+          </a:effectRef>
+          <a:fontRef idx="minor">
+            <a:schemeClr val="lt1"/>
+          </a:fontRef>
+        </p:style>
+        <p:txBody>
+          <a:bodyPr rtlCol="0" anchor="ctr" wrap="square" lIns="64008" rIns="64008" tIns="64008" bIns="64008"/>
+          <a:lstStyle/>
+          <a:p>
+            <a:pPr algn="l">
+              <a:spcAft>
+                <a:spcPts val="200"/>
+              </a:spcAft>
+            </a:pPr>
+            <a:r>
+              <a:rPr sz="1000" b="0">
+                <a:solidFill>
+                  <a:srgbClr val="1E1E1E"/>
+                </a:solidFill>
+                <a:latin typeface="Microsoft JhengHei"/>
+              </a:rPr>
+              <a:t>亞太保險公司以 AI 重塑理賠與客服案例；保險通路 GenAI 年效益逾 500 億美元（2024）</a:t>
+            </a:r>
+          </a:p>
+        </p:txBody>
+      </p:sp>
+      <p:sp>
+        <p:nvSpPr>
+          <p:cNvPr id="20" name="Rectangle 19"/>
+          <p:cNvSpPr/>
+          <p:nvPr/>
+        </p:nvSpPr>
+        <p:spPr>
+          <a:xfrm>
+            <a:off x="5943600" y="2871215"/>
+            <a:ext cx="1837943" cy="566928"/>
+          </a:xfrm>
+          <a:prstGeom prst="rect">
+            <a:avLst/>
+          </a:prstGeom>
+          <a:solidFill>
+            <a:srgbClr val="F3F3F3"/>
+          </a:solidFill>
+          <a:ln>
+            <a:noFill/>
+          </a:ln>
+          <a:effectLst/>
+        </p:spPr>
+        <p:style>
+          <a:lnRef idx="1">
+            <a:schemeClr val="accent1"/>
+          </a:lnRef>
+          <a:fillRef idx="3">
+            <a:schemeClr val="accent1"/>
+          </a:fillRef>
+          <a:effectRef idx="2">
+            <a:schemeClr val="accent1"/>
+          </a:effectRef>
+          <a:fontRef idx="minor">
+            <a:schemeClr val="lt1"/>
+          </a:fontRef>
+        </p:style>
+        <p:txBody>
+          <a:bodyPr rtlCol="0" anchor="ctr" wrap="square" lIns="64008" rIns="64008" tIns="64008" bIns="64008"/>
+          <a:lstStyle/>
+          <a:p>
+            <a:pPr algn="l">
+              <a:spcAft>
+                <a:spcPts val="200"/>
+              </a:spcAft>
+            </a:pPr>
+            <a:r>
+              <a:rPr sz="1000" b="0">
+                <a:solidFill>
+                  <a:srgbClr val="1E1E1E"/>
+                </a:solidFill>
+                <a:latin typeface="Microsoft JhengHei"/>
+              </a:rPr>
+              <a:t>理賠、客服、通路</a:t>
+            </a:r>
+          </a:p>
+        </p:txBody>
+      </p:sp>
+      <p:sp>
+        <p:nvSpPr>
+          <p:cNvPr id="21" name="Rectangle 20"/>
+          <p:cNvSpPr/>
+          <p:nvPr/>
+        </p:nvSpPr>
+        <p:spPr>
+          <a:xfrm>
+            <a:off x="7818120" y="2871215"/>
+            <a:ext cx="2478024" cy="566928"/>
+          </a:xfrm>
+          <a:prstGeom prst="rect">
+            <a:avLst/>
+          </a:prstGeom>
+          <a:solidFill>
+            <a:srgbClr val="F3F3F3"/>
+          </a:solidFill>
+          <a:ln>
+            <a:noFill/>
+          </a:ln>
+          <a:effectLst/>
+        </p:spPr>
+        <p:style>
+          <a:lnRef idx="1">
+            <a:schemeClr val="accent1"/>
+          </a:lnRef>
+          <a:fillRef idx="3">
+            <a:schemeClr val="accent1"/>
+          </a:fillRef>
+          <a:effectRef idx="2">
+            <a:schemeClr val="accent1"/>
+          </a:effectRef>
+          <a:fontRef idx="minor">
+            <a:schemeClr val="lt1"/>
+          </a:fontRef>
+        </p:style>
+        <p:txBody>
+          <a:bodyPr rtlCol="0" anchor="ctr" wrap="square" lIns="64008" rIns="64008" tIns="64008" bIns="64008"/>
+          <a:lstStyle/>
+          <a:p>
+            <a:pPr algn="l">
+              <a:spcAft>
+                <a:spcPts val="200"/>
+              </a:spcAft>
+            </a:pPr>
+            <a:r>
+              <a:rPr sz="1000" b="0">
+                <a:solidFill>
+                  <a:srgbClr val="1E1E1E"/>
+                </a:solidFill>
+                <a:latin typeface="Microsoft JhengHei"/>
+              </a:rPr>
+              <a:t>在台交付規模較小，大型核心導入人力有限</a:t>
+            </a:r>
+          </a:p>
+        </p:txBody>
+      </p:sp>
+      <p:sp>
+        <p:nvSpPr>
+          <p:cNvPr id="22" name="Rectangle 21"/>
+          <p:cNvSpPr/>
+          <p:nvPr/>
+        </p:nvSpPr>
+        <p:spPr>
+          <a:xfrm>
+            <a:off x="10332720" y="2871215"/>
+            <a:ext cx="1426464" cy="566928"/>
+          </a:xfrm>
+          <a:prstGeom prst="rect">
+            <a:avLst/>
+          </a:prstGeom>
+          <a:solidFill>
+            <a:srgbClr val="F3F3F3"/>
+          </a:solidFill>
+          <a:ln>
+            <a:noFill/>
+          </a:ln>
+          <a:effectLst/>
+        </p:spPr>
+        <p:style>
+          <a:lnRef idx="1">
+            <a:schemeClr val="accent1"/>
+          </a:lnRef>
+          <a:fillRef idx="3">
+            <a:schemeClr val="accent1"/>
+          </a:fillRef>
+          <a:effectRef idx="2">
+            <a:schemeClr val="accent1"/>
+          </a:effectRef>
+          <a:fontRef idx="minor">
+            <a:schemeClr val="lt1"/>
+          </a:fontRef>
+        </p:style>
+        <p:txBody>
+          <a:bodyPr rtlCol="0" anchor="ctr" wrap="square" lIns="64008" rIns="64008" tIns="64008" bIns="64008"/>
+          <a:lstStyle/>
+          <a:p>
+            <a:pPr algn="l">
+              <a:spcAft>
+                <a:spcPts val="200"/>
+              </a:spcAft>
+            </a:pPr>
+            <a:r>
+              <a:rPr sz="950" b="0" u="sng">
+                <a:solidFill>
+                  <a:srgbClr val="1F5FBF"/>
+                </a:solidFill>
+                <a:latin typeface="Microsoft JhengHei"/>
+                <a:hlinkClick r:id="rId6"/>
+              </a:rPr>
+              <a:t>案例</a:t>
+            </a:r>
+          </a:p>
+          <a:p>
+            <a:pPr algn="l">
+              <a:spcAft>
+                <a:spcPts val="200"/>
+              </a:spcAft>
+            </a:pPr>
+            <a:r>
+              <a:rPr sz="950" b="0" u="sng">
+                <a:solidFill>
+                  <a:srgbClr val="1F5FBF"/>
+                </a:solidFill>
+                <a:latin typeface="Microsoft JhengHei"/>
+                <a:hlinkClick r:id="rId7"/>
+              </a:rPr>
+              <a:t>通路研究</a:t>
+            </a:r>
+          </a:p>
+        </p:txBody>
+      </p:sp>
+      <p:cxnSp>
+        <p:nvCxnSpPr>
+          <p:cNvPr id="23" name="Connector 22"/>
+          <p:cNvCxnSpPr/>
+          <p:nvPr/>
+        </p:nvCxnSpPr>
+        <p:spPr>
+          <a:xfrm>
+            <a:off x="411480" y="3456432"/>
+            <a:ext cx="11384280" cy="0"/>
+          </a:xfrm>
+          <a:prstGeom prst="line">
+            <a:avLst/>
+          </a:prstGeom>
+          <a:ln w="19050">
+            <a:solidFill>
+              <a:srgbClr val="FD5108"/>
+            </a:solidFill>
+          </a:ln>
+        </p:spPr>
+        <p:style>
+          <a:lnRef idx="2">
+            <a:schemeClr val="accent1"/>
+          </a:lnRef>
+          <a:fillRef idx="0">
+            <a:schemeClr val="accent1"/>
+          </a:fillRef>
+          <a:effectRef idx="1">
+            <a:schemeClr val="accent1"/>
+          </a:effectRef>
+          <a:fontRef idx="minor">
+            <a:schemeClr val="tx1"/>
+          </a:fontRef>
+        </p:style>
+      </p:cxnSp>
+      <p:sp>
+        <p:nvSpPr>
+          <p:cNvPr id="24" name="Rectangle 23"/>
+          <p:cNvSpPr/>
+          <p:nvPr/>
+        </p:nvSpPr>
+        <p:spPr>
+          <a:xfrm>
+            <a:off x="411480" y="3474720"/>
+            <a:ext cx="1289304" cy="566928"/>
+          </a:xfrm>
+          <a:prstGeom prst="rect">
+            <a:avLst/>
+          </a:prstGeom>
+          <a:solidFill>
+            <a:srgbClr val="FFFFFF"/>
+          </a:solidFill>
+          <a:ln>
+            <a:noFill/>
+          </a:ln>
+          <a:effectLst/>
+        </p:spPr>
+        <p:style>
+          <a:lnRef idx="1">
+            <a:schemeClr val="accent1"/>
+          </a:lnRef>
+          <a:fillRef idx="3">
+            <a:schemeClr val="accent1"/>
+          </a:fillRef>
+          <a:effectRef idx="2">
+            <a:schemeClr val="accent1"/>
+          </a:effectRef>
+          <a:fontRef idx="minor">
+            <a:schemeClr val="lt1"/>
+          </a:fontRef>
+        </p:style>
+        <p:txBody>
+          <a:bodyPr rtlCol="0" anchor="ctr" wrap="square" lIns="64008" rIns="64008" tIns="64008" bIns="64008"/>
+          <a:lstStyle/>
+          <a:p>
+            <a:pPr algn="l">
+              <a:spcAft>
+                <a:spcPts val="200"/>
+              </a:spcAft>
+            </a:pPr>
+            <a:r>
+              <a:rPr sz="1150" b="1">
+                <a:solidFill>
+                  <a:srgbClr val="1E1E1E"/>
+                </a:solidFill>
+                <a:latin typeface="Microsoft JhengHei"/>
+              </a:rPr>
+              <a:t>Deloitte</a:t>
+            </a:r>
+          </a:p>
+          <a:p>
+            <a:pPr algn="l">
+              <a:spcAft>
+                <a:spcPts val="200"/>
+              </a:spcAft>
+            </a:pPr>
+            <a:r>
+              <a:rPr sz="900" b="0">
+                <a:solidFill>
+                  <a:srgbClr val="6B6B6B"/>
+                </a:solidFill>
+                <a:latin typeface="Microsoft JhengHei"/>
+              </a:rPr>
+              <a:t>四大</a:t>
+            </a:r>
+          </a:p>
+        </p:txBody>
+      </p:sp>
+      <p:sp>
+        <p:nvSpPr>
+          <p:cNvPr id="25" name="Rectangle 24"/>
+          <p:cNvSpPr/>
+          <p:nvPr/>
+        </p:nvSpPr>
+        <p:spPr>
+          <a:xfrm>
+            <a:off x="1737360" y="3474720"/>
+            <a:ext cx="4169663" cy="566928"/>
+          </a:xfrm>
+          <a:prstGeom prst="rect">
+            <a:avLst/>
+          </a:prstGeom>
+          <a:solidFill>
+            <a:srgbClr val="FFFFFF"/>
+          </a:solidFill>
+          <a:ln>
+            <a:noFill/>
+          </a:ln>
+          <a:effectLst/>
+        </p:spPr>
+        <p:style>
+          <a:lnRef idx="1">
+            <a:schemeClr val="accent1"/>
+          </a:lnRef>
+          <a:fillRef idx="3">
+            <a:schemeClr val="accent1"/>
+          </a:fillRef>
+          <a:effectRef idx="2">
+            <a:schemeClr val="accent1"/>
+          </a:effectRef>
+          <a:fontRef idx="minor">
+            <a:schemeClr val="lt1"/>
+          </a:fontRef>
+        </p:style>
+        <p:txBody>
+          <a:bodyPr rtlCol="0" anchor="ctr" wrap="square" lIns="64008" rIns="64008" tIns="64008" bIns="64008"/>
+          <a:lstStyle/>
+          <a:p>
+            <a:pPr algn="l">
+              <a:spcAft>
+                <a:spcPts val="200"/>
+              </a:spcAft>
+            </a:pPr>
+            <a:r>
+              <a:rPr sz="1000" b="0">
+                <a:solidFill>
+                  <a:srgbClr val="1E1E1E"/>
+                </a:solidFill>
+                <a:latin typeface="Microsoft JhengHei"/>
+              </a:rPr>
+              <a:t>Agentic AI Blueprint for Insurance：產險／壽險分類，評估→設計→試點→規模化，預建＋客製代理</a:t>
+            </a:r>
+          </a:p>
+        </p:txBody>
+      </p:sp>
+      <p:sp>
+        <p:nvSpPr>
+          <p:cNvPr id="26" name="Rectangle 25"/>
+          <p:cNvSpPr/>
+          <p:nvPr/>
+        </p:nvSpPr>
+        <p:spPr>
+          <a:xfrm>
+            <a:off x="5943600" y="3474720"/>
+            <a:ext cx="1837943" cy="566928"/>
+          </a:xfrm>
+          <a:prstGeom prst="rect">
+            <a:avLst/>
+          </a:prstGeom>
+          <a:solidFill>
+            <a:srgbClr val="FFFFFF"/>
+          </a:solidFill>
+          <a:ln>
+            <a:noFill/>
+          </a:ln>
+          <a:effectLst/>
+        </p:spPr>
+        <p:style>
+          <a:lnRef idx="1">
+            <a:schemeClr val="accent1"/>
+          </a:lnRef>
+          <a:fillRef idx="3">
+            <a:schemeClr val="accent1"/>
+          </a:fillRef>
+          <a:effectRef idx="2">
+            <a:schemeClr val="accent1"/>
+          </a:effectRef>
+          <a:fontRef idx="minor">
+            <a:schemeClr val="lt1"/>
+          </a:fontRef>
+        </p:style>
+        <p:txBody>
+          <a:bodyPr rtlCol="0" anchor="ctr" wrap="square" lIns="64008" rIns="64008" tIns="64008" bIns="64008"/>
+          <a:lstStyle/>
+          <a:p>
+            <a:pPr algn="l">
+              <a:spcAft>
+                <a:spcPts val="200"/>
+              </a:spcAft>
+            </a:pPr>
+            <a:r>
+              <a:rPr sz="1000" b="0">
+                <a:solidFill>
+                  <a:srgbClr val="1E1E1E"/>
+                </a:solidFill>
+                <a:latin typeface="Microsoft JhengHei"/>
+              </a:rPr>
+              <a:t>全價值鏈代理型 AI 轉型</a:t>
+            </a:r>
+          </a:p>
+        </p:txBody>
+      </p:sp>
+      <p:sp>
+        <p:nvSpPr>
+          <p:cNvPr id="27" name="Rectangle 26"/>
+          <p:cNvSpPr/>
+          <p:nvPr/>
+        </p:nvSpPr>
+        <p:spPr>
+          <a:xfrm>
+            <a:off x="7818120" y="3474720"/>
+            <a:ext cx="2478024" cy="566928"/>
+          </a:xfrm>
+          <a:prstGeom prst="rect">
+            <a:avLst/>
+          </a:prstGeom>
+          <a:solidFill>
+            <a:srgbClr val="FFFFFF"/>
+          </a:solidFill>
+          <a:ln>
+            <a:noFill/>
+          </a:ln>
+          <a:effectLst/>
+        </p:spPr>
+        <p:style>
+          <a:lnRef idx="1">
+            <a:schemeClr val="accent1"/>
+          </a:lnRef>
+          <a:fillRef idx="3">
+            <a:schemeClr val="accent1"/>
+          </a:fillRef>
+          <a:effectRef idx="2">
+            <a:schemeClr val="accent1"/>
+          </a:effectRef>
+          <a:fontRef idx="minor">
+            <a:schemeClr val="lt1"/>
+          </a:fontRef>
+        </p:style>
+        <p:txBody>
+          <a:bodyPr rtlCol="0" anchor="ctr" wrap="square" lIns="64008" rIns="64008" tIns="64008" bIns="64008"/>
+          <a:lstStyle/>
+          <a:p>
+            <a:pPr algn="l">
+              <a:spcAft>
+                <a:spcPts val="200"/>
+              </a:spcAft>
+            </a:pPr>
+            <a:r>
+              <a:rPr sz="1000" b="0">
+                <a:solidFill>
+                  <a:srgbClr val="1E1E1E"/>
+                </a:solidFill>
+                <a:latin typeface="Microsoft JhengHei"/>
+              </a:rPr>
+              <a:t>預建代理套到台灣客製化舊核心與繁中條款需調適</a:t>
+            </a:r>
+          </a:p>
+        </p:txBody>
+      </p:sp>
+      <p:sp>
+        <p:nvSpPr>
+          <p:cNvPr id="28" name="Rectangle 27"/>
+          <p:cNvSpPr/>
+          <p:nvPr/>
+        </p:nvSpPr>
+        <p:spPr>
+          <a:xfrm>
+            <a:off x="10332720" y="3474720"/>
+            <a:ext cx="1426464" cy="566928"/>
+          </a:xfrm>
+          <a:prstGeom prst="rect">
+            <a:avLst/>
+          </a:prstGeom>
+          <a:solidFill>
+            <a:srgbClr val="FFFFFF"/>
+          </a:solidFill>
+          <a:ln>
+            <a:noFill/>
+          </a:ln>
+          <a:effectLst/>
+        </p:spPr>
+        <p:style>
+          <a:lnRef idx="1">
+            <a:schemeClr val="accent1"/>
+          </a:lnRef>
+          <a:fillRef idx="3">
+            <a:schemeClr val="accent1"/>
+          </a:fillRef>
+          <a:effectRef idx="2">
+            <a:schemeClr val="accent1"/>
+          </a:effectRef>
+          <a:fontRef idx="minor">
+            <a:schemeClr val="lt1"/>
+          </a:fontRef>
+        </p:style>
+        <p:txBody>
+          <a:bodyPr rtlCol="0" anchor="ctr" wrap="square" lIns="64008" rIns="64008" tIns="64008" bIns="64008"/>
+          <a:lstStyle/>
+          <a:p>
+            <a:pPr algn="l">
+              <a:spcAft>
+                <a:spcPts val="200"/>
+              </a:spcAft>
+            </a:pPr>
+            <a:r>
+              <a:rPr sz="950" b="0" u="sng">
+                <a:solidFill>
+                  <a:srgbClr val="1F5FBF"/>
+                </a:solidFill>
+                <a:latin typeface="Microsoft JhengHei"/>
+                <a:hlinkClick r:id="rId8"/>
+              </a:rPr>
+              <a:t>Blueprint</a:t>
+            </a:r>
+          </a:p>
+          <a:p>
+            <a:pPr algn="l">
+              <a:spcAft>
+                <a:spcPts val="200"/>
+              </a:spcAft>
+            </a:pPr>
+            <a:r>
+              <a:rPr sz="950" b="0" u="sng">
+                <a:solidFill>
+                  <a:srgbClr val="1F5FBF"/>
+                </a:solidFill>
+                <a:latin typeface="Microsoft JhengHei"/>
+                <a:hlinkClick r:id="rId9"/>
+              </a:rPr>
+              <a:t>亞太壽險</a:t>
+            </a:r>
+          </a:p>
+        </p:txBody>
+      </p:sp>
+      <p:sp>
+        <p:nvSpPr>
+          <p:cNvPr id="29" name="Rectangle 28"/>
+          <p:cNvSpPr/>
+          <p:nvPr/>
+        </p:nvSpPr>
+        <p:spPr>
+          <a:xfrm>
+            <a:off x="411480" y="4078224"/>
+            <a:ext cx="1289304" cy="566928"/>
+          </a:xfrm>
+          <a:prstGeom prst="rect">
+            <a:avLst/>
+          </a:prstGeom>
+          <a:solidFill>
+            <a:srgbClr val="F3F3F3"/>
+          </a:solidFill>
+          <a:ln>
+            <a:noFill/>
+          </a:ln>
+          <a:effectLst/>
+        </p:spPr>
+        <p:style>
+          <a:lnRef idx="1">
+            <a:schemeClr val="accent1"/>
+          </a:lnRef>
+          <a:fillRef idx="3">
+            <a:schemeClr val="accent1"/>
+          </a:fillRef>
+          <a:effectRef idx="2">
+            <a:schemeClr val="accent1"/>
+          </a:effectRef>
+          <a:fontRef idx="minor">
+            <a:schemeClr val="lt1"/>
+          </a:fontRef>
+        </p:style>
+        <p:txBody>
+          <a:bodyPr rtlCol="0" anchor="ctr" wrap="square" lIns="64008" rIns="64008" tIns="64008" bIns="64008"/>
+          <a:lstStyle/>
+          <a:p>
+            <a:pPr algn="l">
+              <a:spcAft>
+                <a:spcPts val="200"/>
+              </a:spcAft>
+            </a:pPr>
+            <a:r>
+              <a:rPr sz="1150" b="1">
+                <a:solidFill>
+                  <a:srgbClr val="1E1E1E"/>
+                </a:solidFill>
+                <a:latin typeface="Microsoft JhengHei"/>
+              </a:rPr>
+              <a:t>EY</a:t>
+            </a:r>
+          </a:p>
+          <a:p>
+            <a:pPr algn="l">
+              <a:spcAft>
+                <a:spcPts val="200"/>
+              </a:spcAft>
+            </a:pPr>
+            <a:r>
+              <a:rPr sz="900" b="0">
+                <a:solidFill>
+                  <a:srgbClr val="6B6B6B"/>
+                </a:solidFill>
+                <a:latin typeface="Microsoft JhengHei"/>
+              </a:rPr>
+              <a:t>四大</a:t>
+            </a:r>
+          </a:p>
+        </p:txBody>
+      </p:sp>
+      <p:sp>
+        <p:nvSpPr>
+          <p:cNvPr id="30" name="Rectangle 29"/>
+          <p:cNvSpPr/>
+          <p:nvPr/>
+        </p:nvSpPr>
+        <p:spPr>
+          <a:xfrm>
+            <a:off x="1737360" y="4078224"/>
+            <a:ext cx="4169663" cy="566928"/>
+          </a:xfrm>
+          <a:prstGeom prst="rect">
+            <a:avLst/>
+          </a:prstGeom>
+          <a:solidFill>
+            <a:srgbClr val="F3F3F3"/>
+          </a:solidFill>
+          <a:ln>
+            <a:noFill/>
+          </a:ln>
+          <a:effectLst/>
+        </p:spPr>
+        <p:style>
+          <a:lnRef idx="1">
+            <a:schemeClr val="accent1"/>
+          </a:lnRef>
+          <a:fillRef idx="3">
+            <a:schemeClr val="accent1"/>
+          </a:fillRef>
+          <a:effectRef idx="2">
+            <a:schemeClr val="accent1"/>
+          </a:effectRef>
+          <a:fontRef idx="minor">
+            <a:schemeClr val="lt1"/>
+          </a:fontRef>
+        </p:style>
+        <p:txBody>
+          <a:bodyPr rtlCol="0" anchor="ctr" wrap="square" lIns="64008" rIns="64008" tIns="64008" bIns="64008"/>
+          <a:lstStyle/>
+          <a:p>
+            <a:pPr algn="l">
+              <a:spcAft>
+                <a:spcPts val="200"/>
+              </a:spcAft>
+            </a:pPr>
+            <a:r>
+              <a:rPr sz="1000" b="0">
+                <a:solidFill>
+                  <a:srgbClr val="1E1E1E"/>
+                </a:solidFill>
+                <a:latin typeface="Microsoft JhengHei"/>
+              </a:rPr>
+              <a:t>EY Nexus for Insurance：雲原生平台，快速推出新商品與品牌，串接 650+ 保險科技</a:t>
+            </a:r>
+          </a:p>
+        </p:txBody>
+      </p:sp>
+      <p:sp>
+        <p:nvSpPr>
+          <p:cNvPr id="31" name="Rectangle 30"/>
+          <p:cNvSpPr/>
+          <p:nvPr/>
+        </p:nvSpPr>
+        <p:spPr>
+          <a:xfrm>
+            <a:off x="5943600" y="4078224"/>
+            <a:ext cx="1837943" cy="566928"/>
+          </a:xfrm>
+          <a:prstGeom prst="rect">
+            <a:avLst/>
+          </a:prstGeom>
+          <a:solidFill>
+            <a:srgbClr val="F3F3F3"/>
+          </a:solidFill>
+          <a:ln>
+            <a:noFill/>
+          </a:ln>
+          <a:effectLst/>
+        </p:spPr>
+        <p:style>
+          <a:lnRef idx="1">
+            <a:schemeClr val="accent1"/>
+          </a:lnRef>
+          <a:fillRef idx="3">
+            <a:schemeClr val="accent1"/>
+          </a:fillRef>
+          <a:effectRef idx="2">
+            <a:schemeClr val="accent1"/>
+          </a:effectRef>
+          <a:fontRef idx="minor">
+            <a:schemeClr val="lt1"/>
+          </a:fontRef>
+        </p:style>
+        <p:txBody>
+          <a:bodyPr rtlCol="0" anchor="ctr" wrap="square" lIns="64008" rIns="64008" tIns="64008" bIns="64008"/>
+          <a:lstStyle/>
+          <a:p>
+            <a:pPr algn="l">
+              <a:spcAft>
+                <a:spcPts val="200"/>
+              </a:spcAft>
+            </a:pPr>
+            <a:r>
+              <a:rPr sz="1000" b="0">
+                <a:solidFill>
+                  <a:srgbClr val="1E1E1E"/>
+                </a:solidFill>
+                <a:latin typeface="Microsoft JhengHei"/>
+              </a:rPr>
+              <a:t>新商品、嵌入式通路、核心延伸</a:t>
+            </a:r>
+          </a:p>
+        </p:txBody>
+      </p:sp>
+      <p:sp>
+        <p:nvSpPr>
+          <p:cNvPr id="32" name="Rectangle 31"/>
+          <p:cNvSpPr/>
+          <p:nvPr/>
+        </p:nvSpPr>
+        <p:spPr>
+          <a:xfrm>
+            <a:off x="7818120" y="4078224"/>
+            <a:ext cx="2478024" cy="566928"/>
+          </a:xfrm>
+          <a:prstGeom prst="rect">
+            <a:avLst/>
+          </a:prstGeom>
+          <a:solidFill>
+            <a:srgbClr val="F3F3F3"/>
+          </a:solidFill>
+          <a:ln>
+            <a:noFill/>
+          </a:ln>
+          <a:effectLst/>
+        </p:spPr>
+        <p:style>
+          <a:lnRef idx="1">
+            <a:schemeClr val="accent1"/>
+          </a:lnRef>
+          <a:fillRef idx="3">
+            <a:schemeClr val="accent1"/>
+          </a:fillRef>
+          <a:effectRef idx="2">
+            <a:schemeClr val="accent1"/>
+          </a:effectRef>
+          <a:fontRef idx="minor">
+            <a:schemeClr val="lt1"/>
+          </a:fontRef>
+        </p:style>
+        <p:txBody>
+          <a:bodyPr rtlCol="0" anchor="ctr" wrap="square" lIns="64008" rIns="64008" tIns="64008" bIns="64008"/>
+          <a:lstStyle/>
+          <a:p>
+            <a:pPr algn="l">
+              <a:spcAft>
+                <a:spcPts val="200"/>
+              </a:spcAft>
+            </a:pPr>
+            <a:r>
+              <a:rPr sz="1000" b="0">
+                <a:solidFill>
+                  <a:srgbClr val="1E1E1E"/>
+                </a:solidFill>
+                <a:latin typeface="Microsoft JhengHei"/>
+              </a:rPr>
+              <a:t>偏新業務上線，舊核心遷移與 IFRS 17 整合難只靠平台</a:t>
+            </a:r>
+          </a:p>
+        </p:txBody>
+      </p:sp>
+      <p:sp>
+        <p:nvSpPr>
+          <p:cNvPr id="33" name="Rectangle 32"/>
+          <p:cNvSpPr/>
+          <p:nvPr/>
+        </p:nvSpPr>
+        <p:spPr>
+          <a:xfrm>
+            <a:off x="10332720" y="4078224"/>
+            <a:ext cx="1426464" cy="566928"/>
+          </a:xfrm>
+          <a:prstGeom prst="rect">
+            <a:avLst/>
+          </a:prstGeom>
+          <a:solidFill>
+            <a:srgbClr val="F3F3F3"/>
+          </a:solidFill>
+          <a:ln>
+            <a:noFill/>
+          </a:ln>
+          <a:effectLst/>
+        </p:spPr>
+        <p:style>
+          <a:lnRef idx="1">
+            <a:schemeClr val="accent1"/>
+          </a:lnRef>
+          <a:fillRef idx="3">
+            <a:schemeClr val="accent1"/>
+          </a:fillRef>
+          <a:effectRef idx="2">
+            <a:schemeClr val="accent1"/>
+          </a:effectRef>
+          <a:fontRef idx="minor">
+            <a:schemeClr val="lt1"/>
+          </a:fontRef>
+        </p:style>
+        <p:txBody>
+          <a:bodyPr rtlCol="0" anchor="ctr" wrap="square" lIns="64008" rIns="64008" tIns="64008" bIns="64008"/>
+          <a:lstStyle/>
+          <a:p>
+            <a:pPr algn="l">
+              <a:spcAft>
+                <a:spcPts val="200"/>
+              </a:spcAft>
+            </a:pPr>
+            <a:r>
+              <a:rPr sz="950" b="0" u="sng">
+                <a:solidFill>
+                  <a:srgbClr val="1F5FBF"/>
+                </a:solidFill>
+                <a:latin typeface="Microsoft JhengHei"/>
+                <a:hlinkClick r:id="rId10"/>
+              </a:rPr>
+              <a:t>Nexus</a:t>
+            </a:r>
+          </a:p>
+        </p:txBody>
+      </p:sp>
+      <p:sp>
+        <p:nvSpPr>
+          <p:cNvPr id="34" name="Rectangle 33"/>
+          <p:cNvSpPr/>
+          <p:nvPr/>
+        </p:nvSpPr>
+        <p:spPr>
+          <a:xfrm>
+            <a:off x="411480" y="4681728"/>
+            <a:ext cx="1289304" cy="566928"/>
+          </a:xfrm>
+          <a:prstGeom prst="rect">
+            <a:avLst/>
+          </a:prstGeom>
+          <a:solidFill>
+            <a:srgbClr val="FFFFFF"/>
+          </a:solidFill>
+          <a:ln>
+            <a:noFill/>
+          </a:ln>
+          <a:effectLst/>
+        </p:spPr>
+        <p:style>
+          <a:lnRef idx="1">
+            <a:schemeClr val="accent1"/>
+          </a:lnRef>
+          <a:fillRef idx="3">
+            <a:schemeClr val="accent1"/>
+          </a:fillRef>
+          <a:effectRef idx="2">
+            <a:schemeClr val="accent1"/>
+          </a:effectRef>
+          <a:fontRef idx="minor">
+            <a:schemeClr val="lt1"/>
+          </a:fontRef>
+        </p:style>
+        <p:txBody>
+          <a:bodyPr rtlCol="0" anchor="ctr" wrap="square" lIns="64008" rIns="64008" tIns="64008" bIns="64008"/>
+          <a:lstStyle/>
+          <a:p>
+            <a:pPr algn="l">
+              <a:spcAft>
+                <a:spcPts val="200"/>
+              </a:spcAft>
+            </a:pPr>
+            <a:r>
+              <a:rPr sz="1150" b="1">
+                <a:solidFill>
+                  <a:srgbClr val="1E1E1E"/>
+                </a:solidFill>
+                <a:latin typeface="Microsoft JhengHei"/>
+              </a:rPr>
+              <a:t>KPMG</a:t>
+            </a:r>
+          </a:p>
+          <a:p>
+            <a:pPr algn="l">
+              <a:spcAft>
+                <a:spcPts val="200"/>
+              </a:spcAft>
+            </a:pPr>
+            <a:r>
+              <a:rPr sz="900" b="0">
+                <a:solidFill>
+                  <a:srgbClr val="6B6B6B"/>
+                </a:solidFill>
+                <a:latin typeface="Microsoft JhengHei"/>
+              </a:rPr>
+              <a:t>四大</a:t>
+            </a:r>
+          </a:p>
+        </p:txBody>
+      </p:sp>
+      <p:sp>
+        <p:nvSpPr>
+          <p:cNvPr id="35" name="Rectangle 34"/>
+          <p:cNvSpPr/>
+          <p:nvPr/>
+        </p:nvSpPr>
+        <p:spPr>
+          <a:xfrm>
+            <a:off x="1737360" y="4681728"/>
+            <a:ext cx="4169663" cy="566928"/>
+          </a:xfrm>
+          <a:prstGeom prst="rect">
+            <a:avLst/>
+          </a:prstGeom>
+          <a:solidFill>
+            <a:srgbClr val="FFFFFF"/>
+          </a:solidFill>
+          <a:ln>
+            <a:noFill/>
+          </a:ln>
+          <a:effectLst/>
+        </p:spPr>
+        <p:style>
+          <a:lnRef idx="1">
+            <a:schemeClr val="accent1"/>
+          </a:lnRef>
+          <a:fillRef idx="3">
+            <a:schemeClr val="accent1"/>
+          </a:fillRef>
+          <a:effectRef idx="2">
+            <a:schemeClr val="accent1"/>
+          </a:effectRef>
+          <a:fontRef idx="minor">
+            <a:schemeClr val="lt1"/>
+          </a:fontRef>
+        </p:style>
+        <p:txBody>
+          <a:bodyPr rtlCol="0" anchor="ctr" wrap="square" lIns="64008" rIns="64008" tIns="64008" bIns="64008"/>
+          <a:lstStyle/>
+          <a:p>
+            <a:pPr algn="l">
+              <a:spcAft>
+                <a:spcPts val="200"/>
+              </a:spcAft>
+            </a:pPr>
+            <a:r>
+              <a:rPr sz="1000" b="0">
+                <a:solidFill>
+                  <a:srgbClr val="1E1E1E"/>
+                </a:solidFill>
+                <a:latin typeface="Microsoft JhengHei"/>
+              </a:rPr>
+              <a:t>Intelligent Insurance：AI 價值三階段導入；Trusted AI 十大支柱治理框架</a:t>
+            </a:r>
+          </a:p>
+        </p:txBody>
+      </p:sp>
+      <p:sp>
+        <p:nvSpPr>
+          <p:cNvPr id="36" name="Rectangle 35"/>
+          <p:cNvSpPr/>
+          <p:nvPr/>
+        </p:nvSpPr>
+        <p:spPr>
+          <a:xfrm>
+            <a:off x="5943600" y="4681728"/>
+            <a:ext cx="1837943" cy="566928"/>
+          </a:xfrm>
+          <a:prstGeom prst="rect">
+            <a:avLst/>
+          </a:prstGeom>
+          <a:solidFill>
+            <a:srgbClr val="FFFFFF"/>
+          </a:solidFill>
+          <a:ln>
+            <a:noFill/>
+          </a:ln>
+          <a:effectLst/>
+        </p:spPr>
+        <p:style>
+          <a:lnRef idx="1">
+            <a:schemeClr val="accent1"/>
+          </a:lnRef>
+          <a:fillRef idx="3">
+            <a:schemeClr val="accent1"/>
+          </a:fillRef>
+          <a:effectRef idx="2">
+            <a:schemeClr val="accent1"/>
+          </a:effectRef>
+          <a:fontRef idx="minor">
+            <a:schemeClr val="lt1"/>
+          </a:fontRef>
+        </p:style>
+        <p:txBody>
+          <a:bodyPr rtlCol="0" anchor="ctr" wrap="square" lIns="64008" rIns="64008" tIns="64008" bIns="64008"/>
+          <a:lstStyle/>
+          <a:p>
+            <a:pPr algn="l">
+              <a:spcAft>
+                <a:spcPts val="200"/>
+              </a:spcAft>
+            </a:pPr>
+            <a:r>
+              <a:rPr sz="1000" b="0">
+                <a:solidFill>
+                  <a:srgbClr val="1E1E1E"/>
+                </a:solidFill>
+                <a:latin typeface="Microsoft JhengHei"/>
+              </a:rPr>
+              <a:t>AI 導入路徑與治理</a:t>
+            </a:r>
+          </a:p>
+        </p:txBody>
+      </p:sp>
+      <p:sp>
+        <p:nvSpPr>
+          <p:cNvPr id="37" name="Rectangle 36"/>
+          <p:cNvSpPr/>
+          <p:nvPr/>
+        </p:nvSpPr>
+        <p:spPr>
+          <a:xfrm>
+            <a:off x="7818120" y="4681728"/>
+            <a:ext cx="2478024" cy="566928"/>
+          </a:xfrm>
+          <a:prstGeom prst="rect">
+            <a:avLst/>
+          </a:prstGeom>
+          <a:solidFill>
+            <a:srgbClr val="FFFFFF"/>
+          </a:solidFill>
+          <a:ln>
+            <a:noFill/>
+          </a:ln>
+          <a:effectLst/>
+        </p:spPr>
+        <p:style>
+          <a:lnRef idx="1">
+            <a:schemeClr val="accent1"/>
+          </a:lnRef>
+          <a:fillRef idx="3">
+            <a:schemeClr val="accent1"/>
+          </a:fillRef>
+          <a:effectRef idx="2">
+            <a:schemeClr val="accent1"/>
+          </a:effectRef>
+          <a:fontRef idx="minor">
+            <a:schemeClr val="lt1"/>
+          </a:fontRef>
+        </p:style>
+        <p:txBody>
+          <a:bodyPr rtlCol="0" anchor="ctr" wrap="square" lIns="64008" rIns="64008" tIns="64008" bIns="64008"/>
+          <a:lstStyle/>
+          <a:p>
+            <a:pPr algn="l">
+              <a:spcAft>
+                <a:spcPts val="200"/>
+              </a:spcAft>
+            </a:pPr>
+            <a:r>
+              <a:rPr sz="1000" b="0">
+                <a:solidFill>
+                  <a:srgbClr val="1E1E1E"/>
+                </a:solidFill>
+                <a:latin typeface="Microsoft JhengHei"/>
+              </a:rPr>
+              <a:t>公開資料未見保險專屬代理型產品</a:t>
+            </a:r>
+          </a:p>
+        </p:txBody>
+      </p:sp>
+      <p:sp>
+        <p:nvSpPr>
+          <p:cNvPr id="38" name="Rectangle 37"/>
+          <p:cNvSpPr/>
+          <p:nvPr/>
+        </p:nvSpPr>
+        <p:spPr>
+          <a:xfrm>
+            <a:off x="10332720" y="4681728"/>
+            <a:ext cx="1426464" cy="566928"/>
+          </a:xfrm>
+          <a:prstGeom prst="rect">
+            <a:avLst/>
+          </a:prstGeom>
+          <a:solidFill>
+            <a:srgbClr val="FFFFFF"/>
+          </a:solidFill>
+          <a:ln>
+            <a:noFill/>
+          </a:ln>
+          <a:effectLst/>
+        </p:spPr>
+        <p:style>
+          <a:lnRef idx="1">
+            <a:schemeClr val="accent1"/>
+          </a:lnRef>
+          <a:fillRef idx="3">
+            <a:schemeClr val="accent1"/>
+          </a:fillRef>
+          <a:effectRef idx="2">
+            <a:schemeClr val="accent1"/>
+          </a:effectRef>
+          <a:fontRef idx="minor">
+            <a:schemeClr val="lt1"/>
+          </a:fontRef>
+        </p:style>
+        <p:txBody>
+          <a:bodyPr rtlCol="0" anchor="ctr" wrap="square" lIns="64008" rIns="64008" tIns="64008" bIns="64008"/>
+          <a:lstStyle/>
+          <a:p>
+            <a:pPr algn="l">
+              <a:spcAft>
+                <a:spcPts val="200"/>
+              </a:spcAft>
+            </a:pPr>
+            <a:r>
+              <a:rPr sz="950" b="0" u="sng">
+                <a:solidFill>
+                  <a:srgbClr val="1F5FBF"/>
+                </a:solidFill>
+                <a:latin typeface="Microsoft JhengHei"/>
+                <a:hlinkClick r:id="rId11"/>
+              </a:rPr>
+              <a:t>Intelligent Insurance</a:t>
+            </a:r>
+          </a:p>
+          <a:p>
+            <a:pPr algn="l">
+              <a:spcAft>
+                <a:spcPts val="200"/>
+              </a:spcAft>
+            </a:pPr>
+            <a:r>
+              <a:rPr sz="950" b="0" u="sng">
+                <a:solidFill>
+                  <a:srgbClr val="1F5FBF"/>
+                </a:solidFill>
+                <a:latin typeface="Microsoft JhengHei"/>
+                <a:hlinkClick r:id="rId12"/>
+              </a:rPr>
+              <a:t>Trusted AI</a:t>
+            </a:r>
+          </a:p>
+        </p:txBody>
+      </p:sp>
+      <p:sp>
+        <p:nvSpPr>
+          <p:cNvPr id="39" name="Rectangle 38"/>
+          <p:cNvSpPr/>
+          <p:nvPr/>
+        </p:nvSpPr>
+        <p:spPr>
+          <a:xfrm>
+            <a:off x="411480" y="5285231"/>
+            <a:ext cx="1289304" cy="566928"/>
+          </a:xfrm>
+          <a:prstGeom prst="rect">
+            <a:avLst/>
+          </a:prstGeom>
+          <a:solidFill>
+            <a:srgbClr val="FFE8D4"/>
+          </a:solidFill>
+          <a:ln>
+            <a:noFill/>
+          </a:ln>
+          <a:effectLst/>
+        </p:spPr>
+        <p:style>
+          <a:lnRef idx="1">
+            <a:schemeClr val="accent1"/>
+          </a:lnRef>
+          <a:fillRef idx="3">
+            <a:schemeClr val="accent1"/>
+          </a:fillRef>
+          <a:effectRef idx="2">
+            <a:schemeClr val="accent1"/>
+          </a:effectRef>
+          <a:fontRef idx="minor">
+            <a:schemeClr val="lt1"/>
+          </a:fontRef>
+        </p:style>
+        <p:txBody>
+          <a:bodyPr rtlCol="0" anchor="ctr" wrap="square" lIns="64008" rIns="64008" tIns="64008" bIns="64008"/>
+          <a:lstStyle/>
+          <a:p>
+            <a:pPr algn="l">
+              <a:spcAft>
+                <a:spcPts val="200"/>
+              </a:spcAft>
+            </a:pPr>
+            <a:r>
+              <a:rPr sz="1150" b="1">
+                <a:solidFill>
+                  <a:srgbClr val="FD5108"/>
+                </a:solidFill>
+                <a:latin typeface="Microsoft JhengHei"/>
+              </a:rPr>
+              <a:t>PwC（所內）</a:t>
+            </a:r>
+          </a:p>
+          <a:p>
+            <a:pPr algn="l">
+              <a:spcAft>
+                <a:spcPts val="200"/>
+              </a:spcAft>
+            </a:pPr>
+            <a:r>
+              <a:rPr sz="900" b="0">
+                <a:solidFill>
+                  <a:srgbClr val="6B6B6B"/>
+                </a:solidFill>
+                <a:latin typeface="Microsoft JhengHei"/>
+              </a:rPr>
+              <a:t>四大</a:t>
+            </a:r>
+          </a:p>
+        </p:txBody>
+      </p:sp>
+      <p:sp>
+        <p:nvSpPr>
+          <p:cNvPr id="40" name="Rectangle 39"/>
+          <p:cNvSpPr/>
+          <p:nvPr/>
+        </p:nvSpPr>
+        <p:spPr>
+          <a:xfrm>
+            <a:off x="1737360" y="5285231"/>
+            <a:ext cx="4169663" cy="566928"/>
+          </a:xfrm>
+          <a:prstGeom prst="rect">
+            <a:avLst/>
+          </a:prstGeom>
+          <a:solidFill>
+            <a:srgbClr val="FFE8D4"/>
+          </a:solidFill>
+          <a:ln>
+            <a:noFill/>
+          </a:ln>
+          <a:effectLst/>
+        </p:spPr>
+        <p:style>
+          <a:lnRef idx="1">
+            <a:schemeClr val="accent1"/>
+          </a:lnRef>
+          <a:fillRef idx="3">
+            <a:schemeClr val="accent1"/>
+          </a:fillRef>
+          <a:effectRef idx="2">
+            <a:schemeClr val="accent1"/>
+          </a:effectRef>
+          <a:fontRef idx="minor">
+            <a:schemeClr val="lt1"/>
+          </a:fontRef>
+        </p:style>
+        <p:txBody>
+          <a:bodyPr rtlCol="0" anchor="ctr" wrap="square" lIns="64008" rIns="64008" tIns="64008" bIns="64008"/>
+          <a:lstStyle/>
+          <a:p>
+            <a:pPr algn="l">
+              <a:spcAft>
+                <a:spcPts val="200"/>
+              </a:spcAft>
+            </a:pPr>
+            <a:r>
+              <a:rPr sz="1000" b="0">
+                <a:solidFill>
+                  <a:srgbClr val="1E1E1E"/>
+                </a:solidFill>
+                <a:latin typeface="Microsoft JhengHei"/>
+              </a:rPr>
+              <a:t>Agent OS 代理編排平台（跨廠商串接、權限控管、監督儀表板）；IFRS 17／TW-ICS 與 AI 治理服務</a:t>
+            </a:r>
+          </a:p>
+        </p:txBody>
+      </p:sp>
+      <p:sp>
+        <p:nvSpPr>
+          <p:cNvPr id="41" name="Rectangle 40"/>
+          <p:cNvSpPr/>
+          <p:nvPr/>
+        </p:nvSpPr>
+        <p:spPr>
+          <a:xfrm>
+            <a:off x="5943600" y="5285231"/>
+            <a:ext cx="1837943" cy="566928"/>
+          </a:xfrm>
+          <a:prstGeom prst="rect">
+            <a:avLst/>
+          </a:prstGeom>
+          <a:solidFill>
+            <a:srgbClr val="FFE8D4"/>
+          </a:solidFill>
+          <a:ln>
+            <a:noFill/>
+          </a:ln>
+          <a:effectLst/>
+        </p:spPr>
+        <p:style>
+          <a:lnRef idx="1">
+            <a:schemeClr val="accent1"/>
+          </a:lnRef>
+          <a:fillRef idx="3">
+            <a:schemeClr val="accent1"/>
+          </a:fillRef>
+          <a:effectRef idx="2">
+            <a:schemeClr val="accent1"/>
+          </a:effectRef>
+          <a:fontRef idx="minor">
+            <a:schemeClr val="lt1"/>
+          </a:fontRef>
+        </p:style>
+        <p:txBody>
+          <a:bodyPr rtlCol="0" anchor="ctr" wrap="square" lIns="64008" rIns="64008" tIns="64008" bIns="64008"/>
+          <a:lstStyle/>
+          <a:p>
+            <a:pPr algn="l">
+              <a:spcAft>
+                <a:spcPts val="200"/>
+              </a:spcAft>
+            </a:pPr>
+            <a:r>
+              <a:rPr sz="1000" b="0">
+                <a:solidFill>
+                  <a:srgbClr val="1E1E1E"/>
+                </a:solidFill>
+                <a:latin typeface="Microsoft JhengHei"/>
+              </a:rPr>
+              <a:t>治理＋財務資料＋落地</a:t>
+            </a:r>
+          </a:p>
+        </p:txBody>
+      </p:sp>
+      <p:sp>
+        <p:nvSpPr>
+          <p:cNvPr id="42" name="Rectangle 41"/>
+          <p:cNvSpPr/>
+          <p:nvPr/>
+        </p:nvSpPr>
+        <p:spPr>
+          <a:xfrm>
+            <a:off x="7818120" y="5285231"/>
+            <a:ext cx="2478024" cy="566928"/>
+          </a:xfrm>
+          <a:prstGeom prst="rect">
+            <a:avLst/>
+          </a:prstGeom>
+          <a:solidFill>
+            <a:srgbClr val="FFE8D4"/>
+          </a:solidFill>
+          <a:ln>
+            <a:noFill/>
+          </a:ln>
+          <a:effectLst/>
+        </p:spPr>
+        <p:style>
+          <a:lnRef idx="1">
+            <a:schemeClr val="accent1"/>
+          </a:lnRef>
+          <a:fillRef idx="3">
+            <a:schemeClr val="accent1"/>
+          </a:fillRef>
+          <a:effectRef idx="2">
+            <a:schemeClr val="accent1"/>
+          </a:effectRef>
+          <a:fontRef idx="minor">
+            <a:schemeClr val="lt1"/>
+          </a:fontRef>
+        </p:style>
+        <p:txBody>
+          <a:bodyPr rtlCol="0" anchor="ctr" wrap="square" lIns="64008" rIns="64008" tIns="64008" bIns="64008"/>
+          <a:lstStyle/>
+          <a:p>
+            <a:pPr algn="l">
+              <a:spcAft>
+                <a:spcPts val="200"/>
+              </a:spcAft>
+            </a:pPr>
+            <a:r>
+              <a:rPr sz="1000" b="0">
+                <a:solidFill>
+                  <a:srgbClr val="1E1E1E"/>
+                </a:solidFill>
+                <a:latin typeface="Microsoft JhengHei"/>
+              </a:rPr>
+              <a:t>可協作：把 Agent OS 與確信能力帶進第一波服務包</a:t>
+            </a:r>
+          </a:p>
+        </p:txBody>
+      </p:sp>
+      <p:sp>
+        <p:nvSpPr>
+          <p:cNvPr id="43" name="Rectangle 42"/>
+          <p:cNvSpPr/>
+          <p:nvPr/>
+        </p:nvSpPr>
+        <p:spPr>
+          <a:xfrm>
+            <a:off x="10332720" y="5285231"/>
+            <a:ext cx="1426464" cy="566928"/>
+          </a:xfrm>
+          <a:prstGeom prst="rect">
+            <a:avLst/>
+          </a:prstGeom>
+          <a:solidFill>
+            <a:srgbClr val="FFE8D4"/>
+          </a:solidFill>
+          <a:ln>
+            <a:noFill/>
+          </a:ln>
+          <a:effectLst/>
+        </p:spPr>
+        <p:style>
+          <a:lnRef idx="1">
+            <a:schemeClr val="accent1"/>
+          </a:lnRef>
+          <a:fillRef idx="3">
+            <a:schemeClr val="accent1"/>
+          </a:fillRef>
+          <a:effectRef idx="2">
+            <a:schemeClr val="accent1"/>
+          </a:effectRef>
+          <a:fontRef idx="minor">
+            <a:schemeClr val="lt1"/>
+          </a:fontRef>
+        </p:style>
+        <p:txBody>
+          <a:bodyPr rtlCol="0" anchor="ctr" wrap="square" lIns="64008" rIns="64008" tIns="64008" bIns="64008"/>
+          <a:lstStyle/>
+          <a:p>
+            <a:pPr algn="l">
+              <a:spcAft>
+                <a:spcPts val="200"/>
+              </a:spcAft>
+            </a:pPr>
+            <a:r>
+              <a:rPr sz="950" b="0" u="sng">
+                <a:solidFill>
+                  <a:srgbClr val="1F5FBF"/>
+                </a:solidFill>
+                <a:latin typeface="Microsoft JhengHei"/>
+                <a:hlinkClick r:id="rId13"/>
+              </a:rPr>
+              <a:t>Agent OS</a:t>
+            </a:r>
+          </a:p>
+          <a:p>
+            <a:pPr algn="l">
+              <a:spcAft>
+                <a:spcPts val="200"/>
+              </a:spcAft>
+            </a:pPr>
+            <a:r>
+              <a:rPr sz="950" b="0" u="sng">
+                <a:solidFill>
+                  <a:srgbClr val="1F5FBF"/>
+                </a:solidFill>
+                <a:latin typeface="Microsoft JhengHei"/>
+                <a:hlinkClick r:id="rId14"/>
+              </a:rPr>
+              <a:t>IFRS 17</a:t>
+            </a:r>
+          </a:p>
+        </p:txBody>
+      </p:sp>
+      <p:sp>
+        <p:nvSpPr>
+          <p:cNvPr id="44" name="Rectangle 43"/>
+          <p:cNvSpPr/>
+          <p:nvPr/>
+        </p:nvSpPr>
+        <p:spPr>
+          <a:xfrm>
+            <a:off x="411480" y="5925312"/>
+            <a:ext cx="11384280" cy="274320"/>
+          </a:xfrm>
+          <a:prstGeom prst="rect">
+            <a:avLst/>
+          </a:prstGeom>
+          <a:noFill/>
+          <a:ln>
+            <a:noFill/>
+          </a:ln>
+          <a:effectLst/>
+        </p:spPr>
+        <p:style>
+          <a:lnRef idx="1">
+            <a:schemeClr val="accent1"/>
+          </a:lnRef>
+          <a:fillRef idx="3">
+            <a:schemeClr val="accent1"/>
+          </a:fillRef>
+          <a:effectRef idx="2">
+            <a:schemeClr val="accent1"/>
+          </a:effectRef>
+          <a:fontRef idx="minor">
+            <a:schemeClr val="lt1"/>
+          </a:fontRef>
+        </p:style>
+        <p:txBody>
+          <a:bodyPr rtlCol="0" anchor="t" wrap="square" lIns="54864" rIns="54864" tIns="54864" bIns="54864"/>
+          <a:lstStyle/>
+          <a:p>
+            <a:pPr algn="l">
+              <a:spcAft>
+                <a:spcPts val="200"/>
+              </a:spcAft>
+            </a:pPr>
+            <a:r>
+              <a:rPr sz="900" b="0">
+                <a:solidFill>
+                  <a:srgbClr val="6B6B6B"/>
+                </a:solidFill>
+                <a:latin typeface="Microsoft JhengHei"/>
+              </a:rPr>
+              <a:t>「可能侷限」為依公開資料的推論，僅供內部討論，對外勿點名競爭者。點選右欄可開啟各機構官網或原文。</a:t>
+            </a:r>
+          </a:p>
+        </p:txBody>
+      </p:sp>
+    </p:spTree>
+  </p:cSld>
+  <p:clrMapOvr>
+    <a:masterClrMapping/>
+  </p:clrMapOvr>
+</p:sld>
+</file>
+
+<file path=ppt/slides/slide4.xml><?xml version="1.0" encoding="utf-8"?>
 <p:sld xmlns:a="http://schemas.openxmlformats.org/drawingml/2006/main" xmlns:p="http://schemas.openxmlformats.org/presentationml/2006/main" xmlns:r="http://schemas.openxmlformats.org/officeDocument/2006/relationships">
   <p:cSld>
     <p:spTree>

</xml_diff>

<commit_message>
Remove action plan slide from manager brief
Co-Authored-By: Claude Opus 5.5 <noreply@anthropic.com>
Claude-Session: https://claude.ai/code/session_01GwCwwmQUjvhTXeuyRaxofg
</commit_message>
<xml_diff>
--- a/research/insurtech-2026/保險科技服務優先順序_主管精簡版.pptx
+++ b/research/insurtech-2026/保險科技服務優先順序_主管精簡版.pptx
@@ -16,7 +16,6 @@
     <p:sldId id="256" r:id="rId17"/>
     <p:sldId id="257" r:id="rId18"/>
     <p:sldId id="258" r:id="rId19"/>
-    <p:sldId id="259" r:id="rId20"/>
   </p:sldIdLst>
   <p:sldSz cx="12192000" cy="6858000"/>
   <p:notesSz cx="6858000" cy="9144000"/>
@@ -49690,2071 +49689,6 @@
                 <a:latin typeface="Microsoft JhengHei"/>
               </a:rPr>
               <a:t>「可能侷限」為依公開資料的推論，僅供內部討論，對外勿點名競爭者。點選右欄可開啟各機構官網或原文。</a:t>
-            </a:r>
-          </a:p>
-        </p:txBody>
-      </p:sp>
-    </p:spTree>
-  </p:cSld>
-  <p:clrMapOvr>
-    <a:masterClrMapping/>
-  </p:clrMapOvr>
-</p:sld>
-</file>
-
-<file path=ppt/slides/slide4.xml><?xml version="1.0" encoding="utf-8"?>
-<p:sld xmlns:a="http://schemas.openxmlformats.org/drawingml/2006/main" xmlns:p="http://schemas.openxmlformats.org/presentationml/2006/main" xmlns:r="http://schemas.openxmlformats.org/officeDocument/2006/relationships">
-  <p:cSld>
-    <p:spTree>
-      <p:nvGrpSpPr>
-        <p:cNvPr id="1" name=""/>
-        <p:cNvGrpSpPr/>
-        <p:nvPr/>
-      </p:nvGrpSpPr>
-      <p:grpSpPr/>
-      <p:sp>
-        <p:nvSpPr>
-          <p:cNvPr id="2" name="Title 1"/>
-          <p:cNvSpPr>
-            <a:spLocks noGrp="1"/>
-          </p:cNvSpPr>
-          <p:nvPr>
-            <p:ph type="title"/>
-          </p:nvPr>
-        </p:nvSpPr>
-        <p:spPr/>
-        <p:txBody>
-          <a:bodyPr/>
-          <a:lstStyle/>
-          <a:p>
-            <a:r>
-              <a:rPr sz="2000">
-                <a:latin typeface="Microsoft JhengHei"/>
-              </a:rPr>
-              <a:t>90 天內把兩項服務包做成可銷售的提案，今天請決定四件事</a:t>
-            </a:r>
-          </a:p>
-        </p:txBody>
-      </p:sp>
-      <p:sp>
-        <p:nvSpPr>
-          <p:cNvPr id="3" name="Rectangle 2"/>
-          <p:cNvSpPr/>
-          <p:nvPr/>
-        </p:nvSpPr>
-        <p:spPr>
-          <a:xfrm>
-            <a:off x="1600200" y="1280160"/>
-            <a:ext cx="3343656" cy="384048"/>
-          </a:xfrm>
-          <a:prstGeom prst="rect">
-            <a:avLst/>
-          </a:prstGeom>
-          <a:solidFill>
-            <a:srgbClr val="1E1E1E"/>
-          </a:solidFill>
-          <a:ln>
-            <a:noFill/>
-          </a:ln>
-          <a:effectLst/>
-        </p:spPr>
-        <p:style>
-          <a:lnRef idx="1">
-            <a:schemeClr val="accent1"/>
-          </a:lnRef>
-          <a:fillRef idx="3">
-            <a:schemeClr val="accent1"/>
-          </a:fillRef>
-          <a:effectRef idx="2">
-            <a:schemeClr val="accent1"/>
-          </a:effectRef>
-          <a:fontRef idx="minor">
-            <a:schemeClr val="lt1"/>
-          </a:fontRef>
-        </p:style>
-        <p:txBody>
-          <a:bodyPr rtlCol="0" anchor="ctr" wrap="square" lIns="54864" rIns="54864" tIns="54864" bIns="54864"/>
-          <a:lstStyle/>
-          <a:p>
-            <a:pPr algn="ctr">
-              <a:spcAft>
-                <a:spcPts val="200"/>
-              </a:spcAft>
-            </a:pPr>
-            <a:r>
-              <a:rPr sz="1200" b="1">
-                <a:solidFill>
-                  <a:srgbClr val="FFFFFF"/>
-                </a:solidFill>
-                <a:latin typeface="Microsoft JhengHei"/>
-              </a:rPr>
-              <a:t>第 1–4 週｜打包</a:t>
-            </a:r>
-          </a:p>
-        </p:txBody>
-      </p:sp>
-      <p:sp>
-        <p:nvSpPr>
-          <p:cNvPr id="4" name="Rectangle 3"/>
-          <p:cNvSpPr/>
-          <p:nvPr/>
-        </p:nvSpPr>
-        <p:spPr>
-          <a:xfrm>
-            <a:off x="4998720" y="1280160"/>
-            <a:ext cx="3343656" cy="384048"/>
-          </a:xfrm>
-          <a:prstGeom prst="rect">
-            <a:avLst/>
-          </a:prstGeom>
-          <a:solidFill>
-            <a:srgbClr val="1E1E1E"/>
-          </a:solidFill>
-          <a:ln>
-            <a:noFill/>
-          </a:ln>
-          <a:effectLst/>
-        </p:spPr>
-        <p:style>
-          <a:lnRef idx="1">
-            <a:schemeClr val="accent1"/>
-          </a:lnRef>
-          <a:fillRef idx="3">
-            <a:schemeClr val="accent1"/>
-          </a:fillRef>
-          <a:effectRef idx="2">
-            <a:schemeClr val="accent1"/>
-          </a:effectRef>
-          <a:fontRef idx="minor">
-            <a:schemeClr val="lt1"/>
-          </a:fontRef>
-        </p:style>
-        <p:txBody>
-          <a:bodyPr rtlCol="0" anchor="ctr" wrap="square" lIns="54864" rIns="54864" tIns="54864" bIns="54864"/>
-          <a:lstStyle/>
-          <a:p>
-            <a:pPr algn="ctr">
-              <a:spcAft>
-                <a:spcPts val="200"/>
-              </a:spcAft>
-            </a:pPr>
-            <a:r>
-              <a:rPr sz="1200" b="1">
-                <a:solidFill>
-                  <a:srgbClr val="FFFFFF"/>
-                </a:solidFill>
-                <a:latin typeface="Microsoft JhengHei"/>
-              </a:rPr>
-              <a:t>第 5–8 週｜驗證</a:t>
-            </a:r>
-          </a:p>
-        </p:txBody>
-      </p:sp>
-      <p:sp>
-        <p:nvSpPr>
-          <p:cNvPr id="5" name="Rectangle 4"/>
-          <p:cNvSpPr/>
-          <p:nvPr/>
-        </p:nvSpPr>
-        <p:spPr>
-          <a:xfrm>
-            <a:off x="8397240" y="1280160"/>
-            <a:ext cx="3343656" cy="384048"/>
-          </a:xfrm>
-          <a:prstGeom prst="rect">
-            <a:avLst/>
-          </a:prstGeom>
-          <a:solidFill>
-            <a:srgbClr val="1E1E1E"/>
-          </a:solidFill>
-          <a:ln>
-            <a:noFill/>
-          </a:ln>
-          <a:effectLst/>
-        </p:spPr>
-        <p:style>
-          <a:lnRef idx="1">
-            <a:schemeClr val="accent1"/>
-          </a:lnRef>
-          <a:fillRef idx="3">
-            <a:schemeClr val="accent1"/>
-          </a:fillRef>
-          <a:effectRef idx="2">
-            <a:schemeClr val="accent1"/>
-          </a:effectRef>
-          <a:fontRef idx="minor">
-            <a:schemeClr val="lt1"/>
-          </a:fontRef>
-        </p:style>
-        <p:txBody>
-          <a:bodyPr rtlCol="0" anchor="ctr" wrap="square" lIns="54864" rIns="54864" tIns="54864" bIns="54864"/>
-          <a:lstStyle/>
-          <a:p>
-            <a:pPr algn="ctr">
-              <a:spcAft>
-                <a:spcPts val="200"/>
-              </a:spcAft>
-            </a:pPr>
-            <a:r>
-              <a:rPr sz="1200" b="1">
-                <a:solidFill>
-                  <a:srgbClr val="FFFFFF"/>
-                </a:solidFill>
-                <a:latin typeface="Microsoft JhengHei"/>
-              </a:rPr>
-              <a:t>第 9–12 週｜開賣</a:t>
-            </a:r>
-          </a:p>
-        </p:txBody>
-      </p:sp>
-      <p:sp>
-        <p:nvSpPr>
-          <p:cNvPr id="6" name="Rectangle 5"/>
-          <p:cNvSpPr/>
-          <p:nvPr/>
-        </p:nvSpPr>
-        <p:spPr>
-          <a:xfrm>
-            <a:off x="411480" y="1737360"/>
-            <a:ext cx="1133856" cy="548640"/>
-          </a:xfrm>
-          <a:prstGeom prst="rect">
-            <a:avLst/>
-          </a:prstGeom>
-          <a:solidFill>
-            <a:srgbClr val="F3F3F3"/>
-          </a:solidFill>
-          <a:ln>
-            <a:noFill/>
-          </a:ln>
-          <a:effectLst/>
-        </p:spPr>
-        <p:style>
-          <a:lnRef idx="1">
-            <a:schemeClr val="accent1"/>
-          </a:lnRef>
-          <a:fillRef idx="3">
-            <a:schemeClr val="accent1"/>
-          </a:fillRef>
-          <a:effectRef idx="2">
-            <a:schemeClr val="accent1"/>
-          </a:effectRef>
-          <a:fontRef idx="minor">
-            <a:schemeClr val="lt1"/>
-          </a:fontRef>
-        </p:style>
-        <p:txBody>
-          <a:bodyPr rtlCol="0" anchor="ctr" wrap="square" lIns="73152" rIns="73152" tIns="73152" bIns="73152"/>
-          <a:lstStyle/>
-          <a:p>
-            <a:pPr algn="l">
-              <a:spcAft>
-                <a:spcPts val="200"/>
-              </a:spcAft>
-            </a:pPr>
-            <a:r>
-              <a:rPr sz="1200" b="1">
-                <a:solidFill>
-                  <a:srgbClr val="FD5108"/>
-                </a:solidFill>
-                <a:latin typeface="Microsoft JhengHei"/>
-              </a:rPr>
-              <a:t>① IFRS 17</a:t>
-            </a:r>
-          </a:p>
-        </p:txBody>
-      </p:sp>
-      <p:sp>
-        <p:nvSpPr>
-          <p:cNvPr id="7" name="Rectangle 6"/>
-          <p:cNvSpPr/>
-          <p:nvPr/>
-        </p:nvSpPr>
-        <p:spPr>
-          <a:xfrm>
-            <a:off x="1600200" y="1737360"/>
-            <a:ext cx="3343656" cy="548640"/>
-          </a:xfrm>
-          <a:prstGeom prst="rect">
-            <a:avLst/>
-          </a:prstGeom>
-          <a:solidFill>
-            <a:srgbClr val="FFE8D4"/>
-          </a:solidFill>
-          <a:ln>
-            <a:noFill/>
-          </a:ln>
-          <a:effectLst/>
-        </p:spPr>
-        <p:style>
-          <a:lnRef idx="1">
-            <a:schemeClr val="accent1"/>
-          </a:lnRef>
-          <a:fillRef idx="3">
-            <a:schemeClr val="accent1"/>
-          </a:fillRef>
-          <a:effectRef idx="2">
-            <a:schemeClr val="accent1"/>
-          </a:effectRef>
-          <a:fontRef idx="minor">
-            <a:schemeClr val="lt1"/>
-          </a:fontRef>
-        </p:style>
-        <p:txBody>
-          <a:bodyPr rtlCol="0" anchor="ctr" wrap="square" tIns="91440" bIns="91440"/>
-          <a:lstStyle/>
-          <a:p>
-            <a:pPr algn="l">
-              <a:spcAft>
-                <a:spcPts val="200"/>
-              </a:spcAft>
-            </a:pPr>
-            <a:r>
-              <a:rPr sz="1100" b="0">
-                <a:solidFill>
-                  <a:srgbClr val="1E1E1E"/>
-                </a:solidFill>
-                <a:latin typeface="Microsoft JhengHei"/>
-              </a:rPr>
-              <a:t>服務一頁紙、首案範圍與報價區間</a:t>
-            </a:r>
-          </a:p>
-        </p:txBody>
-      </p:sp>
-      <p:sp>
-        <p:nvSpPr>
-          <p:cNvPr id="8" name="Rectangle 7"/>
-          <p:cNvSpPr/>
-          <p:nvPr/>
-        </p:nvSpPr>
-        <p:spPr>
-          <a:xfrm>
-            <a:off x="4998720" y="1737360"/>
-            <a:ext cx="3343656" cy="548640"/>
-          </a:xfrm>
-          <a:prstGeom prst="rect">
-            <a:avLst/>
-          </a:prstGeom>
-          <a:solidFill>
-            <a:srgbClr val="FFE8D4"/>
-          </a:solidFill>
-          <a:ln>
-            <a:noFill/>
-          </a:ln>
-          <a:effectLst/>
-        </p:spPr>
-        <p:style>
-          <a:lnRef idx="1">
-            <a:schemeClr val="accent1"/>
-          </a:lnRef>
-          <a:fillRef idx="3">
-            <a:schemeClr val="accent1"/>
-          </a:fillRef>
-          <a:effectRef idx="2">
-            <a:schemeClr val="accent1"/>
-          </a:effectRef>
-          <a:fontRef idx="minor">
-            <a:schemeClr val="lt1"/>
-          </a:fontRef>
-        </p:style>
-        <p:txBody>
-          <a:bodyPr rtlCol="0" anchor="ctr" wrap="square" tIns="91440" bIns="91440"/>
-          <a:lstStyle/>
-          <a:p>
-            <a:pPr algn="l">
-              <a:spcAft>
-                <a:spcPts val="200"/>
-              </a:spcAft>
-            </a:pPr>
-            <a:r>
-              <a:rPr sz="1100" b="0">
-                <a:solidFill>
-                  <a:srgbClr val="1E1E1E"/>
-                </a:solidFill>
-                <a:latin typeface="Microsoft JhengHei"/>
-              </a:rPr>
-              <a:t>與所內 IFRS 17 團隊確認分工、選目標客戶</a:t>
-            </a:r>
-          </a:p>
-        </p:txBody>
-      </p:sp>
-      <p:sp>
-        <p:nvSpPr>
-          <p:cNvPr id="9" name="Rectangle 8"/>
-          <p:cNvSpPr/>
-          <p:nvPr/>
-        </p:nvSpPr>
-        <p:spPr>
-          <a:xfrm>
-            <a:off x="8397240" y="1737360"/>
-            <a:ext cx="3343656" cy="548640"/>
-          </a:xfrm>
-          <a:prstGeom prst="rect">
-            <a:avLst/>
-          </a:prstGeom>
-          <a:solidFill>
-            <a:srgbClr val="FFE8D4"/>
-          </a:solidFill>
-          <a:ln>
-            <a:noFill/>
-          </a:ln>
-          <a:effectLst/>
-        </p:spPr>
-        <p:style>
-          <a:lnRef idx="1">
-            <a:schemeClr val="accent1"/>
-          </a:lnRef>
-          <a:fillRef idx="3">
-            <a:schemeClr val="accent1"/>
-          </a:fillRef>
-          <a:effectRef idx="2">
-            <a:schemeClr val="accent1"/>
-          </a:effectRef>
-          <a:fontRef idx="minor">
-            <a:schemeClr val="lt1"/>
-          </a:fontRef>
-        </p:style>
-        <p:txBody>
-          <a:bodyPr rtlCol="0" anchor="ctr" wrap="square" tIns="91440" bIns="91440"/>
-          <a:lstStyle/>
-          <a:p>
-            <a:pPr algn="l">
-              <a:spcAft>
-                <a:spcPts val="200"/>
-              </a:spcAft>
-            </a:pPr>
-            <a:r>
-              <a:rPr sz="1100" b="0">
-                <a:solidFill>
-                  <a:srgbClr val="1E1E1E"/>
-                </a:solidFill>
-                <a:latin typeface="Microsoft JhengHei"/>
-              </a:rPr>
-              <a:t>客戶對談、首案建議書</a:t>
-            </a:r>
-          </a:p>
-        </p:txBody>
-      </p:sp>
-      <p:sp>
-        <p:nvSpPr>
-          <p:cNvPr id="10" name="Rectangle 9"/>
-          <p:cNvSpPr/>
-          <p:nvPr/>
-        </p:nvSpPr>
-        <p:spPr>
-          <a:xfrm>
-            <a:off x="411480" y="2359152"/>
-            <a:ext cx="1133856" cy="548640"/>
-          </a:xfrm>
-          <a:prstGeom prst="rect">
-            <a:avLst/>
-          </a:prstGeom>
-          <a:solidFill>
-            <a:srgbClr val="F3F3F3"/>
-          </a:solidFill>
-          <a:ln>
-            <a:noFill/>
-          </a:ln>
-          <a:effectLst/>
-        </p:spPr>
-        <p:style>
-          <a:lnRef idx="1">
-            <a:schemeClr val="accent1"/>
-          </a:lnRef>
-          <a:fillRef idx="3">
-            <a:schemeClr val="accent1"/>
-          </a:fillRef>
-          <a:effectRef idx="2">
-            <a:schemeClr val="accent1"/>
-          </a:effectRef>
-          <a:fontRef idx="minor">
-            <a:schemeClr val="lt1"/>
-          </a:fontRef>
-        </p:style>
-        <p:txBody>
-          <a:bodyPr rtlCol="0" anchor="ctr" wrap="square" lIns="73152" rIns="73152" tIns="73152" bIns="73152"/>
-          <a:lstStyle/>
-          <a:p>
-            <a:pPr algn="l">
-              <a:spcAft>
-                <a:spcPts val="200"/>
-              </a:spcAft>
-            </a:pPr>
-            <a:r>
-              <a:rPr sz="1200" b="1">
-                <a:solidFill>
-                  <a:srgbClr val="FD5108"/>
-                </a:solidFill>
-                <a:latin typeface="Microsoft JhengHei"/>
-              </a:rPr>
-              <a:t>② AI 治理</a:t>
-            </a:r>
-          </a:p>
-        </p:txBody>
-      </p:sp>
-      <p:sp>
-        <p:nvSpPr>
-          <p:cNvPr id="11" name="Rectangle 10"/>
-          <p:cNvSpPr/>
-          <p:nvPr/>
-        </p:nvSpPr>
-        <p:spPr>
-          <a:xfrm>
-            <a:off x="1600200" y="2359152"/>
-            <a:ext cx="3343656" cy="548640"/>
-          </a:xfrm>
-          <a:prstGeom prst="rect">
-            <a:avLst/>
-          </a:prstGeom>
-          <a:solidFill>
-            <a:srgbClr val="FFE8D4"/>
-          </a:solidFill>
-          <a:ln>
-            <a:noFill/>
-          </a:ln>
-          <a:effectLst/>
-        </p:spPr>
-        <p:style>
-          <a:lnRef idx="1">
-            <a:schemeClr val="accent1"/>
-          </a:lnRef>
-          <a:fillRef idx="3">
-            <a:schemeClr val="accent1"/>
-          </a:fillRef>
-          <a:effectRef idx="2">
-            <a:schemeClr val="accent1"/>
-          </a:effectRef>
-          <a:fontRef idx="minor">
-            <a:schemeClr val="lt1"/>
-          </a:fontRef>
-        </p:style>
-        <p:txBody>
-          <a:bodyPr rtlCol="0" anchor="ctr" wrap="square" tIns="91440" bIns="91440"/>
-          <a:lstStyle/>
-          <a:p>
-            <a:pPr algn="l">
-              <a:spcAft>
-                <a:spcPts val="200"/>
-              </a:spcAft>
-            </a:pPr>
-            <a:r>
-              <a:rPr sz="1100" b="0">
-                <a:solidFill>
-                  <a:srgbClr val="1E1E1E"/>
-                </a:solidFill>
-                <a:latin typeface="Microsoft JhengHei"/>
-              </a:rPr>
-              <a:t>健檢方法與 AI 清冊範本</a:t>
-            </a:r>
-          </a:p>
-        </p:txBody>
-      </p:sp>
-      <p:sp>
-        <p:nvSpPr>
-          <p:cNvPr id="12" name="Rectangle 11"/>
-          <p:cNvSpPr/>
-          <p:nvPr/>
-        </p:nvSpPr>
-        <p:spPr>
-          <a:xfrm>
-            <a:off x="4998720" y="2359152"/>
-            <a:ext cx="3343656" cy="548640"/>
-          </a:xfrm>
-          <a:prstGeom prst="rect">
-            <a:avLst/>
-          </a:prstGeom>
-          <a:solidFill>
-            <a:srgbClr val="FFE8D4"/>
-          </a:solidFill>
-          <a:ln>
-            <a:noFill/>
-          </a:ln>
-          <a:effectLst/>
-        </p:spPr>
-        <p:style>
-          <a:lnRef idx="1">
-            <a:schemeClr val="accent1"/>
-          </a:lnRef>
-          <a:fillRef idx="3">
-            <a:schemeClr val="accent1"/>
-          </a:fillRef>
-          <a:effectRef idx="2">
-            <a:schemeClr val="accent1"/>
-          </a:effectRef>
-          <a:fontRef idx="minor">
-            <a:schemeClr val="lt1"/>
-          </a:fontRef>
-        </p:style>
-        <p:txBody>
-          <a:bodyPr rtlCol="0" anchor="ctr" wrap="square" tIns="91440" bIns="91440"/>
-          <a:lstStyle/>
-          <a:p>
-            <a:pPr algn="l">
-              <a:spcAft>
-                <a:spcPts val="200"/>
-              </a:spcAft>
-            </a:pPr>
-            <a:r>
-              <a:rPr sz="1100" b="0">
-                <a:solidFill>
-                  <a:srgbClr val="1E1E1E"/>
-                </a:solidFill>
-                <a:latin typeface="Microsoft JhengHei"/>
-              </a:rPr>
-              <a:t>R&amp;Q 獨立性確認、內部試做</a:t>
-            </a:r>
-          </a:p>
-        </p:txBody>
-      </p:sp>
-      <p:sp>
-        <p:nvSpPr>
-          <p:cNvPr id="13" name="Rectangle 12"/>
-          <p:cNvSpPr/>
-          <p:nvPr/>
-        </p:nvSpPr>
-        <p:spPr>
-          <a:xfrm>
-            <a:off x="8397240" y="2359152"/>
-            <a:ext cx="3343656" cy="548640"/>
-          </a:xfrm>
-          <a:prstGeom prst="rect">
-            <a:avLst/>
-          </a:prstGeom>
-          <a:solidFill>
-            <a:srgbClr val="FFE8D4"/>
-          </a:solidFill>
-          <a:ln>
-            <a:noFill/>
-          </a:ln>
-          <a:effectLst/>
-        </p:spPr>
-        <p:style>
-          <a:lnRef idx="1">
-            <a:schemeClr val="accent1"/>
-          </a:lnRef>
-          <a:fillRef idx="3">
-            <a:schemeClr val="accent1"/>
-          </a:fillRef>
-          <a:effectRef idx="2">
-            <a:schemeClr val="accent1"/>
-          </a:effectRef>
-          <a:fontRef idx="minor">
-            <a:schemeClr val="lt1"/>
-          </a:fontRef>
-        </p:style>
-        <p:txBody>
-          <a:bodyPr rtlCol="0" anchor="ctr" wrap="square" tIns="91440" bIns="91440"/>
-          <a:lstStyle/>
-          <a:p>
-            <a:pPr algn="l">
-              <a:spcAft>
-                <a:spcPts val="200"/>
-              </a:spcAft>
-            </a:pPr>
-            <a:r>
-              <a:rPr sz="1100" b="0">
-                <a:solidFill>
-                  <a:srgbClr val="1E1E1E"/>
-                </a:solidFill>
-                <a:latin typeface="Microsoft JhengHei"/>
-              </a:rPr>
-              <a:t>客戶對談、首案建議書</a:t>
-            </a:r>
-          </a:p>
-        </p:txBody>
-      </p:sp>
-      <p:sp>
-        <p:nvSpPr>
-          <p:cNvPr id="14" name="Rectangle 13"/>
-          <p:cNvSpPr/>
-          <p:nvPr/>
-        </p:nvSpPr>
-        <p:spPr>
-          <a:xfrm>
-            <a:off x="411480" y="3108960"/>
-            <a:ext cx="7498079" cy="384048"/>
-          </a:xfrm>
-          <a:prstGeom prst="rect">
-            <a:avLst/>
-          </a:prstGeom>
-          <a:solidFill>
-            <a:srgbClr val="FD5108"/>
-          </a:solidFill>
-          <a:ln>
-            <a:noFill/>
-          </a:ln>
-          <a:effectLst/>
-        </p:spPr>
-        <p:style>
-          <a:lnRef idx="1">
-            <a:schemeClr val="accent1"/>
-          </a:lnRef>
-          <a:fillRef idx="3">
-            <a:schemeClr val="accent1"/>
-          </a:fillRef>
-          <a:effectRef idx="2">
-            <a:schemeClr val="accent1"/>
-          </a:effectRef>
-          <a:fontRef idx="minor">
-            <a:schemeClr val="lt1"/>
-          </a:fontRef>
-        </p:style>
-        <p:txBody>
-          <a:bodyPr rtlCol="0" anchor="ctr" wrap="square" lIns="54864" rIns="54864" tIns="54864" bIns="54864"/>
-          <a:lstStyle/>
-          <a:p>
-            <a:pPr algn="l">
-              <a:spcAft>
-                <a:spcPts val="200"/>
-              </a:spcAft>
-            </a:pPr>
-            <a:r>
-              <a:rPr sz="1300" b="1">
-                <a:solidFill>
-                  <a:srgbClr val="FFFFFF"/>
-                </a:solidFill>
-                <a:latin typeface="Microsoft JhengHei"/>
-              </a:rPr>
-              <a:t>今天請決定</a:t>
-            </a:r>
-          </a:p>
-        </p:txBody>
-      </p:sp>
-      <p:sp>
-        <p:nvSpPr>
-          <p:cNvPr id="15" name="Oval 14"/>
-          <p:cNvSpPr/>
-          <p:nvPr/>
-        </p:nvSpPr>
-        <p:spPr>
-          <a:xfrm>
-            <a:off x="457200" y="3657600"/>
-            <a:ext cx="384048" cy="384048"/>
-          </a:xfrm>
-          <a:prstGeom prst="ellipse">
-            <a:avLst/>
-          </a:prstGeom>
-          <a:solidFill>
-            <a:srgbClr val="FD5108"/>
-          </a:solidFill>
-          <a:ln>
-            <a:noFill/>
-          </a:ln>
-          <a:effectLst/>
-        </p:spPr>
-        <p:style>
-          <a:lnRef idx="1">
-            <a:schemeClr val="accent1"/>
-          </a:lnRef>
-          <a:fillRef idx="3">
-            <a:schemeClr val="accent1"/>
-          </a:fillRef>
-          <a:effectRef idx="2">
-            <a:schemeClr val="accent1"/>
-          </a:effectRef>
-          <a:fontRef idx="minor">
-            <a:schemeClr val="lt1"/>
-          </a:fontRef>
-        </p:style>
-        <p:txBody>
-          <a:bodyPr rtlCol="0" anchor="ctr" lIns="0" rIns="0" tIns="0" bIns="0"/>
-          <a:lstStyle/>
-          <a:p>
-            <a:pPr algn="ctr"/>
-            <a:r>
-              <a:rPr sz="1200" b="1">
-                <a:solidFill>
-                  <a:srgbClr val="FFFFFF"/>
-                </a:solidFill>
-                <a:latin typeface="Microsoft JhengHei"/>
-              </a:rPr>
-              <a:t>1</a:t>
-            </a:r>
-          </a:p>
-        </p:txBody>
-      </p:sp>
-      <p:sp>
-        <p:nvSpPr>
-          <p:cNvPr id="16" name="Rectangle 15"/>
-          <p:cNvSpPr/>
-          <p:nvPr/>
-        </p:nvSpPr>
-        <p:spPr>
-          <a:xfrm>
-            <a:off x="960120" y="3566160"/>
-            <a:ext cx="2148840" cy="530352"/>
-          </a:xfrm>
-          <a:prstGeom prst="rect">
-            <a:avLst/>
-          </a:prstGeom>
-          <a:solidFill>
-            <a:srgbClr val="F3F3F3"/>
-          </a:solidFill>
-          <a:ln>
-            <a:noFill/>
-          </a:ln>
-          <a:effectLst/>
-        </p:spPr>
-        <p:style>
-          <a:lnRef idx="1">
-            <a:schemeClr val="accent1"/>
-          </a:lnRef>
-          <a:fillRef idx="3">
-            <a:schemeClr val="accent1"/>
-          </a:fillRef>
-          <a:effectRef idx="2">
-            <a:schemeClr val="accent1"/>
-          </a:effectRef>
-          <a:fontRef idx="minor">
-            <a:schemeClr val="lt1"/>
-          </a:fontRef>
-        </p:style>
-        <p:txBody>
-          <a:bodyPr rtlCol="0" anchor="ctr" wrap="square" lIns="73152" rIns="73152" tIns="73152" bIns="73152"/>
-          <a:lstStyle/>
-          <a:p>
-            <a:pPr algn="l">
-              <a:spcAft>
-                <a:spcPts val="200"/>
-              </a:spcAft>
-            </a:pPr>
-            <a:r>
-              <a:rPr sz="1150" b="1">
-                <a:solidFill>
-                  <a:srgbClr val="1E1E1E"/>
-                </a:solidFill>
-                <a:latin typeface="Microsoft JhengHei"/>
-              </a:rPr>
-              <a:t>第一波推哪兩項服務</a:t>
-            </a:r>
-          </a:p>
-        </p:txBody>
-      </p:sp>
-      <p:sp>
-        <p:nvSpPr>
-          <p:cNvPr id="17" name="Rectangle 16"/>
-          <p:cNvSpPr/>
-          <p:nvPr/>
-        </p:nvSpPr>
-        <p:spPr>
-          <a:xfrm>
-            <a:off x="3154680" y="3566160"/>
-            <a:ext cx="3886200" cy="530352"/>
-          </a:xfrm>
-          <a:prstGeom prst="rect">
-            <a:avLst/>
-          </a:prstGeom>
-          <a:solidFill>
-            <a:srgbClr val="FFE8D4"/>
-          </a:solidFill>
-          <a:ln>
-            <a:noFill/>
-          </a:ln>
-          <a:effectLst/>
-        </p:spPr>
-        <p:style>
-          <a:lnRef idx="1">
-            <a:schemeClr val="accent1"/>
-          </a:lnRef>
-          <a:fillRef idx="3">
-            <a:schemeClr val="accent1"/>
-          </a:fillRef>
-          <a:effectRef idx="2">
-            <a:schemeClr val="accent1"/>
-          </a:effectRef>
-          <a:fontRef idx="minor">
-            <a:schemeClr val="lt1"/>
-          </a:fontRef>
-        </p:style>
-        <p:txBody>
-          <a:bodyPr rtlCol="0" anchor="ctr" wrap="square" lIns="73152" rIns="73152" tIns="73152" bIns="73152"/>
-          <a:lstStyle/>
-          <a:p>
-            <a:pPr algn="l">
-              <a:spcAft>
-                <a:spcPts val="200"/>
-              </a:spcAft>
-            </a:pPr>
-            <a:r>
-              <a:rPr sz="1100" b="0">
-                <a:solidFill>
-                  <a:srgbClr val="1E1E1E"/>
-                </a:solidFill>
-                <a:latin typeface="Microsoft JhengHei"/>
-              </a:rPr>
-              <a:t>IFRS 17／TW-ICS 後財務轉型、AI 清冊與模型驗證健檢</a:t>
-            </a:r>
-          </a:p>
-        </p:txBody>
-      </p:sp>
-      <p:sp>
-        <p:nvSpPr>
-          <p:cNvPr id="18" name="Rectangle 17"/>
-          <p:cNvSpPr/>
-          <p:nvPr/>
-        </p:nvSpPr>
-        <p:spPr>
-          <a:xfrm>
-            <a:off x="7086600" y="3566160"/>
-            <a:ext cx="822960" cy="530352"/>
-          </a:xfrm>
-          <a:prstGeom prst="rect">
-            <a:avLst/>
-          </a:prstGeom>
-          <a:solidFill>
-            <a:srgbClr val="F3F3F3"/>
-          </a:solidFill>
-          <a:ln>
-            <a:noFill/>
-          </a:ln>
-          <a:effectLst/>
-        </p:spPr>
-        <p:style>
-          <a:lnRef idx="1">
-            <a:schemeClr val="accent1"/>
-          </a:lnRef>
-          <a:fillRef idx="3">
-            <a:schemeClr val="accent1"/>
-          </a:fillRef>
-          <a:effectRef idx="2">
-            <a:schemeClr val="accent1"/>
-          </a:effectRef>
-          <a:fontRef idx="minor">
-            <a:schemeClr val="lt1"/>
-          </a:fontRef>
-        </p:style>
-        <p:txBody>
-          <a:bodyPr rtlCol="0" anchor="ctr" wrap="square" lIns="36576" rIns="36576" tIns="36576" bIns="36576"/>
-          <a:lstStyle/>
-          <a:p>
-            <a:pPr algn="ctr">
-              <a:spcAft>
-                <a:spcPts val="200"/>
-              </a:spcAft>
-            </a:pPr>
-            <a:r>
-              <a:rPr sz="1100" b="1">
-                <a:solidFill>
-                  <a:srgbClr val="FD5108"/>
-                </a:solidFill>
-                <a:latin typeface="Microsoft JhengHei"/>
-              </a:rPr>
-              <a:t>今天</a:t>
-            </a:r>
-          </a:p>
-        </p:txBody>
-      </p:sp>
-      <p:sp>
-        <p:nvSpPr>
-          <p:cNvPr id="19" name="Oval 18"/>
-          <p:cNvSpPr/>
-          <p:nvPr/>
-        </p:nvSpPr>
-        <p:spPr>
-          <a:xfrm>
-            <a:off x="457200" y="4261103"/>
-            <a:ext cx="384048" cy="384048"/>
-          </a:xfrm>
-          <a:prstGeom prst="ellipse">
-            <a:avLst/>
-          </a:prstGeom>
-          <a:solidFill>
-            <a:srgbClr val="FD5108"/>
-          </a:solidFill>
-          <a:ln>
-            <a:noFill/>
-          </a:ln>
-          <a:effectLst/>
-        </p:spPr>
-        <p:style>
-          <a:lnRef idx="1">
-            <a:schemeClr val="accent1"/>
-          </a:lnRef>
-          <a:fillRef idx="3">
-            <a:schemeClr val="accent1"/>
-          </a:fillRef>
-          <a:effectRef idx="2">
-            <a:schemeClr val="accent1"/>
-          </a:effectRef>
-          <a:fontRef idx="minor">
-            <a:schemeClr val="lt1"/>
-          </a:fontRef>
-        </p:style>
-        <p:txBody>
-          <a:bodyPr rtlCol="0" anchor="ctr" lIns="0" rIns="0" tIns="0" bIns="0"/>
-          <a:lstStyle/>
-          <a:p>
-            <a:pPr algn="ctr"/>
-            <a:r>
-              <a:rPr sz="1200" b="1">
-                <a:solidFill>
-                  <a:srgbClr val="FFFFFF"/>
-                </a:solidFill>
-                <a:latin typeface="Microsoft JhengHei"/>
-              </a:rPr>
-              <a:t>2</a:t>
-            </a:r>
-          </a:p>
-        </p:txBody>
-      </p:sp>
-      <p:sp>
-        <p:nvSpPr>
-          <p:cNvPr id="20" name="Rectangle 19"/>
-          <p:cNvSpPr/>
-          <p:nvPr/>
-        </p:nvSpPr>
-        <p:spPr>
-          <a:xfrm>
-            <a:off x="960120" y="4169663"/>
-            <a:ext cx="2148840" cy="530352"/>
-          </a:xfrm>
-          <a:prstGeom prst="rect">
-            <a:avLst/>
-          </a:prstGeom>
-          <a:solidFill>
-            <a:srgbClr val="F3F3F3"/>
-          </a:solidFill>
-          <a:ln>
-            <a:noFill/>
-          </a:ln>
-          <a:effectLst/>
-        </p:spPr>
-        <p:style>
-          <a:lnRef idx="1">
-            <a:schemeClr val="accent1"/>
-          </a:lnRef>
-          <a:fillRef idx="3">
-            <a:schemeClr val="accent1"/>
-          </a:fillRef>
-          <a:effectRef idx="2">
-            <a:schemeClr val="accent1"/>
-          </a:effectRef>
-          <a:fontRef idx="minor">
-            <a:schemeClr val="lt1"/>
-          </a:fontRef>
-        </p:style>
-        <p:txBody>
-          <a:bodyPr rtlCol="0" anchor="ctr" wrap="square" lIns="73152" rIns="73152" tIns="73152" bIns="73152"/>
-          <a:lstStyle/>
-          <a:p>
-            <a:pPr algn="l">
-              <a:spcAft>
-                <a:spcPts val="200"/>
-              </a:spcAft>
-            </a:pPr>
-            <a:r>
-              <a:rPr sz="1150" b="1">
-                <a:solidFill>
-                  <a:srgbClr val="1E1E1E"/>
-                </a:solidFill>
-                <a:latin typeface="Microsoft JhengHei"/>
-              </a:rPr>
-              <a:t>每項服務包的負責人</a:t>
-            </a:r>
-          </a:p>
-        </p:txBody>
-      </p:sp>
-      <p:sp>
-        <p:nvSpPr>
-          <p:cNvPr id="21" name="Rectangle 20"/>
-          <p:cNvSpPr/>
-          <p:nvPr/>
-        </p:nvSpPr>
-        <p:spPr>
-          <a:xfrm>
-            <a:off x="3154680" y="4169663"/>
-            <a:ext cx="3886200" cy="530352"/>
-          </a:xfrm>
-          <a:prstGeom prst="rect">
-            <a:avLst/>
-          </a:prstGeom>
-          <a:solidFill>
-            <a:srgbClr val="FFE8D4"/>
-          </a:solidFill>
-          <a:ln>
-            <a:noFill/>
-          </a:ln>
-          <a:effectLst/>
-        </p:spPr>
-        <p:style>
-          <a:lnRef idx="1">
-            <a:schemeClr val="accent1"/>
-          </a:lnRef>
-          <a:fillRef idx="3">
-            <a:schemeClr val="accent1"/>
-          </a:fillRef>
-          <a:effectRef idx="2">
-            <a:schemeClr val="accent1"/>
-          </a:effectRef>
-          <a:fontRef idx="minor">
-            <a:schemeClr val="lt1"/>
-          </a:fontRef>
-        </p:style>
-        <p:txBody>
-          <a:bodyPr rtlCol="0" anchor="ctr" wrap="square" lIns="73152" rIns="73152" tIns="73152" bIns="73152"/>
-          <a:lstStyle/>
-          <a:p>
-            <a:pPr algn="l">
-              <a:spcAft>
-                <a:spcPts val="200"/>
-              </a:spcAft>
-            </a:pPr>
-            <a:r>
-              <a:rPr sz="1100" b="0">
-                <a:solidFill>
-                  <a:srgbClr val="1E1E1E"/>
-                </a:solidFill>
-                <a:latin typeface="Microsoft JhengHei"/>
-              </a:rPr>
-              <a:t>各 1 位負責人＋1 位支援；第 1 週找 R&amp;Q 確認獨立性</a:t>
-            </a:r>
-          </a:p>
-        </p:txBody>
-      </p:sp>
-      <p:sp>
-        <p:nvSpPr>
-          <p:cNvPr id="22" name="Rectangle 21"/>
-          <p:cNvSpPr/>
-          <p:nvPr/>
-        </p:nvSpPr>
-        <p:spPr>
-          <a:xfrm>
-            <a:off x="7086600" y="4169663"/>
-            <a:ext cx="822960" cy="530352"/>
-          </a:xfrm>
-          <a:prstGeom prst="rect">
-            <a:avLst/>
-          </a:prstGeom>
-          <a:solidFill>
-            <a:srgbClr val="F3F3F3"/>
-          </a:solidFill>
-          <a:ln>
-            <a:noFill/>
-          </a:ln>
-          <a:effectLst/>
-        </p:spPr>
-        <p:style>
-          <a:lnRef idx="1">
-            <a:schemeClr val="accent1"/>
-          </a:lnRef>
-          <a:fillRef idx="3">
-            <a:schemeClr val="accent1"/>
-          </a:fillRef>
-          <a:effectRef idx="2">
-            <a:schemeClr val="accent1"/>
-          </a:effectRef>
-          <a:fontRef idx="minor">
-            <a:schemeClr val="lt1"/>
-          </a:fontRef>
-        </p:style>
-        <p:txBody>
-          <a:bodyPr rtlCol="0" anchor="ctr" wrap="square" lIns="36576" rIns="36576" tIns="36576" bIns="36576"/>
-          <a:lstStyle/>
-          <a:p>
-            <a:pPr algn="ctr">
-              <a:spcAft>
-                <a:spcPts val="200"/>
-              </a:spcAft>
-            </a:pPr>
-            <a:r>
-              <a:rPr sz="1100" b="1">
-                <a:solidFill>
-                  <a:srgbClr val="FD5108"/>
-                </a:solidFill>
-                <a:latin typeface="Microsoft JhengHei"/>
-              </a:rPr>
-              <a:t>今天</a:t>
-            </a:r>
-          </a:p>
-        </p:txBody>
-      </p:sp>
-      <p:sp>
-        <p:nvSpPr>
-          <p:cNvPr id="23" name="Oval 22"/>
-          <p:cNvSpPr/>
-          <p:nvPr/>
-        </p:nvSpPr>
-        <p:spPr>
-          <a:xfrm>
-            <a:off x="457200" y="4864607"/>
-            <a:ext cx="384048" cy="384048"/>
-          </a:xfrm>
-          <a:prstGeom prst="ellipse">
-            <a:avLst/>
-          </a:prstGeom>
-          <a:solidFill>
-            <a:srgbClr val="FD5108"/>
-          </a:solidFill>
-          <a:ln>
-            <a:noFill/>
-          </a:ln>
-          <a:effectLst/>
-        </p:spPr>
-        <p:style>
-          <a:lnRef idx="1">
-            <a:schemeClr val="accent1"/>
-          </a:lnRef>
-          <a:fillRef idx="3">
-            <a:schemeClr val="accent1"/>
-          </a:fillRef>
-          <a:effectRef idx="2">
-            <a:schemeClr val="accent1"/>
-          </a:effectRef>
-          <a:fontRef idx="minor">
-            <a:schemeClr val="lt1"/>
-          </a:fontRef>
-        </p:style>
-        <p:txBody>
-          <a:bodyPr rtlCol="0" anchor="ctr" lIns="0" rIns="0" tIns="0" bIns="0"/>
-          <a:lstStyle/>
-          <a:p>
-            <a:pPr algn="ctr"/>
-            <a:r>
-              <a:rPr sz="1200" b="1">
-                <a:solidFill>
-                  <a:srgbClr val="FFFFFF"/>
-                </a:solidFill>
-                <a:latin typeface="Microsoft JhengHei"/>
-              </a:rPr>
-              <a:t>3</a:t>
-            </a:r>
-          </a:p>
-        </p:txBody>
-      </p:sp>
-      <p:sp>
-        <p:nvSpPr>
-          <p:cNvPr id="24" name="Rectangle 23"/>
-          <p:cNvSpPr/>
-          <p:nvPr/>
-        </p:nvSpPr>
-        <p:spPr>
-          <a:xfrm>
-            <a:off x="960120" y="4773168"/>
-            <a:ext cx="2148840" cy="530352"/>
-          </a:xfrm>
-          <a:prstGeom prst="rect">
-            <a:avLst/>
-          </a:prstGeom>
-          <a:solidFill>
-            <a:srgbClr val="F3F3F3"/>
-          </a:solidFill>
-          <a:ln>
-            <a:noFill/>
-          </a:ln>
-          <a:effectLst/>
-        </p:spPr>
-        <p:style>
-          <a:lnRef idx="1">
-            <a:schemeClr val="accent1"/>
-          </a:lnRef>
-          <a:fillRef idx="3">
-            <a:schemeClr val="accent1"/>
-          </a:fillRef>
-          <a:effectRef idx="2">
-            <a:schemeClr val="accent1"/>
-          </a:effectRef>
-          <a:fontRef idx="minor">
-            <a:schemeClr val="lt1"/>
-          </a:fontRef>
-        </p:style>
-        <p:txBody>
-          <a:bodyPr rtlCol="0" anchor="ctr" wrap="square" lIns="73152" rIns="73152" tIns="73152" bIns="73152"/>
-          <a:lstStyle/>
-          <a:p>
-            <a:pPr algn="l">
-              <a:spcAft>
-                <a:spcPts val="200"/>
-              </a:spcAft>
-            </a:pPr>
-            <a:r>
-              <a:rPr sz="1150" b="1">
-                <a:solidFill>
-                  <a:srgbClr val="1E1E1E"/>
-                </a:solidFill>
-                <a:latin typeface="Microsoft JhengHei"/>
-              </a:rPr>
-              <a:t>90 天計畫與檢查點</a:t>
-            </a:r>
-          </a:p>
-        </p:txBody>
-      </p:sp>
-      <p:sp>
-        <p:nvSpPr>
-          <p:cNvPr id="25" name="Rectangle 24"/>
-          <p:cNvSpPr/>
-          <p:nvPr/>
-        </p:nvSpPr>
-        <p:spPr>
-          <a:xfrm>
-            <a:off x="3154680" y="4773168"/>
-            <a:ext cx="3886200" cy="530352"/>
-          </a:xfrm>
-          <a:prstGeom prst="rect">
-            <a:avLst/>
-          </a:prstGeom>
-          <a:solidFill>
-            <a:srgbClr val="FFE8D4"/>
-          </a:solidFill>
-          <a:ln>
-            <a:noFill/>
-          </a:ln>
-          <a:effectLst/>
-        </p:spPr>
-        <p:style>
-          <a:lnRef idx="1">
-            <a:schemeClr val="accent1"/>
-          </a:lnRef>
-          <a:fillRef idx="3">
-            <a:schemeClr val="accent1"/>
-          </a:fillRef>
-          <a:effectRef idx="2">
-            <a:schemeClr val="accent1"/>
-          </a:effectRef>
-          <a:fontRef idx="minor">
-            <a:schemeClr val="lt1"/>
-          </a:fontRef>
-        </p:style>
-        <p:txBody>
-          <a:bodyPr rtlCol="0" anchor="ctr" wrap="square" lIns="73152" rIns="73152" tIns="73152" bIns="73152"/>
-          <a:lstStyle/>
-          <a:p>
-            <a:pPr algn="l">
-              <a:spcAft>
-                <a:spcPts val="200"/>
-              </a:spcAft>
-            </a:pPr>
-            <a:r>
-              <a:rPr sz="1100" b="0">
-                <a:solidFill>
-                  <a:srgbClr val="1E1E1E"/>
-                </a:solidFill>
-                <a:latin typeface="Microsoft JhengHei"/>
-              </a:rPr>
-              <a:t>第 4、8、12 週各一次，每次 30 分鐘</a:t>
-            </a:r>
-          </a:p>
-        </p:txBody>
-      </p:sp>
-      <p:sp>
-        <p:nvSpPr>
-          <p:cNvPr id="26" name="Rectangle 25"/>
-          <p:cNvSpPr/>
-          <p:nvPr/>
-        </p:nvSpPr>
-        <p:spPr>
-          <a:xfrm>
-            <a:off x="7086600" y="4773168"/>
-            <a:ext cx="822960" cy="530352"/>
-          </a:xfrm>
-          <a:prstGeom prst="rect">
-            <a:avLst/>
-          </a:prstGeom>
-          <a:solidFill>
-            <a:srgbClr val="F3F3F3"/>
-          </a:solidFill>
-          <a:ln>
-            <a:noFill/>
-          </a:ln>
-          <a:effectLst/>
-        </p:spPr>
-        <p:style>
-          <a:lnRef idx="1">
-            <a:schemeClr val="accent1"/>
-          </a:lnRef>
-          <a:fillRef idx="3">
-            <a:schemeClr val="accent1"/>
-          </a:fillRef>
-          <a:effectRef idx="2">
-            <a:schemeClr val="accent1"/>
-          </a:effectRef>
-          <a:fontRef idx="minor">
-            <a:schemeClr val="lt1"/>
-          </a:fontRef>
-        </p:style>
-        <p:txBody>
-          <a:bodyPr rtlCol="0" anchor="ctr" wrap="square" lIns="36576" rIns="36576" tIns="36576" bIns="36576"/>
-          <a:lstStyle/>
-          <a:p>
-            <a:pPr algn="ctr">
-              <a:spcAft>
-                <a:spcPts val="200"/>
-              </a:spcAft>
-            </a:pPr>
-            <a:r>
-              <a:rPr sz="1100" b="1">
-                <a:solidFill>
-                  <a:srgbClr val="FD5108"/>
-                </a:solidFill>
-                <a:latin typeface="Microsoft JhengHei"/>
-              </a:rPr>
-              <a:t>第 1 週</a:t>
-            </a:r>
-          </a:p>
-        </p:txBody>
-      </p:sp>
-      <p:sp>
-        <p:nvSpPr>
-          <p:cNvPr id="27" name="Oval 26"/>
-          <p:cNvSpPr/>
-          <p:nvPr/>
-        </p:nvSpPr>
-        <p:spPr>
-          <a:xfrm>
-            <a:off x="457200" y="5468112"/>
-            <a:ext cx="384048" cy="384048"/>
-          </a:xfrm>
-          <a:prstGeom prst="ellipse">
-            <a:avLst/>
-          </a:prstGeom>
-          <a:solidFill>
-            <a:srgbClr val="FD5108"/>
-          </a:solidFill>
-          <a:ln>
-            <a:noFill/>
-          </a:ln>
-          <a:effectLst/>
-        </p:spPr>
-        <p:style>
-          <a:lnRef idx="1">
-            <a:schemeClr val="accent1"/>
-          </a:lnRef>
-          <a:fillRef idx="3">
-            <a:schemeClr val="accent1"/>
-          </a:fillRef>
-          <a:effectRef idx="2">
-            <a:schemeClr val="accent1"/>
-          </a:effectRef>
-          <a:fontRef idx="minor">
-            <a:schemeClr val="lt1"/>
-          </a:fontRef>
-        </p:style>
-        <p:txBody>
-          <a:bodyPr rtlCol="0" anchor="ctr" lIns="0" rIns="0" tIns="0" bIns="0"/>
-          <a:lstStyle/>
-          <a:p>
-            <a:pPr algn="ctr"/>
-            <a:r>
-              <a:rPr sz="1200" b="1">
-                <a:solidFill>
-                  <a:srgbClr val="FFFFFF"/>
-                </a:solidFill>
-                <a:latin typeface="Microsoft JhengHei"/>
-              </a:rPr>
-              <a:t>4</a:t>
-            </a:r>
-          </a:p>
-        </p:txBody>
-      </p:sp>
-      <p:sp>
-        <p:nvSpPr>
-          <p:cNvPr id="28" name="Rectangle 27"/>
-          <p:cNvSpPr/>
-          <p:nvPr/>
-        </p:nvSpPr>
-        <p:spPr>
-          <a:xfrm>
-            <a:off x="960120" y="5376672"/>
-            <a:ext cx="2148840" cy="530352"/>
-          </a:xfrm>
-          <a:prstGeom prst="rect">
-            <a:avLst/>
-          </a:prstGeom>
-          <a:solidFill>
-            <a:srgbClr val="F3F3F3"/>
-          </a:solidFill>
-          <a:ln>
-            <a:noFill/>
-          </a:ln>
-          <a:effectLst/>
-        </p:spPr>
-        <p:style>
-          <a:lnRef idx="1">
-            <a:schemeClr val="accent1"/>
-          </a:lnRef>
-          <a:fillRef idx="3">
-            <a:schemeClr val="accent1"/>
-          </a:fillRef>
-          <a:effectRef idx="2">
-            <a:schemeClr val="accent1"/>
-          </a:effectRef>
-          <a:fontRef idx="minor">
-            <a:schemeClr val="lt1"/>
-          </a:fontRef>
-        </p:style>
-        <p:txBody>
-          <a:bodyPr rtlCol="0" anchor="ctr" wrap="square" lIns="73152" rIns="73152" tIns="73152" bIns="73152"/>
-          <a:lstStyle/>
-          <a:p>
-            <a:pPr algn="l">
-              <a:spcAft>
-                <a:spcPts val="200"/>
-              </a:spcAft>
-            </a:pPr>
-            <a:r>
-              <a:rPr sz="1150" b="1">
-                <a:solidFill>
-                  <a:srgbClr val="1E1E1E"/>
-                </a:solidFill>
-                <a:latin typeface="Microsoft JhengHei"/>
-              </a:rPr>
-              <a:t>研討會 AI 短片主題</a:t>
-            </a:r>
-          </a:p>
-        </p:txBody>
-      </p:sp>
-      <p:sp>
-        <p:nvSpPr>
-          <p:cNvPr id="29" name="Rectangle 28"/>
-          <p:cNvSpPr/>
-          <p:nvPr/>
-        </p:nvSpPr>
-        <p:spPr>
-          <a:xfrm>
-            <a:off x="3154680" y="5376672"/>
-            <a:ext cx="3886200" cy="530352"/>
-          </a:xfrm>
-          <a:prstGeom prst="rect">
-            <a:avLst/>
-          </a:prstGeom>
-          <a:solidFill>
-            <a:srgbClr val="FFE8D4"/>
-          </a:solidFill>
-          <a:ln>
-            <a:noFill/>
-          </a:ln>
-          <a:effectLst/>
-        </p:spPr>
-        <p:style>
-          <a:lnRef idx="1">
-            <a:schemeClr val="accent1"/>
-          </a:lnRef>
-          <a:fillRef idx="3">
-            <a:schemeClr val="accent1"/>
-          </a:fillRef>
-          <a:effectRef idx="2">
-            <a:schemeClr val="accent1"/>
-          </a:effectRef>
-          <a:fontRef idx="minor">
-            <a:schemeClr val="lt1"/>
-          </a:fontRef>
-        </p:style>
-        <p:txBody>
-          <a:bodyPr rtlCol="0" anchor="ctr" wrap="square" lIns="73152" rIns="73152" tIns="73152" bIns="73152"/>
-          <a:lstStyle/>
-          <a:p>
-            <a:pPr algn="l">
-              <a:spcAft>
-                <a:spcPts val="200"/>
-              </a:spcAft>
-            </a:pPr>
-            <a:r>
-              <a:rPr sz="1100" b="0">
-                <a:solidFill>
-                  <a:srgbClr val="1E1E1E"/>
-                </a:solidFill>
-                <a:latin typeface="Microsoft JhengHei"/>
-              </a:rPr>
-              <a:t>以第一波服務為主題</a:t>
-            </a:r>
-          </a:p>
-        </p:txBody>
-      </p:sp>
-      <p:sp>
-        <p:nvSpPr>
-          <p:cNvPr id="30" name="Rectangle 29"/>
-          <p:cNvSpPr/>
-          <p:nvPr/>
-        </p:nvSpPr>
-        <p:spPr>
-          <a:xfrm>
-            <a:off x="7086600" y="5376672"/>
-            <a:ext cx="822960" cy="530352"/>
-          </a:xfrm>
-          <a:prstGeom prst="rect">
-            <a:avLst/>
-          </a:prstGeom>
-          <a:solidFill>
-            <a:srgbClr val="F3F3F3"/>
-          </a:solidFill>
-          <a:ln>
-            <a:noFill/>
-          </a:ln>
-          <a:effectLst/>
-        </p:spPr>
-        <p:style>
-          <a:lnRef idx="1">
-            <a:schemeClr val="accent1"/>
-          </a:lnRef>
-          <a:fillRef idx="3">
-            <a:schemeClr val="accent1"/>
-          </a:fillRef>
-          <a:effectRef idx="2">
-            <a:schemeClr val="accent1"/>
-          </a:effectRef>
-          <a:fontRef idx="minor">
-            <a:schemeClr val="lt1"/>
-          </a:fontRef>
-        </p:style>
-        <p:txBody>
-          <a:bodyPr rtlCol="0" anchor="ctr" wrap="square" lIns="36576" rIns="36576" tIns="36576" bIns="36576"/>
-          <a:lstStyle/>
-          <a:p>
-            <a:pPr algn="ctr">
-              <a:spcAft>
-                <a:spcPts val="200"/>
-              </a:spcAft>
-            </a:pPr>
-            <a:r>
-              <a:rPr sz="1100" b="1">
-                <a:solidFill>
-                  <a:srgbClr val="FD5108"/>
-                </a:solidFill>
-                <a:latin typeface="Microsoft JhengHei"/>
-              </a:rPr>
-              <a:t>第 2 週</a:t>
-            </a:r>
-          </a:p>
-        </p:txBody>
-      </p:sp>
-      <p:sp>
-        <p:nvSpPr>
-          <p:cNvPr id="31" name="Rectangle 30"/>
-          <p:cNvSpPr/>
-          <p:nvPr/>
-        </p:nvSpPr>
-        <p:spPr>
-          <a:xfrm>
-            <a:off x="8138160" y="3108960"/>
-            <a:ext cx="3657600" cy="384048"/>
-          </a:xfrm>
-          <a:prstGeom prst="rect">
-            <a:avLst/>
-          </a:prstGeom>
-          <a:solidFill>
-            <a:srgbClr val="1E1E1E"/>
-          </a:solidFill>
-          <a:ln>
-            <a:noFill/>
-          </a:ln>
-          <a:effectLst/>
-        </p:spPr>
-        <p:style>
-          <a:lnRef idx="1">
-            <a:schemeClr val="accent1"/>
-          </a:lnRef>
-          <a:fillRef idx="3">
-            <a:schemeClr val="accent1"/>
-          </a:fillRef>
-          <a:effectRef idx="2">
-            <a:schemeClr val="accent1"/>
-          </a:effectRef>
-          <a:fontRef idx="minor">
-            <a:schemeClr val="lt1"/>
-          </a:fontRef>
-        </p:style>
-        <p:txBody>
-          <a:bodyPr rtlCol="0" anchor="ctr" wrap="square" lIns="54864" rIns="54864" tIns="54864" bIns="54864"/>
-          <a:lstStyle/>
-          <a:p>
-            <a:pPr algn="l">
-              <a:spcAft>
-                <a:spcPts val="200"/>
-              </a:spcAft>
-            </a:pPr>
-            <a:r>
-              <a:rPr sz="1300" b="1">
-                <a:solidFill>
-                  <a:srgbClr val="FFFFFF"/>
-                </a:solidFill>
-                <a:latin typeface="Microsoft JhengHei"/>
-              </a:rPr>
-              <a:t>使用前注意</a:t>
-            </a:r>
-          </a:p>
-        </p:txBody>
-      </p:sp>
-      <p:sp>
-        <p:nvSpPr>
-          <p:cNvPr id="32" name="Rectangle 31"/>
-          <p:cNvSpPr/>
-          <p:nvPr/>
-        </p:nvSpPr>
-        <p:spPr>
-          <a:xfrm>
-            <a:off x="8138160" y="3566160"/>
-            <a:ext cx="3657600" cy="530352"/>
-          </a:xfrm>
-          <a:prstGeom prst="rect">
-            <a:avLst/>
-          </a:prstGeom>
-          <a:solidFill>
-            <a:srgbClr val="F3F3F3"/>
-          </a:solidFill>
-          <a:ln>
-            <a:noFill/>
-          </a:ln>
-          <a:effectLst/>
-        </p:spPr>
-        <p:style>
-          <a:lnRef idx="1">
-            <a:schemeClr val="accent1"/>
-          </a:lnRef>
-          <a:fillRef idx="3">
-            <a:schemeClr val="accent1"/>
-          </a:fillRef>
-          <a:effectRef idx="2">
-            <a:schemeClr val="accent1"/>
-          </a:effectRef>
-          <a:fontRef idx="minor">
-            <a:schemeClr val="lt1"/>
-          </a:fontRef>
-        </p:style>
-        <p:txBody>
-          <a:bodyPr rtlCol="0" anchor="ctr" wrap="square" tIns="91440" bIns="91440"/>
-          <a:lstStyle/>
-          <a:p>
-            <a:pPr algn="l">
-              <a:spcAft>
-                <a:spcPts val="200"/>
-              </a:spcAft>
-            </a:pPr>
-            <a:r>
-              <a:rPr sz="1050" b="1">
-                <a:solidFill>
-                  <a:srgbClr val="1E1E1E"/>
-                </a:solidFill>
-                <a:latin typeface="Microsoft JhengHei"/>
-              </a:rPr>
-              <a:t>數字核對　</a:t>
-            </a:r>
-            <a:r>
-              <a:rPr sz="1050" b="0">
-                <a:solidFill>
-                  <a:srgbClr val="1E1E1E"/>
-                </a:solidFill>
-                <a:latin typeface="Microsoft JhengHei"/>
-              </a:rPr>
-              <a:t>對外引用前回原文確認；95% 為跨產業數字</a:t>
-            </a:r>
-          </a:p>
-        </p:txBody>
-      </p:sp>
-      <p:sp>
-        <p:nvSpPr>
-          <p:cNvPr id="33" name="Rectangle 32"/>
-          <p:cNvSpPr/>
-          <p:nvPr/>
-        </p:nvSpPr>
-        <p:spPr>
-          <a:xfrm>
-            <a:off x="8138160" y="4169663"/>
-            <a:ext cx="3657600" cy="530352"/>
-          </a:xfrm>
-          <a:prstGeom prst="rect">
-            <a:avLst/>
-          </a:prstGeom>
-          <a:solidFill>
-            <a:srgbClr val="F3F3F3"/>
-          </a:solidFill>
-          <a:ln>
-            <a:noFill/>
-          </a:ln>
-          <a:effectLst/>
-        </p:spPr>
-        <p:style>
-          <a:lnRef idx="1">
-            <a:schemeClr val="accent1"/>
-          </a:lnRef>
-          <a:fillRef idx="3">
-            <a:schemeClr val="accent1"/>
-          </a:fillRef>
-          <a:effectRef idx="2">
-            <a:schemeClr val="accent1"/>
-          </a:effectRef>
-          <a:fontRef idx="minor">
-            <a:schemeClr val="lt1"/>
-          </a:fontRef>
-        </p:style>
-        <p:txBody>
-          <a:bodyPr rtlCol="0" anchor="ctr" wrap="square" tIns="91440" bIns="91440"/>
-          <a:lstStyle/>
-          <a:p>
-            <a:pPr algn="l">
-              <a:spcAft>
-                <a:spcPts val="200"/>
-              </a:spcAft>
-            </a:pPr>
-            <a:r>
-              <a:rPr sz="1050" b="1">
-                <a:solidFill>
-                  <a:srgbClr val="1E1E1E"/>
-                </a:solidFill>
-                <a:latin typeface="Microsoft JhengHei"/>
-              </a:rPr>
-              <a:t>獨立性　</a:t>
-            </a:r>
-            <a:r>
-              <a:rPr sz="1050" b="0">
-                <a:solidFill>
-                  <a:srgbClr val="1E1E1E"/>
-                </a:solidFill>
-                <a:latin typeface="Microsoft JhengHei"/>
-              </a:rPr>
-              <a:t>AI 治理健檢與 IFRS 17 顧問碰到審計客戶時，先與 R&amp;Q 確認</a:t>
-            </a:r>
-          </a:p>
-        </p:txBody>
-      </p:sp>
-      <p:sp>
-        <p:nvSpPr>
-          <p:cNvPr id="34" name="Rectangle 33"/>
-          <p:cNvSpPr/>
-          <p:nvPr/>
-        </p:nvSpPr>
-        <p:spPr>
-          <a:xfrm>
-            <a:off x="8138160" y="4773168"/>
-            <a:ext cx="3657600" cy="530352"/>
-          </a:xfrm>
-          <a:prstGeom prst="rect">
-            <a:avLst/>
-          </a:prstGeom>
-          <a:solidFill>
-            <a:srgbClr val="F3F3F3"/>
-          </a:solidFill>
-          <a:ln>
-            <a:noFill/>
-          </a:ln>
-          <a:effectLst/>
-        </p:spPr>
-        <p:style>
-          <a:lnRef idx="1">
-            <a:schemeClr val="accent1"/>
-          </a:lnRef>
-          <a:fillRef idx="3">
-            <a:schemeClr val="accent1"/>
-          </a:fillRef>
-          <a:effectRef idx="2">
-            <a:schemeClr val="accent1"/>
-          </a:effectRef>
-          <a:fontRef idx="minor">
-            <a:schemeClr val="lt1"/>
-          </a:fontRef>
-        </p:style>
-        <p:txBody>
-          <a:bodyPr rtlCol="0" anchor="ctr" wrap="square" tIns="91440" bIns="91440"/>
-          <a:lstStyle/>
-          <a:p>
-            <a:pPr algn="l">
-              <a:spcAft>
-                <a:spcPts val="200"/>
-              </a:spcAft>
-            </a:pPr>
-            <a:r>
-              <a:rPr sz="1050" b="1">
-                <a:solidFill>
-                  <a:srgbClr val="1E1E1E"/>
-                </a:solidFill>
-                <a:latin typeface="Microsoft JhengHei"/>
-              </a:rPr>
-              <a:t>對外不點名　</a:t>
-            </a:r>
-            <a:r>
-              <a:rPr sz="1050" b="0">
-                <a:solidFill>
-                  <a:srgbClr val="1E1E1E"/>
-                </a:solidFill>
-                <a:latin typeface="Microsoft JhengHei"/>
-              </a:rPr>
-              <a:t>研究中的同業與競爭者僅供內部討論</a:t>
-            </a:r>
-          </a:p>
-        </p:txBody>
-      </p:sp>
-      <p:sp>
-        <p:nvSpPr>
-          <p:cNvPr id="35" name="Rectangle 34"/>
-          <p:cNvSpPr/>
-          <p:nvPr/>
-        </p:nvSpPr>
-        <p:spPr>
-          <a:xfrm>
-            <a:off x="8138160" y="5376672"/>
-            <a:ext cx="3657600" cy="530352"/>
-          </a:xfrm>
-          <a:prstGeom prst="rect">
-            <a:avLst/>
-          </a:prstGeom>
-          <a:solidFill>
-            <a:srgbClr val="F3F3F3"/>
-          </a:solidFill>
-          <a:ln>
-            <a:noFill/>
-          </a:ln>
-          <a:effectLst/>
-        </p:spPr>
-        <p:style>
-          <a:lnRef idx="1">
-            <a:schemeClr val="accent1"/>
-          </a:lnRef>
-          <a:fillRef idx="3">
-            <a:schemeClr val="accent1"/>
-          </a:fillRef>
-          <a:effectRef idx="2">
-            <a:schemeClr val="accent1"/>
-          </a:effectRef>
-          <a:fontRef idx="minor">
-            <a:schemeClr val="lt1"/>
-          </a:fontRef>
-        </p:style>
-        <p:txBody>
-          <a:bodyPr rtlCol="0" anchor="ctr" wrap="square" tIns="91440" bIns="91440"/>
-          <a:lstStyle/>
-          <a:p>
-            <a:pPr algn="l">
-              <a:spcAft>
-                <a:spcPts val="200"/>
-              </a:spcAft>
-            </a:pPr>
-            <a:r>
-              <a:rPr sz="1050" b="1">
-                <a:solidFill>
-                  <a:srgbClr val="1E1E1E"/>
-                </a:solidFill>
-                <a:latin typeface="Microsoft JhengHei"/>
-              </a:rPr>
-              <a:t>完整版　</a:t>
-            </a:r>
-            <a:r>
-              <a:rPr sz="1050" b="0">
-                <a:solidFill>
-                  <a:srgbClr val="1E1E1E"/>
-                </a:solidFill>
-                <a:latin typeface="Microsoft JhengHei"/>
-              </a:rPr>
-              <a:t>24 頁會議簡報含問題樹、矩陣與風險</a:t>
-            </a:r>
-          </a:p>
-        </p:txBody>
-      </p:sp>
-      <p:sp>
-        <p:nvSpPr>
-          <p:cNvPr id="36" name="Rectangle 35"/>
-          <p:cNvSpPr/>
-          <p:nvPr/>
-        </p:nvSpPr>
-        <p:spPr>
-          <a:xfrm>
-            <a:off x="411480" y="6053328"/>
-            <a:ext cx="11384280" cy="384048"/>
-          </a:xfrm>
-          <a:prstGeom prst="rect">
-            <a:avLst/>
-          </a:prstGeom>
-          <a:noFill/>
-          <a:ln>
-            <a:noFill/>
-          </a:ln>
-          <a:effectLst/>
-        </p:spPr>
-        <p:style>
-          <a:lnRef idx="1">
-            <a:schemeClr val="accent1"/>
-          </a:lnRef>
-          <a:fillRef idx="3">
-            <a:schemeClr val="accent1"/>
-          </a:fillRef>
-          <a:effectRef idx="2">
-            <a:schemeClr val="accent1"/>
-          </a:effectRef>
-          <a:fontRef idx="minor">
-            <a:schemeClr val="lt1"/>
-          </a:fontRef>
-        </p:style>
-        <p:txBody>
-          <a:bodyPr rtlCol="0" anchor="t" wrap="square" lIns="27432" rIns="27432" tIns="27432" bIns="27432"/>
-          <a:lstStyle/>
-          <a:p>
-            <a:pPr algn="l">
-              <a:spcAft>
-                <a:spcPts val="200"/>
-              </a:spcAft>
-            </a:pPr>
-            <a:r>
-              <a:rPr sz="900" b="1">
-                <a:solidFill>
-                  <a:srgbClr val="6B6B6B"/>
-                </a:solidFill>
-                <a:latin typeface="Microsoft JhengHei"/>
-              </a:rPr>
-              <a:t>來源：</a:t>
-            </a:r>
-            <a:r>
-              <a:rPr sz="900" b="0" u="sng">
-                <a:solidFill>
-                  <a:srgbClr val="1F5FBF"/>
-                </a:solidFill>
-                <a:latin typeface="Microsoft JhengHei"/>
-                <a:hlinkClick r:id="rId2"/>
-              </a:rPr>
-              <a:t>McKinsey：代理型 AI 核心現代化</a:t>
-            </a:r>
-            <a:r>
-              <a:rPr sz="900" b="0">
-                <a:solidFill>
-                  <a:srgbClr val="6B6B6B"/>
-                </a:solidFill>
-                <a:latin typeface="Microsoft JhengHei"/>
-              </a:rPr>
-              <a:t>　</a:t>
-            </a:r>
-            <a:r>
-              <a:rPr sz="900" b="0" u="sng">
-                <a:solidFill>
-                  <a:srgbClr val="1F5FBF"/>
-                </a:solidFill>
-                <a:latin typeface="Microsoft JhengHei"/>
-                <a:hlinkClick r:id="rId3"/>
-              </a:rPr>
-              <a:t>Deloitte：亞太壽險規模化代理型 AI</a:t>
-            </a:r>
-            <a:r>
-              <a:rPr sz="900" b="0">
-                <a:solidFill>
-                  <a:srgbClr val="6B6B6B"/>
-                </a:solidFill>
-                <a:latin typeface="Microsoft JhengHei"/>
-              </a:rPr>
-              <a:t>　</a:t>
-            </a:r>
-            <a:r>
-              <a:rPr sz="900" b="0" u="sng">
-                <a:solidFill>
-                  <a:srgbClr val="1F5FBF"/>
-                </a:solidFill>
-                <a:latin typeface="Microsoft JhengHei"/>
-                <a:hlinkClick r:id="rId4"/>
-              </a:rPr>
-              <a:t>資誠 IFRS 17 關鍵議題</a:t>
-            </a:r>
-            <a:r>
-              <a:rPr sz="900" b="0">
-                <a:solidFill>
-                  <a:srgbClr val="6B6B6B"/>
-                </a:solidFill>
-                <a:latin typeface="Microsoft JhengHei"/>
-              </a:rPr>
-              <a:t>　</a:t>
-            </a:r>
-            <a:r>
-              <a:rPr sz="900" b="0" u="sng">
-                <a:solidFill>
-                  <a:srgbClr val="1F5FBF"/>
-                </a:solidFill>
-                <a:latin typeface="Microsoft JhengHei"/>
-                <a:hlinkClick r:id="rId5"/>
-              </a:rPr>
-              <a:t>MAS AI 風險管理指引</a:t>
             </a:r>
           </a:p>
         </p:txBody>

</xml_diff>

<commit_message>
Match insurtech decks to firm template fonts, colors and layout
Use the template theme fonts (Georgia titles, Arial body, Microsoft JhengHei
for Chinese), theme text and fill colors, the plain title-only layout, and
copy footer and slide-number placeholders from the layout.

Co-Authored-By: Claude Opus 5.5 <noreply@anthropic.com>
Claude-Session: https://claude.ai/code/session_01GwCwwmQUjvhTXeuyRaxofg
</commit_message>
<xml_diff>
--- a/research/insurtech-2026/保險科技服務優先順序_主管精簡版.pptx
+++ b/research/insurtech-2026/保險科技服務優先順序_主管精簡版.pptx
@@ -42222,8 +42222,9 @@
           <a:lstStyle/>
           <a:p>
             <a:r>
-              <a:rPr sz="2000">
-                <a:latin typeface="Microsoft JhengHei"/>
+              <a:rPr sz="2000" b="1">
+                <a:latin typeface="Georgia"/>
+                <a:ea typeface="微軟正黑體"/>
               </a:rPr>
               <a:t>重點摘要：保險 AI 已進入規模化，建議第一波先推 IFRS 17 與 AI 治理兩項服務包</a:t>
             </a:r>
@@ -42232,7 +42233,108 @@
       </p:sp>
       <p:sp>
         <p:nvSpPr>
-          <p:cNvPr id="3" name="Rectangle 2"/>
+          <p:cNvPr id="4" name="Footer Placeholder 4">
+            <a:extLst>
+              <a:ext uri="{FF2B5EF4-FFF2-40B4-BE49-F238E27FC236}">
+                <a16:creationId xmlns:a16="http://schemas.microsoft.com/office/drawing/2014/main" id="{E57B29C1-93EA-1886-CD27-23CE023225D9}"/>
+              </a:ext>
+            </a:extLst>
+          </p:cNvPr>
+          <p:cNvSpPr>
+            <a:spLocks noGrp="1"/>
+          </p:cNvSpPr>
+          <p:nvPr>
+            <p:ph type="ftr" sz="quarter" idx="3"/>
+          </p:nvPr>
+        </p:nvSpPr>
+        <p:spPr>
+          <a:xfrm>
+            <a:off x="1066800" y="6497441"/>
+            <a:ext cx="8814816" cy="161583"/>
+          </a:xfrm>
+          <a:prstGeom prst="rect">
+            <a:avLst/>
+          </a:prstGeom>
+        </p:spPr>
+        <p:txBody>
+          <a:bodyPr vert="horz" wrap="square" lIns="0" tIns="0" rIns="0" bIns="0" rtlCol="0" anchor="b" anchorCtr="0">
+            <a:spAutoFit/>
+          </a:bodyPr>
+          <a:lstStyle>
+            <a:lvl1pPr algn="l">
+              <a:defRPr sz="1050" b="0">
+                <a:solidFill>
+                  <a:sysClr val="windowText" lastClr="000000"/>
+                </a:solidFill>
+                <a:latin typeface="+mn-lt"/>
+                <a:cs typeface="Arial" panose="020B0604020202020204" pitchFamily="34" charset="0"/>
+              </a:defRPr>
+            </a:lvl1pPr>
+          </a:lstStyle>
+          <a:p>
+            <a:r>
+              <a:rPr>
+                <a:latin typeface="Arial"/>
+                <a:ea typeface="微軟正黑體"/>
+              </a:rPr>
+              <a:t>內部討論稿｜僅供 FSC1 保險組內部使用｜資料來源為公開研究，點選來源可開啟原文</a:t>
+            </a:r>
+          </a:p>
+        </p:txBody>
+      </p:sp>
+      <p:sp>
+        <p:nvSpPr>
+          <p:cNvPr id="6" name="Slide Number Placeholder 13">
+            <a:extLst>
+              <a:ext uri="{FF2B5EF4-FFF2-40B4-BE49-F238E27FC236}">
+                <a16:creationId xmlns:a16="http://schemas.microsoft.com/office/drawing/2014/main" id="{D15FEAD4-DFB9-ED08-EBEE-A4E5DE31E318}"/>
+              </a:ext>
+            </a:extLst>
+          </p:cNvPr>
+          <p:cNvSpPr>
+            <a:spLocks noGrp="1"/>
+          </p:cNvSpPr>
+          <p:nvPr>
+            <p:ph type="sldNum" sz="quarter" idx="4"/>
+          </p:nvPr>
+        </p:nvSpPr>
+        <p:spPr>
+          <a:xfrm>
+            <a:off x="11503818" y="6501384"/>
+            <a:ext cx="298209" cy="161583"/>
+          </a:xfrm>
+          <a:prstGeom prst="rect">
+            <a:avLst/>
+          </a:prstGeom>
+        </p:spPr>
+        <p:txBody>
+          <a:bodyPr vert="horz" wrap="square" lIns="0" tIns="0" rIns="0" bIns="0" rtlCol="0" anchor="b" anchorCtr="0">
+            <a:spAutoFit/>
+          </a:bodyPr>
+          <a:lstStyle>
+            <a:lvl1pPr algn="r">
+              <a:defRPr sz="1050">
+                <a:solidFill>
+                  <a:schemeClr val="tx1"/>
+                </a:solidFill>
+                <a:latin typeface="+mn-lt"/>
+                <a:cs typeface="Arial" panose="020B0604020202020204" pitchFamily="34" charset="0"/>
+              </a:defRPr>
+            </a:lvl1pPr>
+          </a:lstStyle>
+          <a:p>
+            <a:fld id="{3E6AC032-1535-134B-A583-D5E1DDD0D167}" type="slidenum">
+              <a:rPr lang="en-US" smtClean="0"/>
+              <a:pPr/>
+              <a:t>‹#›</a:t>
+            </a:fld>
+            <a:endParaRPr lang="en-US"/>
+          </a:p>
+        </p:txBody>
+      </p:sp>
+      <p:sp>
+        <p:nvSpPr>
+          <p:cNvPr id="7" name="Rectangle 6"/>
           <p:cNvSpPr/>
           <p:nvPr/>
         </p:nvSpPr>
@@ -42245,7 +42347,7 @@
             <a:avLst/>
           </a:prstGeom>
           <a:solidFill>
-            <a:srgbClr val="F3F3F3"/>
+            <a:srgbClr val="EBEBEB"/>
           </a:solidFill>
           <a:ln>
             <a:noFill/>
@@ -42278,9 +42380,10 @@
             <a:r>
               <a:rPr sz="1100" b="0">
                 <a:solidFill>
-                  <a:srgbClr val="1E1E1E"/>
+                  <a:srgbClr val="000000"/>
                 </a:solidFill>
-                <a:latin typeface="Microsoft JhengHei"/>
+                <a:latin typeface="Arial"/>
+                <a:ea typeface="微軟正黑體"/>
               </a:rPr>
               <a:t/>
             </a:r>
@@ -42289,7 +42392,7 @@
       </p:sp>
       <p:sp>
         <p:nvSpPr>
-          <p:cNvPr id="4" name="Rectangle 3"/>
+          <p:cNvPr id="8" name="Rectangle 7"/>
           <p:cNvSpPr/>
           <p:nvPr/>
         </p:nvSpPr>
@@ -42331,11 +42434,12 @@
               </a:spcAft>
             </a:pPr>
             <a:r>
-              <a:rPr sz="3000" b="1">
+              <a:rPr sz="3200" b="0">
                 <a:solidFill>
                   <a:srgbClr val="FD5108"/>
                 </a:solidFill>
-                <a:latin typeface="Microsoft JhengHei"/>
+                <a:latin typeface="Arial"/>
+                <a:ea typeface="微軟正黑體"/>
               </a:rPr>
               <a:t>95.2%</a:t>
             </a:r>
@@ -42344,7 +42448,7 @@
       </p:sp>
       <p:sp>
         <p:nvSpPr>
-          <p:cNvPr id="5" name="Rectangle 4"/>
+          <p:cNvPr id="9" name="Rectangle 8"/>
           <p:cNvSpPr/>
           <p:nvPr/>
         </p:nvSpPr>
@@ -42388,9 +42492,10 @@
             <a:r>
               <a:rPr sz="1100" b="0">
                 <a:solidFill>
-                  <a:srgbClr val="1E1E1E"/>
+                  <a:srgbClr val="000000"/>
                 </a:solidFill>
-                <a:latin typeface="Microsoft JhengHei"/>
+                <a:latin typeface="Arial"/>
+                <a:ea typeface="微軟正黑體"/>
               </a:rPr>
               <a:t>2026 Q1 全球保險科技募資流向 AI 企業的比例（歷史新高）</a:t>
             </a:r>
@@ -42399,7 +42504,7 @@
       </p:sp>
       <p:sp>
         <p:nvSpPr>
-          <p:cNvPr id="6" name="Rectangle 5"/>
+          <p:cNvPr id="10" name="Rectangle 9"/>
           <p:cNvSpPr/>
           <p:nvPr/>
         </p:nvSpPr>
@@ -42443,9 +42548,10 @@
             <a:r>
               <a:rPr sz="900" b="0" u="sng">
                 <a:solidFill>
-                  <a:srgbClr val="1F5FBF"/>
+                  <a:srgbClr val="000000"/>
                 </a:solidFill>
-                <a:latin typeface="Microsoft JhengHei"/>
+                <a:latin typeface="Arial"/>
+                <a:ea typeface="微軟正黑體"/>
                 <a:hlinkClick r:id="rId2"/>
               </a:rPr>
               <a:t>Gallagher Re, 2026-05</a:t>
@@ -42455,7 +42561,7 @@
       </p:sp>
       <p:sp>
         <p:nvSpPr>
-          <p:cNvPr id="7" name="Rectangle 6"/>
+          <p:cNvPr id="11" name="Rectangle 10"/>
           <p:cNvSpPr/>
           <p:nvPr/>
         </p:nvSpPr>
@@ -42468,7 +42574,7 @@
             <a:avLst/>
           </a:prstGeom>
           <a:solidFill>
-            <a:srgbClr val="F3F3F3"/>
+            <a:srgbClr val="EBEBEB"/>
           </a:solidFill>
           <a:ln>
             <a:noFill/>
@@ -42501,9 +42607,10 @@
             <a:r>
               <a:rPr sz="1100" b="0">
                 <a:solidFill>
-                  <a:srgbClr val="1E1E1E"/>
+                  <a:srgbClr val="000000"/>
                 </a:solidFill>
-                <a:latin typeface="Microsoft JhengHei"/>
+                <a:latin typeface="Arial"/>
+                <a:ea typeface="微軟正黑體"/>
               </a:rPr>
               <a:t/>
             </a:r>
@@ -42512,7 +42619,7 @@
       </p:sp>
       <p:sp>
         <p:nvSpPr>
-          <p:cNvPr id="8" name="Rectangle 7"/>
+          <p:cNvPr id="12" name="Rectangle 11"/>
           <p:cNvSpPr/>
           <p:nvPr/>
         </p:nvSpPr>
@@ -42554,11 +42661,12 @@
               </a:spcAft>
             </a:pPr>
             <a:r>
-              <a:rPr sz="3000" b="1">
+              <a:rPr sz="3200" b="0">
                 <a:solidFill>
                   <a:srgbClr val="FD5108"/>
                 </a:solidFill>
-                <a:latin typeface="Microsoft JhengHei"/>
+                <a:latin typeface="Arial"/>
+                <a:ea typeface="微軟正黑體"/>
               </a:rPr>
               <a:t>57%</a:t>
             </a:r>
@@ -42567,7 +42675,7 @@
       </p:sp>
       <p:sp>
         <p:nvSpPr>
-          <p:cNvPr id="9" name="Rectangle 8"/>
+          <p:cNvPr id="13" name="Rectangle 12"/>
           <p:cNvSpPr/>
           <p:nvPr/>
         </p:nvSpPr>
@@ -42611,9 +42719,10 @@
             <a:r>
               <a:rPr sz="1100" b="0">
                 <a:solidFill>
-                  <a:srgbClr val="1E1E1E"/>
+                  <a:srgbClr val="000000"/>
                 </a:solidFill>
-                <a:latin typeface="Microsoft JhengHei"/>
+                <a:latin typeface="Arial"/>
+                <a:ea typeface="微軟正黑體"/>
               </a:rPr>
               <a:t>保險高階主管把生成式與代理型 AI 列為 2026 首要科技投資</a:t>
             </a:r>
@@ -42622,7 +42731,7 @@
       </p:sp>
       <p:sp>
         <p:nvSpPr>
-          <p:cNvPr id="10" name="Rectangle 9"/>
+          <p:cNvPr id="14" name="Rectangle 13"/>
           <p:cNvSpPr/>
           <p:nvPr/>
         </p:nvSpPr>
@@ -42666,9 +42775,10 @@
             <a:r>
               <a:rPr sz="900" b="0" u="sng">
                 <a:solidFill>
-                  <a:srgbClr val="1F5FBF"/>
+                  <a:srgbClr val="000000"/>
                 </a:solidFill>
-                <a:latin typeface="Microsoft JhengHei"/>
+                <a:latin typeface="Arial"/>
+                <a:ea typeface="微軟正黑體"/>
                 <a:hlinkClick r:id="rId3"/>
               </a:rPr>
               <a:t>PwC 調查, 2025-11</a:t>
@@ -42678,7 +42788,7 @@
       </p:sp>
       <p:sp>
         <p:nvSpPr>
-          <p:cNvPr id="11" name="Rectangle 10"/>
+          <p:cNvPr id="15" name="Rectangle 14"/>
           <p:cNvSpPr/>
           <p:nvPr/>
         </p:nvSpPr>
@@ -42724,9 +42834,10 @@
             <a:r>
               <a:rPr sz="1100" b="0">
                 <a:solidFill>
-                  <a:srgbClr val="1E1E1E"/>
+                  <a:srgbClr val="000000"/>
                 </a:solidFill>
-                <a:latin typeface="Microsoft JhengHei"/>
+                <a:latin typeface="Arial"/>
+                <a:ea typeface="微軟正黑體"/>
               </a:rPr>
               <a:t/>
             </a:r>
@@ -42735,7 +42846,7 @@
       </p:sp>
       <p:sp>
         <p:nvSpPr>
-          <p:cNvPr id="12" name="Rectangle 11"/>
+          <p:cNvPr id="16" name="Rectangle 15"/>
           <p:cNvSpPr/>
           <p:nvPr/>
         </p:nvSpPr>
@@ -42777,11 +42888,12 @@
               </a:spcAft>
             </a:pPr>
             <a:r>
-              <a:rPr sz="3000" b="1">
+              <a:rPr sz="3200" b="0">
                 <a:solidFill>
                   <a:srgbClr val="FFFFFF"/>
                 </a:solidFill>
-                <a:latin typeface="Microsoft JhengHei"/>
+                <a:latin typeface="Arial"/>
+                <a:ea typeface="微軟正黑體"/>
               </a:rPr>
               <a:t>95%</a:t>
             </a:r>
@@ -42790,7 +42902,7 @@
       </p:sp>
       <p:sp>
         <p:nvSpPr>
-          <p:cNvPr id="13" name="Rectangle 12"/>
+          <p:cNvPr id="17" name="Rectangle 16"/>
           <p:cNvSpPr/>
           <p:nvPr/>
         </p:nvSpPr>
@@ -42836,7 +42948,8 @@
                 <a:solidFill>
                   <a:srgbClr val="FFFFFF"/>
                 </a:solidFill>
-                <a:latin typeface="Microsoft JhengHei"/>
+                <a:latin typeface="Arial"/>
+                <a:ea typeface="微軟正黑體"/>
               </a:rPr>
               <a:t>投資 AI 但尚未看到可衡量回報的企業（跨產業）</a:t>
             </a:r>
@@ -42845,7 +42958,7 @@
       </p:sp>
       <p:sp>
         <p:nvSpPr>
-          <p:cNvPr id="14" name="Rectangle 13"/>
+          <p:cNvPr id="18" name="Rectangle 17"/>
           <p:cNvSpPr/>
           <p:nvPr/>
         </p:nvSpPr>
@@ -42891,7 +43004,8 @@
                 <a:solidFill>
                   <a:srgbClr val="FFFFFF"/>
                 </a:solidFill>
-                <a:latin typeface="Microsoft JhengHei"/>
+                <a:latin typeface="Arial"/>
+                <a:ea typeface="微軟正黑體"/>
                 <a:hlinkClick r:id="rId4"/>
               </a:rPr>
               <a:t>Bain 引述 MIT</a:t>
@@ -42901,7 +43015,7 @@
       </p:sp>
       <p:sp>
         <p:nvSpPr>
-          <p:cNvPr id="15" name="Rectangle 14"/>
+          <p:cNvPr id="19" name="Rectangle 18"/>
           <p:cNvSpPr/>
           <p:nvPr/>
         </p:nvSpPr>
@@ -42914,7 +43028,7 @@
             <a:avLst/>
           </a:prstGeom>
           <a:solidFill>
-            <a:srgbClr val="F3F3F3"/>
+            <a:srgbClr val="EBEBEB"/>
           </a:solidFill>
           <a:ln>
             <a:noFill/>
@@ -42949,16 +43063,18 @@
                 <a:solidFill>
                   <a:srgbClr val="FD5108"/>
                 </a:solidFill>
-                <a:latin typeface="Microsoft JhengHei"/>
+                <a:latin typeface="Arial"/>
+                <a:ea typeface="微軟正黑體"/>
               </a:rPr>
               <a:t>情境　</a:t>
             </a:r>
             <a:r>
               <a:rPr sz="1200" b="0">
                 <a:solidFill>
-                  <a:srgbClr val="1E1E1E"/>
+                  <a:srgbClr val="000000"/>
                 </a:solidFill>
-                <a:latin typeface="Microsoft JhengHei"/>
+                <a:latin typeface="Arial"/>
+                <a:ea typeface="微軟正黑體"/>
               </a:rPr>
               <a:t>資金與預算全面轉向 AI，保險業已從試點走向規模化。</a:t>
             </a:r>
@@ -42974,16 +43090,18 @@
                 <a:solidFill>
                   <a:srgbClr val="FD5108"/>
                 </a:solidFill>
-                <a:latin typeface="Microsoft JhengHei"/>
+                <a:latin typeface="Arial"/>
+                <a:ea typeface="微軟正黑體"/>
               </a:rPr>
               <a:t>衝突　</a:t>
             </a:r>
             <a:r>
               <a:rPr sz="1200" b="0">
                 <a:solidFill>
-                  <a:srgbClr val="1E1E1E"/>
+                  <a:srgbClr val="000000"/>
                 </a:solidFill>
-                <a:latin typeface="Microsoft JhengHei"/>
+                <a:latin typeface="Arial"/>
+                <a:ea typeface="微軟正黑體"/>
               </a:rPr>
               <a:t>多數投資還看不到回報；台灣同時面對 IFRS 17／TW-ICS 首年出表與 AI 治理要求。</a:t>
             </a:r>
@@ -42992,7 +43110,7 @@
       </p:sp>
       <p:sp>
         <p:nvSpPr>
-          <p:cNvPr id="16" name="Rectangle 15"/>
+          <p:cNvPr id="20" name="Rectangle 19"/>
           <p:cNvSpPr/>
           <p:nvPr/>
         </p:nvSpPr>
@@ -43040,7 +43158,8 @@
                 <a:solidFill>
                   <a:srgbClr val="FFFFFF"/>
                 </a:solidFill>
-                <a:latin typeface="Microsoft JhengHei"/>
+                <a:latin typeface="Arial"/>
+                <a:ea typeface="微軟正黑體"/>
               </a:rPr>
               <a:t>建議　</a:t>
             </a:r>
@@ -43049,7 +43168,8 @@
                 <a:solidFill>
                   <a:srgbClr val="FFFFFF"/>
                 </a:solidFill>
-                <a:latin typeface="Microsoft JhengHei"/>
+                <a:latin typeface="微軟正黑體"/>
+                <a:ea typeface="微軟正黑體"/>
               </a:rPr>
               <a:t>第一波先推 ① IFRS 17／TW-ICS 後財務轉型　② AI 清冊、模型驗證與護欄；代理型 AI 核保理賠、核心現代化、深偽反詐欺列為第二波。</a:t>
             </a:r>
@@ -43058,7 +43178,7 @@
       </p:sp>
       <p:sp>
         <p:nvSpPr>
-          <p:cNvPr id="17" name="Rectangle 16"/>
+          <p:cNvPr id="21" name="Rectangle 20"/>
           <p:cNvSpPr/>
           <p:nvPr/>
         </p:nvSpPr>
@@ -43106,7 +43226,8 @@
                 <a:solidFill>
                   <a:srgbClr val="FD5108"/>
                 </a:solidFill>
-                <a:latin typeface="Microsoft JhengHei"/>
+                <a:latin typeface="Arial"/>
+                <a:ea typeface="微軟正黑體"/>
               </a:rPr>
               <a:t>需求有時限</a:t>
             </a:r>
@@ -43115,7 +43236,7 @@
       </p:sp>
       <p:sp>
         <p:nvSpPr>
-          <p:cNvPr id="18" name="Rectangle 17"/>
+          <p:cNvPr id="22" name="Rectangle 21"/>
           <p:cNvSpPr/>
           <p:nvPr/>
         </p:nvSpPr>
@@ -43128,7 +43249,7 @@
             <a:avLst/>
           </a:prstGeom>
           <a:solidFill>
-            <a:srgbClr val="F3F3F3"/>
+            <a:srgbClr val="EBEBEB"/>
           </a:solidFill>
           <a:ln>
             <a:noFill/>
@@ -43161,9 +43282,10 @@
             <a:r>
               <a:rPr sz="1100" b="0">
                 <a:solidFill>
-                  <a:srgbClr val="1E1E1E"/>
+                  <a:srgbClr val="000000"/>
                 </a:solidFill>
-                <a:latin typeface="Microsoft JhengHei"/>
+                <a:latin typeface="Arial"/>
+                <a:ea typeface="微軟正黑體"/>
               </a:rPr>
               <a:t>IFRS 17／TW-ICS 2026-01-01 接軌；委外新辦法 2025-12-31 施行；AI 指引進入落地</a:t>
             </a:r>
@@ -43172,7 +43294,7 @@
       </p:sp>
       <p:sp>
         <p:nvSpPr>
-          <p:cNvPr id="19" name="Rectangle 18"/>
+          <p:cNvPr id="23" name="Rectangle 22"/>
           <p:cNvSpPr/>
           <p:nvPr/>
         </p:nvSpPr>
@@ -43220,7 +43342,8 @@
                 <a:solidFill>
                   <a:srgbClr val="FD5108"/>
                 </a:solidFill>
-                <a:latin typeface="Microsoft JhengHei"/>
+                <a:latin typeface="Arial"/>
+                <a:ea typeface="微軟正黑體"/>
               </a:rPr>
               <a:t>離既有服務最近</a:t>
             </a:r>
@@ -43229,7 +43352,7 @@
       </p:sp>
       <p:sp>
         <p:nvSpPr>
-          <p:cNvPr id="20" name="Rectangle 19"/>
+          <p:cNvPr id="24" name="Rectangle 23"/>
           <p:cNvSpPr/>
           <p:nvPr/>
         </p:nvSpPr>
@@ -43242,7 +43365,7 @@
             <a:avLst/>
           </a:prstGeom>
           <a:solidFill>
-            <a:srgbClr val="F3F3F3"/>
+            <a:srgbClr val="EBEBEB"/>
           </a:solidFill>
           <a:ln>
             <a:noFill/>
@@ -43275,9 +43398,10 @@
             <a:r>
               <a:rPr sz="1100" b="0">
                 <a:solidFill>
-                  <a:srgbClr val="1E1E1E"/>
+                  <a:srgbClr val="000000"/>
                 </a:solidFill>
-                <a:latin typeface="Microsoft JhengHei"/>
+                <a:latin typeface="Arial"/>
+                <a:ea typeface="微軟正黑體"/>
               </a:rPr>
               <a:t>延伸既有駐點團隊與 AI 治理服務，不需新技術夥伴；AI 治理健檢 4–6 週可交付</a:t>
             </a:r>
@@ -43286,7 +43410,7 @@
       </p:sp>
       <p:sp>
         <p:nvSpPr>
-          <p:cNvPr id="21" name="Rectangle 20"/>
+          <p:cNvPr id="25" name="Rectangle 24"/>
           <p:cNvSpPr/>
           <p:nvPr/>
         </p:nvSpPr>
@@ -43334,7 +43458,8 @@
                 <a:solidFill>
                   <a:srgbClr val="FD5108"/>
                 </a:solidFill>
-                <a:latin typeface="Microsoft JhengHei"/>
+                <a:latin typeface="Arial"/>
+                <a:ea typeface="微軟正黑體"/>
               </a:rPr>
               <a:t>能帶出第二波</a:t>
             </a:r>
@@ -43343,7 +43468,7 @@
       </p:sp>
       <p:sp>
         <p:nvSpPr>
-          <p:cNvPr id="22" name="Rectangle 21"/>
+          <p:cNvPr id="26" name="Rectangle 25"/>
           <p:cNvSpPr/>
           <p:nvPr/>
         </p:nvSpPr>
@@ -43356,7 +43481,7 @@
             <a:avLst/>
           </a:prstGeom>
           <a:solidFill>
-            <a:srgbClr val="F3F3F3"/>
+            <a:srgbClr val="EBEBEB"/>
           </a:solidFill>
           <a:ln>
             <a:noFill/>
@@ -43389,9 +43514,10 @@
             <a:r>
               <a:rPr sz="1100" b="0">
                 <a:solidFill>
-                  <a:srgbClr val="1E1E1E"/>
+                  <a:srgbClr val="000000"/>
                 </a:solidFill>
-                <a:latin typeface="Microsoft JhengHei"/>
+                <a:latin typeface="Arial"/>
+                <a:ea typeface="微軟正黑體"/>
               </a:rPr>
               <a:t>財務資料與 AI 治理是代理型 AI、核心現代化的前置條件，可延伸為 1–3 年人力委外</a:t>
             </a:r>
@@ -43400,7 +43526,7 @@
       </p:sp>
       <p:sp>
         <p:nvSpPr>
-          <p:cNvPr id="23" name="Rectangle 22"/>
+          <p:cNvPr id="27" name="Rectangle 26"/>
           <p:cNvSpPr/>
           <p:nvPr/>
         </p:nvSpPr>
@@ -43448,16 +43574,18 @@
                 <a:solidFill>
                   <a:srgbClr val="FD5108"/>
                 </a:solidFill>
-                <a:latin typeface="Microsoft JhengHei"/>
+                <a:latin typeface="Arial"/>
+                <a:ea typeface="微軟正黑體"/>
               </a:rPr>
               <a:t>今天請決定：</a:t>
             </a:r>
             <a:r>
               <a:rPr sz="1200" b="0">
                 <a:solidFill>
-                  <a:srgbClr val="1E1E1E"/>
+                  <a:srgbClr val="000000"/>
                 </a:solidFill>
-                <a:latin typeface="Microsoft JhengHei"/>
+                <a:latin typeface="Arial"/>
+                <a:ea typeface="微軟正黑體"/>
               </a:rPr>
               <a:t>同意第一波兩項服務，並各指派 1 位負責人。</a:t>
             </a:r>
@@ -43466,7 +43594,7 @@
       </p:sp>
       <p:sp>
         <p:nvSpPr>
-          <p:cNvPr id="24" name="Rectangle 23"/>
+          <p:cNvPr id="28" name="Rectangle 27"/>
           <p:cNvSpPr/>
           <p:nvPr/>
         </p:nvSpPr>
@@ -43510,18 +43638,20 @@
             <a:r>
               <a:rPr sz="900" b="1">
                 <a:solidFill>
-                  <a:srgbClr val="6B6B6B"/>
+                  <a:srgbClr val="595959"/>
                 </a:solidFill>
-                <a:latin typeface="Microsoft JhengHei"/>
+                <a:latin typeface="Arial"/>
+                <a:ea typeface="微軟正黑體"/>
               </a:rPr>
               <a:t>來源：</a:t>
             </a:r>
             <a:r>
               <a:rPr sz="900" b="0" u="sng">
                 <a:solidFill>
-                  <a:srgbClr val="1F5FBF"/>
+                  <a:srgbClr val="595959"/>
                 </a:solidFill>
-                <a:latin typeface="Microsoft JhengHei"/>
+                <a:latin typeface="Arial"/>
+                <a:ea typeface="微軟正黑體"/>
                 <a:hlinkClick r:id="rId2"/>
               </a:rPr>
               <a:t>Gallagher Re Global InsurTech Report Q1 2026</a:t>
@@ -43529,18 +43659,20 @@
             <a:r>
               <a:rPr sz="900" b="0">
                 <a:solidFill>
-                  <a:srgbClr val="6B6B6B"/>
+                  <a:srgbClr val="595959"/>
                 </a:solidFill>
-                <a:latin typeface="Microsoft JhengHei"/>
+                <a:latin typeface="Arial"/>
+                <a:ea typeface="微軟正黑體"/>
               </a:rPr>
               <a:t>　</a:t>
             </a:r>
             <a:r>
               <a:rPr sz="900" b="0" u="sng">
                 <a:solidFill>
-                  <a:srgbClr val="1F5FBF"/>
+                  <a:srgbClr val="595959"/>
                 </a:solidFill>
-                <a:latin typeface="Microsoft JhengHei"/>
+                <a:latin typeface="Arial"/>
+                <a:ea typeface="微軟正黑體"/>
                 <a:hlinkClick r:id="rId5"/>
               </a:rPr>
               <a:t>Insurance Business 報導（95.2%）</a:t>
@@ -43548,18 +43680,20 @@
             <a:r>
               <a:rPr sz="900" b="0">
                 <a:solidFill>
-                  <a:srgbClr val="6B6B6B"/>
+                  <a:srgbClr val="595959"/>
                 </a:solidFill>
-                <a:latin typeface="Microsoft JhengHei"/>
+                <a:latin typeface="Arial"/>
+                <a:ea typeface="微軟正黑體"/>
               </a:rPr>
               <a:t>　</a:t>
             </a:r>
             <a:r>
               <a:rPr sz="900" b="0" u="sng">
                 <a:solidFill>
-                  <a:srgbClr val="1F5FBF"/>
+                  <a:srgbClr val="595959"/>
                 </a:solidFill>
-                <a:latin typeface="Microsoft JhengHei"/>
+                <a:latin typeface="Arial"/>
+                <a:ea typeface="微軟正黑體"/>
                 <a:hlinkClick r:id="rId3"/>
               </a:rPr>
               <a:t>PwC 保險高階主管調查（Claims Journal）</a:t>
@@ -43567,18 +43701,20 @@
             <a:r>
               <a:rPr sz="900" b="0">
                 <a:solidFill>
-                  <a:srgbClr val="6B6B6B"/>
+                  <a:srgbClr val="595959"/>
                 </a:solidFill>
-                <a:latin typeface="Microsoft JhengHei"/>
+                <a:latin typeface="Arial"/>
+                <a:ea typeface="微軟正黑體"/>
               </a:rPr>
               <a:t>　</a:t>
             </a:r>
             <a:r>
               <a:rPr sz="900" b="0" u="sng">
                 <a:solidFill>
-                  <a:srgbClr val="1F5FBF"/>
+                  <a:srgbClr val="595959"/>
                 </a:solidFill>
-                <a:latin typeface="Microsoft JhengHei"/>
+                <a:latin typeface="Arial"/>
+                <a:ea typeface="微軟正黑體"/>
                 <a:hlinkClick r:id="rId4"/>
               </a:rPr>
               <a:t>Bain：Reimagining Insurance for the AI Era</a:t>
@@ -43620,17 +43756,119 @@
           <a:lstStyle/>
           <a:p>
             <a:r>
-              <a:rPr sz="2000">
-                <a:latin typeface="Microsoft JhengHei"/>
+              <a:rPr sz="2000" b="1">
+                <a:latin typeface="Georgia"/>
+                <a:ea typeface="微軟正黑體"/>
               </a:rPr>
               <a:t>為什麼是這兩項：台灣監理時程已經確定，而且兩項服務離我們的既有能力最近</a:t>
             </a:r>
           </a:p>
         </p:txBody>
       </p:sp>
+      <p:sp>
+        <p:nvSpPr>
+          <p:cNvPr id="4" name="Footer Placeholder 4">
+            <a:extLst>
+              <a:ext uri="{FF2B5EF4-FFF2-40B4-BE49-F238E27FC236}">
+                <a16:creationId xmlns:a16="http://schemas.microsoft.com/office/drawing/2014/main" id="{E57B29C1-93EA-1886-CD27-23CE023225D9}"/>
+              </a:ext>
+            </a:extLst>
+          </p:cNvPr>
+          <p:cNvSpPr>
+            <a:spLocks noGrp="1"/>
+          </p:cNvSpPr>
+          <p:nvPr>
+            <p:ph type="ftr" sz="quarter" idx="3"/>
+          </p:nvPr>
+        </p:nvSpPr>
+        <p:spPr>
+          <a:xfrm>
+            <a:off x="1066800" y="6497441"/>
+            <a:ext cx="8814816" cy="161583"/>
+          </a:xfrm>
+          <a:prstGeom prst="rect">
+            <a:avLst/>
+          </a:prstGeom>
+        </p:spPr>
+        <p:txBody>
+          <a:bodyPr vert="horz" wrap="square" lIns="0" tIns="0" rIns="0" bIns="0" rtlCol="0" anchor="b" anchorCtr="0">
+            <a:spAutoFit/>
+          </a:bodyPr>
+          <a:lstStyle>
+            <a:lvl1pPr algn="l">
+              <a:defRPr sz="1050" b="0">
+                <a:solidFill>
+                  <a:sysClr val="windowText" lastClr="000000"/>
+                </a:solidFill>
+                <a:latin typeface="+mn-lt"/>
+                <a:cs typeface="Arial" panose="020B0604020202020204" pitchFamily="34" charset="0"/>
+              </a:defRPr>
+            </a:lvl1pPr>
+          </a:lstStyle>
+          <a:p>
+            <a:r>
+              <a:rPr>
+                <a:latin typeface="Arial"/>
+                <a:ea typeface="微軟正黑體"/>
+              </a:rPr>
+              <a:t>內部討論稿｜僅供 FSC1 保險組內部使用｜資料來源為公開研究，點選來源可開啟原文</a:t>
+            </a:r>
+          </a:p>
+        </p:txBody>
+      </p:sp>
+      <p:sp>
+        <p:nvSpPr>
+          <p:cNvPr id="6" name="Slide Number Placeholder 13">
+            <a:extLst>
+              <a:ext uri="{FF2B5EF4-FFF2-40B4-BE49-F238E27FC236}">
+                <a16:creationId xmlns:a16="http://schemas.microsoft.com/office/drawing/2014/main" id="{D15FEAD4-DFB9-ED08-EBEE-A4E5DE31E318}"/>
+              </a:ext>
+            </a:extLst>
+          </p:cNvPr>
+          <p:cNvSpPr>
+            <a:spLocks noGrp="1"/>
+          </p:cNvSpPr>
+          <p:nvPr>
+            <p:ph type="sldNum" sz="quarter" idx="4"/>
+          </p:nvPr>
+        </p:nvSpPr>
+        <p:spPr>
+          <a:xfrm>
+            <a:off x="11503818" y="6501384"/>
+            <a:ext cx="298209" cy="161583"/>
+          </a:xfrm>
+          <a:prstGeom prst="rect">
+            <a:avLst/>
+          </a:prstGeom>
+        </p:spPr>
+        <p:txBody>
+          <a:bodyPr vert="horz" wrap="square" lIns="0" tIns="0" rIns="0" bIns="0" rtlCol="0" anchor="b" anchorCtr="0">
+            <a:spAutoFit/>
+          </a:bodyPr>
+          <a:lstStyle>
+            <a:lvl1pPr algn="r">
+              <a:defRPr sz="1050">
+                <a:solidFill>
+                  <a:schemeClr val="tx1"/>
+                </a:solidFill>
+                <a:latin typeface="+mn-lt"/>
+                <a:cs typeface="Arial" panose="020B0604020202020204" pitchFamily="34" charset="0"/>
+              </a:defRPr>
+            </a:lvl1pPr>
+          </a:lstStyle>
+          <a:p>
+            <a:fld id="{3E6AC032-1535-134B-A583-D5E1DDD0D167}" type="slidenum">
+              <a:rPr lang="en-US" smtClean="0"/>
+              <a:pPr/>
+              <a:t>‹#›</a:t>
+            </a:fld>
+            <a:endParaRPr lang="en-US"/>
+          </a:p>
+        </p:txBody>
+      </p:sp>
       <p:cxnSp>
         <p:nvCxnSpPr>
-          <p:cNvPr id="3" name="Connector 2"/>
+          <p:cNvPr id="7" name="Connector 6"/>
           <p:cNvCxnSpPr/>
           <p:nvPr/>
         </p:nvCxnSpPr>
@@ -43665,7 +43903,7 @@
       </p:cxnSp>
       <p:sp>
         <p:nvSpPr>
-          <p:cNvPr id="4" name="Oval 3"/>
+          <p:cNvPr id="8" name="Oval 7"/>
           <p:cNvSpPr/>
           <p:nvPr/>
         </p:nvSpPr>
@@ -43709,7 +43947,8 @@
                 <a:solidFill>
                   <a:srgbClr val="FFFFFF"/>
                 </a:solidFill>
-                <a:latin typeface="Microsoft JhengHei"/>
+                <a:latin typeface="Arial"/>
+                <a:ea typeface="微軟正黑體"/>
               </a:rPr>
               <a:t/>
             </a:r>
@@ -43718,7 +43957,7 @@
       </p:sp>
       <p:sp>
         <p:nvSpPr>
-          <p:cNvPr id="5" name="Rectangle 4"/>
+          <p:cNvPr id="9" name="Rectangle 8"/>
           <p:cNvSpPr/>
           <p:nvPr/>
         </p:nvSpPr>
@@ -43764,7 +44003,8 @@
                 <a:solidFill>
                   <a:srgbClr val="FD5108"/>
                 </a:solidFill>
-                <a:latin typeface="Microsoft JhengHei"/>
+                <a:latin typeface="Arial"/>
+                <a:ea typeface="微軟正黑體"/>
               </a:rPr>
               <a:t>2024-06</a:t>
             </a:r>
@@ -43773,7 +44013,7 @@
       </p:sp>
       <p:sp>
         <p:nvSpPr>
-          <p:cNvPr id="6" name="Rectangle 5"/>
+          <p:cNvPr id="10" name="Rectangle 9"/>
           <p:cNvSpPr/>
           <p:nvPr/>
         </p:nvSpPr>
@@ -43786,7 +44026,7 @@
             <a:avLst/>
           </a:prstGeom>
           <a:solidFill>
-            <a:srgbClr val="F3F3F3"/>
+            <a:srgbClr val="EBEBEB"/>
           </a:solidFill>
           <a:ln>
             <a:noFill/>
@@ -43819,9 +44059,10 @@
             <a:r>
               <a:rPr sz="1050" b="0">
                 <a:solidFill>
-                  <a:srgbClr val="1E1E1E"/>
+                  <a:srgbClr val="000000"/>
                 </a:solidFill>
-                <a:latin typeface="Microsoft JhengHei"/>
+                <a:latin typeface="Arial"/>
+                <a:ea typeface="微軟正黑體"/>
               </a:rPr>
               <a:t>金管會《金融業運用 AI 指引》</a:t>
             </a:r>
@@ -43835,9 +44076,10 @@
             <a:r>
               <a:rPr sz="900" b="0" u="sng">
                 <a:solidFill>
-                  <a:srgbClr val="1F5FBF"/>
+                  <a:srgbClr val="000000"/>
                 </a:solidFill>
-                <a:latin typeface="Microsoft JhengHei"/>
+                <a:latin typeface="Arial"/>
+                <a:ea typeface="微軟正黑體"/>
                 <a:hlinkClick r:id="rId2"/>
               </a:rPr>
               <a:t>原文</a:t>
@@ -43847,7 +44089,7 @@
       </p:sp>
       <p:sp>
         <p:nvSpPr>
-          <p:cNvPr id="7" name="Oval 6"/>
+          <p:cNvPr id="11" name="Oval 10"/>
           <p:cNvSpPr/>
           <p:nvPr/>
         </p:nvSpPr>
@@ -43891,7 +44133,8 @@
                 <a:solidFill>
                   <a:srgbClr val="FFFFFF"/>
                 </a:solidFill>
-                <a:latin typeface="Microsoft JhengHei"/>
+                <a:latin typeface="Arial"/>
+                <a:ea typeface="微軟正黑體"/>
               </a:rPr>
               <a:t/>
             </a:r>
@@ -43900,7 +44143,7 @@
       </p:sp>
       <p:sp>
         <p:nvSpPr>
-          <p:cNvPr id="8" name="Rectangle 7"/>
+          <p:cNvPr id="12" name="Rectangle 11"/>
           <p:cNvSpPr/>
           <p:nvPr/>
         </p:nvSpPr>
@@ -43946,7 +44189,8 @@
                 <a:solidFill>
                   <a:srgbClr val="FD5108"/>
                 </a:solidFill>
-                <a:latin typeface="Microsoft JhengHei"/>
+                <a:latin typeface="Arial"/>
+                <a:ea typeface="微軟正黑體"/>
               </a:rPr>
               <a:t>2024-08</a:t>
             </a:r>
@@ -43955,7 +44199,7 @@
       </p:sp>
       <p:sp>
         <p:nvSpPr>
-          <p:cNvPr id="9" name="Rectangle 8"/>
+          <p:cNvPr id="13" name="Rectangle 12"/>
           <p:cNvSpPr/>
           <p:nvPr/>
         </p:nvSpPr>
@@ -43968,7 +44212,7 @@
             <a:avLst/>
           </a:prstGeom>
           <a:solidFill>
-            <a:srgbClr val="F3F3F3"/>
+            <a:srgbClr val="EBEBEB"/>
           </a:solidFill>
           <a:ln>
             <a:noFill/>
@@ -44001,9 +44245,10 @@
             <a:r>
               <a:rPr sz="1050" b="0">
                 <a:solidFill>
-                  <a:srgbClr val="1E1E1E"/>
+                  <a:srgbClr val="000000"/>
                 </a:solidFill>
-                <a:latin typeface="Microsoft JhengHei"/>
+                <a:latin typeface="Arial"/>
+                <a:ea typeface="微軟正黑體"/>
               </a:rPr>
               <a:t>委外注意事項修正：放寬雲端聯合查核</a:t>
             </a:r>
@@ -44017,9 +44262,10 @@
             <a:r>
               <a:rPr sz="900" b="0" u="sng">
                 <a:solidFill>
-                  <a:srgbClr val="1F5FBF"/>
+                  <a:srgbClr val="000000"/>
                 </a:solidFill>
-                <a:latin typeface="Microsoft JhengHei"/>
+                <a:latin typeface="Arial"/>
+                <a:ea typeface="微軟正黑體"/>
                 <a:hlinkClick r:id="rId3"/>
               </a:rPr>
               <a:t>原文</a:t>
@@ -44029,7 +44275,7 @@
       </p:sp>
       <p:sp>
         <p:nvSpPr>
-          <p:cNvPr id="10" name="Oval 9"/>
+          <p:cNvPr id="14" name="Oval 13"/>
           <p:cNvSpPr/>
           <p:nvPr/>
         </p:nvSpPr>
@@ -44073,7 +44319,8 @@
                 <a:solidFill>
                   <a:srgbClr val="FFFFFF"/>
                 </a:solidFill>
-                <a:latin typeface="Microsoft JhengHei"/>
+                <a:latin typeface="Arial"/>
+                <a:ea typeface="微軟正黑體"/>
               </a:rPr>
               <a:t/>
             </a:r>
@@ -44082,7 +44329,7 @@
       </p:sp>
       <p:sp>
         <p:nvSpPr>
-          <p:cNvPr id="11" name="Rectangle 10"/>
+          <p:cNvPr id="15" name="Rectangle 14"/>
           <p:cNvSpPr/>
           <p:nvPr/>
         </p:nvSpPr>
@@ -44128,7 +44375,8 @@
                 <a:solidFill>
                   <a:srgbClr val="FD5108"/>
                 </a:solidFill>
-                <a:latin typeface="Microsoft JhengHei"/>
+                <a:latin typeface="Arial"/>
+                <a:ea typeface="微軟正黑體"/>
               </a:rPr>
               <a:t>2025-12-31</a:t>
             </a:r>
@@ -44137,7 +44385,7 @@
       </p:sp>
       <p:sp>
         <p:nvSpPr>
-          <p:cNvPr id="12" name="Rectangle 11"/>
+          <p:cNvPr id="16" name="Rectangle 15"/>
           <p:cNvSpPr/>
           <p:nvPr/>
         </p:nvSpPr>
@@ -44150,7 +44398,7 @@
             <a:avLst/>
           </a:prstGeom>
           <a:solidFill>
-            <a:srgbClr val="F3F3F3"/>
+            <a:srgbClr val="EBEBEB"/>
           </a:solidFill>
           <a:ln>
             <a:noFill/>
@@ -44183,9 +44431,10 @@
             <a:r>
               <a:rPr sz="1050" b="0">
                 <a:solidFill>
-                  <a:srgbClr val="1E1E1E"/>
+                  <a:srgbClr val="000000"/>
                 </a:solidFill>
-                <a:latin typeface="Microsoft JhengHei"/>
+                <a:latin typeface="Arial"/>
+                <a:ea typeface="微軟正黑體"/>
               </a:rPr>
               <a:t>委外新辦法施行，提升為法規命令</a:t>
             </a:r>
@@ -44199,9 +44448,10 @@
             <a:r>
               <a:rPr sz="900" b="0" u="sng">
                 <a:solidFill>
-                  <a:srgbClr val="1F5FBF"/>
+                  <a:srgbClr val="000000"/>
                 </a:solidFill>
-                <a:latin typeface="Microsoft JhengHei"/>
+                <a:latin typeface="Arial"/>
+                <a:ea typeface="微軟正黑體"/>
                 <a:hlinkClick r:id="rId4"/>
               </a:rPr>
               <a:t>原文</a:t>
@@ -44211,7 +44461,7 @@
       </p:sp>
       <p:sp>
         <p:nvSpPr>
-          <p:cNvPr id="13" name="Oval 12"/>
+          <p:cNvPr id="17" name="Oval 16"/>
           <p:cNvSpPr/>
           <p:nvPr/>
         </p:nvSpPr>
@@ -44255,7 +44505,8 @@
                 <a:solidFill>
                   <a:srgbClr val="FFFFFF"/>
                 </a:solidFill>
-                <a:latin typeface="Microsoft JhengHei"/>
+                <a:latin typeface="Arial"/>
+                <a:ea typeface="微軟正黑體"/>
               </a:rPr>
               <a:t/>
             </a:r>
@@ -44264,7 +44515,7 @@
       </p:sp>
       <p:sp>
         <p:nvSpPr>
-          <p:cNvPr id="14" name="Rectangle 13"/>
+          <p:cNvPr id="18" name="Rectangle 17"/>
           <p:cNvSpPr/>
           <p:nvPr/>
         </p:nvSpPr>
@@ -44310,7 +44561,8 @@
                 <a:solidFill>
                   <a:srgbClr val="FD5108"/>
                 </a:solidFill>
-                <a:latin typeface="Microsoft JhengHei"/>
+                <a:latin typeface="Arial"/>
+                <a:ea typeface="微軟正黑體"/>
               </a:rPr>
               <a:t>2026-01-01</a:t>
             </a:r>
@@ -44319,7 +44571,7 @@
       </p:sp>
       <p:sp>
         <p:nvSpPr>
-          <p:cNvPr id="15" name="Rectangle 14"/>
+          <p:cNvPr id="19" name="Rectangle 18"/>
           <p:cNvSpPr/>
           <p:nvPr/>
         </p:nvSpPr>
@@ -44332,7 +44584,7 @@
             <a:avLst/>
           </a:prstGeom>
           <a:solidFill>
-            <a:srgbClr val="F3F3F3"/>
+            <a:srgbClr val="EBEBEB"/>
           </a:solidFill>
           <a:ln>
             <a:noFill/>
@@ -44365,9 +44617,10 @@
             <a:r>
               <a:rPr sz="1050" b="0">
                 <a:solidFill>
-                  <a:srgbClr val="1E1E1E"/>
+                  <a:srgbClr val="000000"/>
                 </a:solidFill>
-                <a:latin typeface="Microsoft JhengHei"/>
+                <a:latin typeface="Arial"/>
+                <a:ea typeface="微軟正黑體"/>
               </a:rPr>
               <a:t>IFRS 17／TW-ICS 正式接軌</a:t>
             </a:r>
@@ -44381,9 +44634,10 @@
             <a:r>
               <a:rPr sz="900" b="0" u="sng">
                 <a:solidFill>
-                  <a:srgbClr val="1F5FBF"/>
+                  <a:srgbClr val="000000"/>
                 </a:solidFill>
-                <a:latin typeface="Microsoft JhengHei"/>
+                <a:latin typeface="Arial"/>
+                <a:ea typeface="微軟正黑體"/>
                 <a:hlinkClick r:id="rId5"/>
               </a:rPr>
               <a:t>原文</a:t>
@@ -44393,7 +44647,7 @@
       </p:sp>
       <p:sp>
         <p:nvSpPr>
-          <p:cNvPr id="16" name="Oval 15"/>
+          <p:cNvPr id="20" name="Oval 19"/>
           <p:cNvSpPr/>
           <p:nvPr/>
         </p:nvSpPr>
@@ -44406,7 +44660,7 @@
             <a:avLst/>
           </a:prstGeom>
           <a:solidFill>
-            <a:srgbClr val="6B6B6B"/>
+            <a:srgbClr val="595959"/>
           </a:solidFill>
           <a:ln>
             <a:noFill/>
@@ -44437,7 +44691,8 @@
                 <a:solidFill>
                   <a:srgbClr val="FFFFFF"/>
                 </a:solidFill>
-                <a:latin typeface="Microsoft JhengHei"/>
+                <a:latin typeface="Arial"/>
+                <a:ea typeface="微軟正黑體"/>
               </a:rPr>
               <a:t/>
             </a:r>
@@ -44446,7 +44701,7 @@
       </p:sp>
       <p:sp>
         <p:nvSpPr>
-          <p:cNvPr id="17" name="Rectangle 16"/>
+          <p:cNvPr id="21" name="Rectangle 20"/>
           <p:cNvSpPr/>
           <p:nvPr/>
         </p:nvSpPr>
@@ -44490,9 +44745,10 @@
             <a:r>
               <a:rPr sz="1250" b="1">
                 <a:solidFill>
-                  <a:srgbClr val="6B6B6B"/>
+                  <a:srgbClr val="595959"/>
                 </a:solidFill>
-                <a:latin typeface="Microsoft JhengHei"/>
+                <a:latin typeface="Arial"/>
+                <a:ea typeface="微軟正黑體"/>
               </a:rPr>
               <a:t>2026-03～09</a:t>
             </a:r>
@@ -44501,7 +44757,7 @@
       </p:sp>
       <p:sp>
         <p:nvSpPr>
-          <p:cNvPr id="18" name="Rectangle 17"/>
+          <p:cNvPr id="22" name="Rectangle 21"/>
           <p:cNvSpPr/>
           <p:nvPr/>
         </p:nvSpPr>
@@ -44516,7 +44772,7 @@
           <a:noFill/>
           <a:ln w="9525">
             <a:solidFill>
-              <a:srgbClr val="D9D9D9"/>
+              <a:srgbClr val="CBD1D6"/>
             </a:solidFill>
           </a:ln>
           <a:effectLst/>
@@ -44547,9 +44803,10 @@
             <a:r>
               <a:rPr sz="1050" b="0">
                 <a:solidFill>
-                  <a:srgbClr val="1E1E1E"/>
+                  <a:srgbClr val="000000"/>
                 </a:solidFill>
-                <a:latin typeface="Microsoft JhengHei"/>
+                <a:latin typeface="Arial"/>
+                <a:ea typeface="微軟正黑體"/>
               </a:rPr>
               <a:t>NAIC 12 州 AI 評估工具試點（美國）</a:t>
             </a:r>
@@ -44563,9 +44820,10 @@
             <a:r>
               <a:rPr sz="900" b="0" u="sng">
                 <a:solidFill>
-                  <a:srgbClr val="1F5FBF"/>
+                  <a:srgbClr val="000000"/>
                 </a:solidFill>
-                <a:latin typeface="Microsoft JhengHei"/>
+                <a:latin typeface="Arial"/>
+                <a:ea typeface="微軟正黑體"/>
                 <a:hlinkClick r:id="rId6"/>
               </a:rPr>
               <a:t>原文</a:t>
@@ -44575,7 +44833,7 @@
       </p:sp>
       <p:sp>
         <p:nvSpPr>
-          <p:cNvPr id="19" name="Oval 18"/>
+          <p:cNvPr id="23" name="Oval 22"/>
           <p:cNvSpPr/>
           <p:nvPr/>
         </p:nvSpPr>
@@ -44588,7 +44846,7 @@
             <a:avLst/>
           </a:prstGeom>
           <a:solidFill>
-            <a:srgbClr val="6B6B6B"/>
+            <a:srgbClr val="595959"/>
           </a:solidFill>
           <a:ln>
             <a:noFill/>
@@ -44619,7 +44877,8 @@
                 <a:solidFill>
                   <a:srgbClr val="FFFFFF"/>
                 </a:solidFill>
-                <a:latin typeface="Microsoft JhengHei"/>
+                <a:latin typeface="Arial"/>
+                <a:ea typeface="微軟正黑體"/>
               </a:rPr>
               <a:t/>
             </a:r>
@@ -44628,7 +44887,7 @@
       </p:sp>
       <p:sp>
         <p:nvSpPr>
-          <p:cNvPr id="20" name="Rectangle 19"/>
+          <p:cNvPr id="24" name="Rectangle 23"/>
           <p:cNvSpPr/>
           <p:nvPr/>
         </p:nvSpPr>
@@ -44672,9 +44931,10 @@
             <a:r>
               <a:rPr sz="1250" b="1">
                 <a:solidFill>
-                  <a:srgbClr val="6B6B6B"/>
+                  <a:srgbClr val="595959"/>
                 </a:solidFill>
-                <a:latin typeface="Microsoft JhengHei"/>
+                <a:latin typeface="Arial"/>
+                <a:ea typeface="微軟正黑體"/>
               </a:rPr>
               <a:t>2026-10</a:t>
             </a:r>
@@ -44683,7 +44943,7 @@
       </p:sp>
       <p:sp>
         <p:nvSpPr>
-          <p:cNvPr id="21" name="Rectangle 20"/>
+          <p:cNvPr id="25" name="Rectangle 24"/>
           <p:cNvSpPr/>
           <p:nvPr/>
         </p:nvSpPr>
@@ -44698,7 +44958,7 @@
           <a:noFill/>
           <a:ln w="9525">
             <a:solidFill>
-              <a:srgbClr val="D9D9D9"/>
+              <a:srgbClr val="CBD1D6"/>
             </a:solidFill>
           </a:ln>
           <a:effectLst/>
@@ -44729,9 +44989,10 @@
             <a:r>
               <a:rPr sz="1050" b="0">
                 <a:solidFill>
-                  <a:srgbClr val="1E1E1E"/>
+                  <a:srgbClr val="000000"/>
                 </a:solidFill>
-                <a:latin typeface="Microsoft JhengHei"/>
+                <a:latin typeface="Arial"/>
+                <a:ea typeface="微軟正黑體"/>
               </a:rPr>
               <a:t>MAS AI 風險管理指引定稿（新加坡）</a:t>
             </a:r>
@@ -44745,9 +45006,10 @@
             <a:r>
               <a:rPr sz="900" b="0" u="sng">
                 <a:solidFill>
-                  <a:srgbClr val="1F5FBF"/>
+                  <a:srgbClr val="000000"/>
                 </a:solidFill>
-                <a:latin typeface="Microsoft JhengHei"/>
+                <a:latin typeface="Arial"/>
+                <a:ea typeface="微軟正黑體"/>
                 <a:hlinkClick r:id="rId7"/>
               </a:rPr>
               <a:t>原文</a:t>
@@ -44757,7 +45019,7 @@
       </p:sp>
       <p:sp>
         <p:nvSpPr>
-          <p:cNvPr id="22" name="Rectangle 21"/>
+          <p:cNvPr id="26" name="Rectangle 25"/>
           <p:cNvSpPr/>
           <p:nvPr/>
         </p:nvSpPr>
@@ -44801,9 +45063,10 @@
             <a:r>
               <a:rPr sz="900" b="0">
                 <a:solidFill>
-                  <a:srgbClr val="6B6B6B"/>
+                  <a:srgbClr val="595959"/>
                 </a:solidFill>
-                <a:latin typeface="Microsoft JhengHei"/>
+                <a:latin typeface="微軟正黑體"/>
+                <a:ea typeface="微軟正黑體"/>
               </a:rPr>
               <a:t>時間軸：橘色為台灣監理事件，灰色為國際標竿。　評等：● 有利　◐ 中等　○ 不利，為團隊依研究報告判斷，請會議校準。</a:t>
             </a:r>
@@ -44812,7 +45075,7 @@
       </p:sp>
       <p:sp>
         <p:nvSpPr>
-          <p:cNvPr id="23" name="Rectangle 22"/>
+          <p:cNvPr id="27" name="Rectangle 26"/>
           <p:cNvSpPr/>
           <p:nvPr/>
         </p:nvSpPr>
@@ -44860,7 +45123,8 @@
                 <a:solidFill>
                   <a:srgbClr val="FFFFFF"/>
                 </a:solidFill>
-                <a:latin typeface="Microsoft JhengHei"/>
+                <a:latin typeface="Arial"/>
+                <a:ea typeface="微軟正黑體"/>
               </a:rPr>
               <a:t>服務</a:t>
             </a:r>
@@ -44869,7 +45133,7 @@
       </p:sp>
       <p:sp>
         <p:nvSpPr>
-          <p:cNvPr id="24" name="Rectangle 23"/>
+          <p:cNvPr id="28" name="Rectangle 27"/>
           <p:cNvSpPr/>
           <p:nvPr/>
         </p:nvSpPr>
@@ -44917,7 +45181,8 @@
                 <a:solidFill>
                   <a:srgbClr val="FFFFFF"/>
                 </a:solidFill>
-                <a:latin typeface="Microsoft JhengHei"/>
+                <a:latin typeface="Arial"/>
+                <a:ea typeface="微軟正黑體"/>
               </a:rPr>
               <a:t>需求迫切度</a:t>
             </a:r>
@@ -44926,7 +45191,7 @@
       </p:sp>
       <p:sp>
         <p:nvSpPr>
-          <p:cNvPr id="25" name="Rectangle 24"/>
+          <p:cNvPr id="29" name="Rectangle 28"/>
           <p:cNvSpPr/>
           <p:nvPr/>
         </p:nvSpPr>
@@ -44974,7 +45239,8 @@
                 <a:solidFill>
                   <a:srgbClr val="FFFFFF"/>
                 </a:solidFill>
-                <a:latin typeface="Microsoft JhengHei"/>
+                <a:latin typeface="Arial"/>
+                <a:ea typeface="微軟正黑體"/>
               </a:rPr>
               <a:t>離既有服務</a:t>
             </a:r>
@@ -44983,7 +45249,7 @@
       </p:sp>
       <p:sp>
         <p:nvSpPr>
-          <p:cNvPr id="26" name="Rectangle 25"/>
+          <p:cNvPr id="30" name="Rectangle 29"/>
           <p:cNvSpPr/>
           <p:nvPr/>
         </p:nvSpPr>
@@ -45031,7 +45297,8 @@
                 <a:solidFill>
                   <a:srgbClr val="FFFFFF"/>
                 </a:solidFill>
-                <a:latin typeface="Microsoft JhengHei"/>
+                <a:latin typeface="Arial"/>
+                <a:ea typeface="微軟正黑體"/>
               </a:rPr>
               <a:t>首案週期</a:t>
             </a:r>
@@ -45040,7 +45307,7 @@
       </p:sp>
       <p:sp>
         <p:nvSpPr>
-          <p:cNvPr id="27" name="Rectangle 26"/>
+          <p:cNvPr id="31" name="Rectangle 30"/>
           <p:cNvSpPr/>
           <p:nvPr/>
         </p:nvSpPr>
@@ -45088,7 +45355,8 @@
                 <a:solidFill>
                   <a:srgbClr val="FFFFFF"/>
                 </a:solidFill>
-                <a:latin typeface="Microsoft JhengHei"/>
+                <a:latin typeface="Arial"/>
+                <a:ea typeface="微軟正黑體"/>
               </a:rPr>
               <a:t>切入案</a:t>
             </a:r>
@@ -45097,7 +45365,7 @@
       </p:sp>
       <p:sp>
         <p:nvSpPr>
-          <p:cNvPr id="28" name="Rectangle 27"/>
+          <p:cNvPr id="32" name="Rectangle 31"/>
           <p:cNvSpPr/>
           <p:nvPr/>
         </p:nvSpPr>
@@ -45145,7 +45413,8 @@
                 <a:solidFill>
                   <a:srgbClr val="FFFFFF"/>
                 </a:solidFill>
-                <a:latin typeface="Microsoft JhengHei"/>
+                <a:latin typeface="Arial"/>
+                <a:ea typeface="微軟正黑體"/>
               </a:rPr>
               <a:t>建議</a:t>
             </a:r>
@@ -45154,7 +45423,7 @@
       </p:sp>
       <p:sp>
         <p:nvSpPr>
-          <p:cNvPr id="29" name="Rectangle 28"/>
+          <p:cNvPr id="33" name="Rectangle 32"/>
           <p:cNvSpPr/>
           <p:nvPr/>
         </p:nvSpPr>
@@ -45167,7 +45436,7 @@
             <a:avLst/>
           </a:prstGeom>
           <a:solidFill>
-            <a:srgbClr val="F3F3F3"/>
+            <a:srgbClr val="EBEBEB"/>
           </a:solidFill>
           <a:ln>
             <a:noFill/>
@@ -45200,9 +45469,10 @@
             <a:r>
               <a:rPr sz="1100" b="1">
                 <a:solidFill>
-                  <a:srgbClr val="1E1E1E"/>
+                  <a:srgbClr val="000000"/>
                 </a:solidFill>
-                <a:latin typeface="Microsoft JhengHei"/>
+                <a:latin typeface="Arial"/>
+                <a:ea typeface="微軟正黑體"/>
               </a:rPr>
               <a:t>IFRS 17／TW-ICS 後財務轉型</a:t>
             </a:r>
@@ -45211,7 +45481,7 @@
       </p:sp>
       <p:sp>
         <p:nvSpPr>
-          <p:cNvPr id="30" name="Rectangle 29"/>
+          <p:cNvPr id="34" name="Rectangle 33"/>
           <p:cNvSpPr/>
           <p:nvPr/>
         </p:nvSpPr>
@@ -45224,7 +45494,7 @@
             <a:avLst/>
           </a:prstGeom>
           <a:solidFill>
-            <a:srgbClr val="F3F3F3"/>
+            <a:srgbClr val="EBEBEB"/>
           </a:solidFill>
           <a:ln>
             <a:noFill/>
@@ -45259,7 +45529,8 @@
                 <a:solidFill>
                   <a:srgbClr val="FD5108"/>
                 </a:solidFill>
-                <a:latin typeface="Microsoft JhengHei"/>
+                <a:latin typeface="微軟正黑體"/>
+                <a:ea typeface="微軟正黑體"/>
               </a:rPr>
               <a:t>●</a:t>
             </a:r>
@@ -45268,7 +45539,7 @@
       </p:sp>
       <p:sp>
         <p:nvSpPr>
-          <p:cNvPr id="31" name="Rectangle 30"/>
+          <p:cNvPr id="35" name="Rectangle 34"/>
           <p:cNvSpPr/>
           <p:nvPr/>
         </p:nvSpPr>
@@ -45281,7 +45552,7 @@
             <a:avLst/>
           </a:prstGeom>
           <a:solidFill>
-            <a:srgbClr val="F3F3F3"/>
+            <a:srgbClr val="EBEBEB"/>
           </a:solidFill>
           <a:ln>
             <a:noFill/>
@@ -45316,7 +45587,8 @@
                 <a:solidFill>
                   <a:srgbClr val="FD5108"/>
                 </a:solidFill>
-                <a:latin typeface="Microsoft JhengHei"/>
+                <a:latin typeface="微軟正黑體"/>
+                <a:ea typeface="微軟正黑體"/>
               </a:rPr>
               <a:t>●</a:t>
             </a:r>
@@ -45325,7 +45597,7 @@
       </p:sp>
       <p:sp>
         <p:nvSpPr>
-          <p:cNvPr id="32" name="Rectangle 31"/>
+          <p:cNvPr id="36" name="Rectangle 35"/>
           <p:cNvSpPr/>
           <p:nvPr/>
         </p:nvSpPr>
@@ -45338,7 +45610,7 @@
             <a:avLst/>
           </a:prstGeom>
           <a:solidFill>
-            <a:srgbClr val="F3F3F3"/>
+            <a:srgbClr val="EBEBEB"/>
           </a:solidFill>
           <a:ln>
             <a:noFill/>
@@ -45373,7 +45645,8 @@
                 <a:solidFill>
                   <a:srgbClr val="FD5108"/>
                 </a:solidFill>
-                <a:latin typeface="Microsoft JhengHei"/>
+                <a:latin typeface="微軟正黑體"/>
+                <a:ea typeface="微軟正黑體"/>
               </a:rPr>
               <a:t>●</a:t>
             </a:r>
@@ -45382,7 +45655,7 @@
       </p:sp>
       <p:sp>
         <p:nvSpPr>
-          <p:cNvPr id="33" name="Rectangle 32"/>
+          <p:cNvPr id="37" name="Rectangle 36"/>
           <p:cNvSpPr/>
           <p:nvPr/>
         </p:nvSpPr>
@@ -45395,7 +45668,7 @@
             <a:avLst/>
           </a:prstGeom>
           <a:solidFill>
-            <a:srgbClr val="F3F3F3"/>
+            <a:srgbClr val="EBEBEB"/>
           </a:solidFill>
           <a:ln>
             <a:noFill/>
@@ -45428,9 +45701,10 @@
             <a:r>
               <a:rPr sz="1100" b="0">
                 <a:solidFill>
-                  <a:srgbClr val="1E1E1E"/>
+                  <a:srgbClr val="000000"/>
                 </a:solidFill>
-                <a:latin typeface="Microsoft JhengHei"/>
+                <a:latin typeface="Arial"/>
+                <a:ea typeface="微軟正黑體"/>
               </a:rPr>
               <a:t>首年結帳瓶頸診斷＋CSM 儀表板</a:t>
             </a:r>
@@ -45439,7 +45713,7 @@
       </p:sp>
       <p:sp>
         <p:nvSpPr>
-          <p:cNvPr id="34" name="Rectangle 33"/>
+          <p:cNvPr id="38" name="Rectangle 37"/>
           <p:cNvSpPr/>
           <p:nvPr/>
         </p:nvSpPr>
@@ -45487,7 +45761,8 @@
                 <a:solidFill>
                   <a:srgbClr val="FFFFFF"/>
                 </a:solidFill>
-                <a:latin typeface="Microsoft JhengHei"/>
+                <a:latin typeface="Arial"/>
+                <a:ea typeface="微軟正黑體"/>
               </a:rPr>
               <a:t>第一波</a:t>
             </a:r>
@@ -45496,7 +45771,7 @@
       </p:sp>
       <p:sp>
         <p:nvSpPr>
-          <p:cNvPr id="35" name="Rectangle 34"/>
+          <p:cNvPr id="39" name="Rectangle 38"/>
           <p:cNvSpPr/>
           <p:nvPr/>
         </p:nvSpPr>
@@ -45542,9 +45817,10 @@
             <a:r>
               <a:rPr sz="1100" b="1">
                 <a:solidFill>
-                  <a:srgbClr val="1E1E1E"/>
+                  <a:srgbClr val="000000"/>
                 </a:solidFill>
-                <a:latin typeface="Microsoft JhengHei"/>
+                <a:latin typeface="Arial"/>
+                <a:ea typeface="微軟正黑體"/>
               </a:rPr>
               <a:t>AI 清冊、模型驗證與護欄</a:t>
             </a:r>
@@ -45553,7 +45829,7 @@
       </p:sp>
       <p:sp>
         <p:nvSpPr>
-          <p:cNvPr id="36" name="Rectangle 35"/>
+          <p:cNvPr id="40" name="Rectangle 39"/>
           <p:cNvSpPr/>
           <p:nvPr/>
         </p:nvSpPr>
@@ -45601,7 +45877,8 @@
                 <a:solidFill>
                   <a:srgbClr val="FD5108"/>
                 </a:solidFill>
-                <a:latin typeface="Microsoft JhengHei"/>
+                <a:latin typeface="微軟正黑體"/>
+                <a:ea typeface="微軟正黑體"/>
               </a:rPr>
               <a:t>●</a:t>
             </a:r>
@@ -45610,7 +45887,7 @@
       </p:sp>
       <p:sp>
         <p:nvSpPr>
-          <p:cNvPr id="37" name="Rectangle 36"/>
+          <p:cNvPr id="41" name="Rectangle 40"/>
           <p:cNvSpPr/>
           <p:nvPr/>
         </p:nvSpPr>
@@ -45658,7 +45935,8 @@
                 <a:solidFill>
                   <a:srgbClr val="FD5108"/>
                 </a:solidFill>
-                <a:latin typeface="Microsoft JhengHei"/>
+                <a:latin typeface="微軟正黑體"/>
+                <a:ea typeface="微軟正黑體"/>
               </a:rPr>
               <a:t>●</a:t>
             </a:r>
@@ -45667,7 +45945,7 @@
       </p:sp>
       <p:sp>
         <p:nvSpPr>
-          <p:cNvPr id="38" name="Rectangle 37"/>
+          <p:cNvPr id="42" name="Rectangle 41"/>
           <p:cNvSpPr/>
           <p:nvPr/>
         </p:nvSpPr>
@@ -45715,7 +45993,8 @@
                 <a:solidFill>
                   <a:srgbClr val="FD5108"/>
                 </a:solidFill>
-                <a:latin typeface="Microsoft JhengHei"/>
+                <a:latin typeface="微軟正黑體"/>
+                <a:ea typeface="微軟正黑體"/>
               </a:rPr>
               <a:t>●</a:t>
             </a:r>
@@ -45724,7 +46003,7 @@
       </p:sp>
       <p:sp>
         <p:nvSpPr>
-          <p:cNvPr id="39" name="Rectangle 38"/>
+          <p:cNvPr id="43" name="Rectangle 42"/>
           <p:cNvSpPr/>
           <p:nvPr/>
         </p:nvSpPr>
@@ -45770,9 +46049,10 @@
             <a:r>
               <a:rPr sz="1100" b="0">
                 <a:solidFill>
-                  <a:srgbClr val="1E1E1E"/>
+                  <a:srgbClr val="000000"/>
                 </a:solidFill>
-                <a:latin typeface="Microsoft JhengHei"/>
+                <a:latin typeface="Arial"/>
+                <a:ea typeface="微軟正黑體"/>
               </a:rPr>
               <a:t>4–6 週 AI 清冊盤點與合規健檢</a:t>
             </a:r>
@@ -45781,7 +46061,7 @@
       </p:sp>
       <p:sp>
         <p:nvSpPr>
-          <p:cNvPr id="40" name="Rectangle 39"/>
+          <p:cNvPr id="44" name="Rectangle 43"/>
           <p:cNvSpPr/>
           <p:nvPr/>
         </p:nvSpPr>
@@ -45829,7 +46109,8 @@
                 <a:solidFill>
                   <a:srgbClr val="FFFFFF"/>
                 </a:solidFill>
-                <a:latin typeface="Microsoft JhengHei"/>
+                <a:latin typeface="Arial"/>
+                <a:ea typeface="微軟正黑體"/>
               </a:rPr>
               <a:t>第一波</a:t>
             </a:r>
@@ -45838,7 +46119,7 @@
       </p:sp>
       <p:sp>
         <p:nvSpPr>
-          <p:cNvPr id="41" name="Rectangle 40"/>
+          <p:cNvPr id="45" name="Rectangle 44"/>
           <p:cNvSpPr/>
           <p:nvPr/>
         </p:nvSpPr>
@@ -45851,7 +46132,7 @@
             <a:avLst/>
           </a:prstGeom>
           <a:solidFill>
-            <a:srgbClr val="F3F3F3"/>
+            <a:srgbClr val="EBEBEB"/>
           </a:solidFill>
           <a:ln>
             <a:noFill/>
@@ -45884,9 +46165,10 @@
             <a:r>
               <a:rPr sz="1100" b="1">
                 <a:solidFill>
-                  <a:srgbClr val="1E1E1E"/>
+                  <a:srgbClr val="000000"/>
                 </a:solidFill>
-                <a:latin typeface="Microsoft JhengHei"/>
+                <a:latin typeface="Arial"/>
+                <a:ea typeface="微軟正黑體"/>
               </a:rPr>
               <a:t>代理型 AI 核保與理賠</a:t>
             </a:r>
@@ -45895,7 +46177,7 @@
       </p:sp>
       <p:sp>
         <p:nvSpPr>
-          <p:cNvPr id="42" name="Rectangle 41"/>
+          <p:cNvPr id="46" name="Rectangle 45"/>
           <p:cNvSpPr/>
           <p:nvPr/>
         </p:nvSpPr>
@@ -45908,7 +46190,7 @@
             <a:avLst/>
           </a:prstGeom>
           <a:solidFill>
-            <a:srgbClr val="F3F3F3"/>
+            <a:srgbClr val="EBEBEB"/>
           </a:solidFill>
           <a:ln>
             <a:noFill/>
@@ -45943,7 +46225,8 @@
                 <a:solidFill>
                   <a:srgbClr val="FD5108"/>
                 </a:solidFill>
-                <a:latin typeface="Microsoft JhengHei"/>
+                <a:latin typeface="微軟正黑體"/>
+                <a:ea typeface="微軟正黑體"/>
               </a:rPr>
               <a:t>●</a:t>
             </a:r>
@@ -45952,7 +46235,7 @@
       </p:sp>
       <p:sp>
         <p:nvSpPr>
-          <p:cNvPr id="43" name="Rectangle 42"/>
+          <p:cNvPr id="47" name="Rectangle 46"/>
           <p:cNvSpPr/>
           <p:nvPr/>
         </p:nvSpPr>
@@ -45965,7 +46248,7 @@
             <a:avLst/>
           </a:prstGeom>
           <a:solidFill>
-            <a:srgbClr val="F3F3F3"/>
+            <a:srgbClr val="EBEBEB"/>
           </a:solidFill>
           <a:ln>
             <a:noFill/>
@@ -46000,7 +46283,8 @@
                 <a:solidFill>
                   <a:srgbClr val="FD5108"/>
                 </a:solidFill>
-                <a:latin typeface="Microsoft JhengHei"/>
+                <a:latin typeface="微軟正黑體"/>
+                <a:ea typeface="微軟正黑體"/>
               </a:rPr>
               <a:t>◐</a:t>
             </a:r>
@@ -46009,7 +46293,7 @@
       </p:sp>
       <p:sp>
         <p:nvSpPr>
-          <p:cNvPr id="44" name="Rectangle 43"/>
+          <p:cNvPr id="48" name="Rectangle 47"/>
           <p:cNvSpPr/>
           <p:nvPr/>
         </p:nvSpPr>
@@ -46022,7 +46306,7 @@
             <a:avLst/>
           </a:prstGeom>
           <a:solidFill>
-            <a:srgbClr val="F3F3F3"/>
+            <a:srgbClr val="EBEBEB"/>
           </a:solidFill>
           <a:ln>
             <a:noFill/>
@@ -46057,7 +46341,8 @@
                 <a:solidFill>
                   <a:srgbClr val="FD5108"/>
                 </a:solidFill>
-                <a:latin typeface="Microsoft JhengHei"/>
+                <a:latin typeface="微軟正黑體"/>
+                <a:ea typeface="微軟正黑體"/>
               </a:rPr>
               <a:t>◐</a:t>
             </a:r>
@@ -46066,7 +46351,7 @@
       </p:sp>
       <p:sp>
         <p:nvSpPr>
-          <p:cNvPr id="45" name="Rectangle 44"/>
+          <p:cNvPr id="49" name="Rectangle 48"/>
           <p:cNvSpPr/>
           <p:nvPr/>
         </p:nvSpPr>
@@ -46079,7 +46364,7 @@
             <a:avLst/>
           </a:prstGeom>
           <a:solidFill>
-            <a:srgbClr val="F3F3F3"/>
+            <a:srgbClr val="EBEBEB"/>
           </a:solidFill>
           <a:ln>
             <a:noFill/>
@@ -46112,9 +46397,10 @@
             <a:r>
               <a:rPr sz="1100" b="0">
                 <a:solidFill>
-                  <a:srgbClr val="1E1E1E"/>
+                  <a:srgbClr val="000000"/>
                 </a:solidFill>
-                <a:latin typeface="Microsoft JhengHei"/>
+                <a:latin typeface="Arial"/>
+                <a:ea typeface="微軟正黑體"/>
               </a:rPr>
               <a:t>6–8 週單一險種工作流藍圖</a:t>
             </a:r>
@@ -46123,7 +46409,7 @@
       </p:sp>
       <p:sp>
         <p:nvSpPr>
-          <p:cNvPr id="46" name="Rectangle 45"/>
+          <p:cNvPr id="50" name="Rectangle 49"/>
           <p:cNvSpPr/>
           <p:nvPr/>
         </p:nvSpPr>
@@ -46171,7 +46457,8 @@
                 <a:solidFill>
                   <a:srgbClr val="FD5108"/>
                 </a:solidFill>
-                <a:latin typeface="Microsoft JhengHei"/>
+                <a:latin typeface="Arial"/>
+                <a:ea typeface="微軟正黑體"/>
               </a:rPr>
               <a:t>第二波</a:t>
             </a:r>
@@ -46180,7 +46467,7 @@
       </p:sp>
       <p:sp>
         <p:nvSpPr>
-          <p:cNvPr id="47" name="Rectangle 46"/>
+          <p:cNvPr id="51" name="Rectangle 50"/>
           <p:cNvSpPr/>
           <p:nvPr/>
         </p:nvSpPr>
@@ -46226,9 +46513,10 @@
             <a:r>
               <a:rPr sz="1100" b="1">
                 <a:solidFill>
-                  <a:srgbClr val="1E1E1E"/>
+                  <a:srgbClr val="000000"/>
                 </a:solidFill>
-                <a:latin typeface="Microsoft JhengHei"/>
+                <a:latin typeface="Arial"/>
+                <a:ea typeface="微軟正黑體"/>
               </a:rPr>
               <a:t>AI 加速核心現代化與雲端</a:t>
             </a:r>
@@ -46237,7 +46525,7 @@
       </p:sp>
       <p:sp>
         <p:nvSpPr>
-          <p:cNvPr id="48" name="Rectangle 47"/>
+          <p:cNvPr id="52" name="Rectangle 51"/>
           <p:cNvSpPr/>
           <p:nvPr/>
         </p:nvSpPr>
@@ -46285,7 +46573,8 @@
                 <a:solidFill>
                   <a:srgbClr val="FD5108"/>
                 </a:solidFill>
-                <a:latin typeface="Microsoft JhengHei"/>
+                <a:latin typeface="微軟正黑體"/>
+                <a:ea typeface="微軟正黑體"/>
               </a:rPr>
               <a:t>◐</a:t>
             </a:r>
@@ -46294,7 +46583,7 @@
       </p:sp>
       <p:sp>
         <p:nvSpPr>
-          <p:cNvPr id="49" name="Rectangle 48"/>
+          <p:cNvPr id="53" name="Rectangle 52"/>
           <p:cNvSpPr/>
           <p:nvPr/>
         </p:nvSpPr>
@@ -46342,7 +46631,8 @@
                 <a:solidFill>
                   <a:srgbClr val="FD5108"/>
                 </a:solidFill>
-                <a:latin typeface="Microsoft JhengHei"/>
+                <a:latin typeface="微軟正黑體"/>
+                <a:ea typeface="微軟正黑體"/>
               </a:rPr>
               <a:t>◐</a:t>
             </a:r>
@@ -46351,7 +46641,7 @@
       </p:sp>
       <p:sp>
         <p:nvSpPr>
-          <p:cNvPr id="50" name="Rectangle 49"/>
+          <p:cNvPr id="54" name="Rectangle 53"/>
           <p:cNvSpPr/>
           <p:nvPr/>
         </p:nvSpPr>
@@ -46399,7 +46689,8 @@
                 <a:solidFill>
                   <a:srgbClr val="FD5108"/>
                 </a:solidFill>
-                <a:latin typeface="Microsoft JhengHei"/>
+                <a:latin typeface="微軟正黑體"/>
+                <a:ea typeface="微軟正黑體"/>
               </a:rPr>
               <a:t>○</a:t>
             </a:r>
@@ -46408,7 +46699,7 @@
       </p:sp>
       <p:sp>
         <p:nvSpPr>
-          <p:cNvPr id="51" name="Rectangle 50"/>
+          <p:cNvPr id="55" name="Rectangle 54"/>
           <p:cNvSpPr/>
           <p:nvPr/>
         </p:nvSpPr>
@@ -46454,9 +46745,10 @@
             <a:r>
               <a:rPr sz="1100" b="0">
                 <a:solidFill>
-                  <a:srgbClr val="1E1E1E"/>
+                  <a:srgbClr val="000000"/>
                 </a:solidFill>
-                <a:latin typeface="Microsoft JhengHei"/>
+                <a:latin typeface="Arial"/>
+                <a:ea typeface="微軟正黑體"/>
               </a:rPr>
               <a:t>雲端委外合規評估或 AI 重寫 PoC</a:t>
             </a:r>
@@ -46465,7 +46757,7 @@
       </p:sp>
       <p:sp>
         <p:nvSpPr>
-          <p:cNvPr id="52" name="Rectangle 51"/>
+          <p:cNvPr id="56" name="Rectangle 55"/>
           <p:cNvSpPr/>
           <p:nvPr/>
         </p:nvSpPr>
@@ -46513,7 +46805,8 @@
                 <a:solidFill>
                   <a:srgbClr val="FD5108"/>
                 </a:solidFill>
-                <a:latin typeface="Microsoft JhengHei"/>
+                <a:latin typeface="Arial"/>
+                <a:ea typeface="微軟正黑體"/>
               </a:rPr>
               <a:t>第二波</a:t>
             </a:r>
@@ -46522,7 +46815,7 @@
       </p:sp>
       <p:sp>
         <p:nvSpPr>
-          <p:cNvPr id="53" name="Rectangle 52"/>
+          <p:cNvPr id="57" name="Rectangle 56"/>
           <p:cNvSpPr/>
           <p:nvPr/>
         </p:nvSpPr>
@@ -46535,7 +46828,7 @@
             <a:avLst/>
           </a:prstGeom>
           <a:solidFill>
-            <a:srgbClr val="F3F3F3"/>
+            <a:srgbClr val="EBEBEB"/>
           </a:solidFill>
           <a:ln>
             <a:noFill/>
@@ -46568,9 +46861,10 @@
             <a:r>
               <a:rPr sz="1100" b="1">
                 <a:solidFill>
-                  <a:srgbClr val="1E1E1E"/>
+                  <a:srgbClr val="000000"/>
                 </a:solidFill>
-                <a:latin typeface="Microsoft JhengHei"/>
+                <a:latin typeface="Arial"/>
+                <a:ea typeface="微軟正黑體"/>
               </a:rPr>
               <a:t>深偽理賠反詐欺</a:t>
             </a:r>
@@ -46579,7 +46873,7 @@
       </p:sp>
       <p:sp>
         <p:nvSpPr>
-          <p:cNvPr id="54" name="Rectangle 53"/>
+          <p:cNvPr id="58" name="Rectangle 57"/>
           <p:cNvSpPr/>
           <p:nvPr/>
         </p:nvSpPr>
@@ -46592,7 +46886,7 @@
             <a:avLst/>
           </a:prstGeom>
           <a:solidFill>
-            <a:srgbClr val="F3F3F3"/>
+            <a:srgbClr val="EBEBEB"/>
           </a:solidFill>
           <a:ln>
             <a:noFill/>
@@ -46627,7 +46921,8 @@
                 <a:solidFill>
                   <a:srgbClr val="FD5108"/>
                 </a:solidFill>
-                <a:latin typeface="Microsoft JhengHei"/>
+                <a:latin typeface="微軟正黑體"/>
+                <a:ea typeface="微軟正黑體"/>
               </a:rPr>
               <a:t>◐</a:t>
             </a:r>
@@ -46636,7 +46931,7 @@
       </p:sp>
       <p:sp>
         <p:nvSpPr>
-          <p:cNvPr id="55" name="Rectangle 54"/>
+          <p:cNvPr id="59" name="Rectangle 58"/>
           <p:cNvSpPr/>
           <p:nvPr/>
         </p:nvSpPr>
@@ -46649,7 +46944,7 @@
             <a:avLst/>
           </a:prstGeom>
           <a:solidFill>
-            <a:srgbClr val="F3F3F3"/>
+            <a:srgbClr val="EBEBEB"/>
           </a:solidFill>
           <a:ln>
             <a:noFill/>
@@ -46684,7 +46979,8 @@
                 <a:solidFill>
                   <a:srgbClr val="FD5108"/>
                 </a:solidFill>
-                <a:latin typeface="Microsoft JhengHei"/>
+                <a:latin typeface="微軟正黑體"/>
+                <a:ea typeface="微軟正黑體"/>
               </a:rPr>
               <a:t>○</a:t>
             </a:r>
@@ -46693,7 +46989,7 @@
       </p:sp>
       <p:sp>
         <p:nvSpPr>
-          <p:cNvPr id="56" name="Rectangle 55"/>
+          <p:cNvPr id="60" name="Rectangle 59"/>
           <p:cNvSpPr/>
           <p:nvPr/>
         </p:nvSpPr>
@@ -46706,7 +47002,7 @@
             <a:avLst/>
           </a:prstGeom>
           <a:solidFill>
-            <a:srgbClr val="F3F3F3"/>
+            <a:srgbClr val="EBEBEB"/>
           </a:solidFill>
           <a:ln>
             <a:noFill/>
@@ -46741,7 +47037,8 @@
                 <a:solidFill>
                   <a:srgbClr val="FD5108"/>
                 </a:solidFill>
-                <a:latin typeface="Microsoft JhengHei"/>
+                <a:latin typeface="微軟正黑體"/>
+                <a:ea typeface="微軟正黑體"/>
               </a:rPr>
               <a:t>◐</a:t>
             </a:r>
@@ -46750,7 +47047,7 @@
       </p:sp>
       <p:sp>
         <p:nvSpPr>
-          <p:cNvPr id="57" name="Rectangle 56"/>
+          <p:cNvPr id="61" name="Rectangle 60"/>
           <p:cNvSpPr/>
           <p:nvPr/>
         </p:nvSpPr>
@@ -46763,7 +47060,7 @@
             <a:avLst/>
           </a:prstGeom>
           <a:solidFill>
-            <a:srgbClr val="F3F3F3"/>
+            <a:srgbClr val="EBEBEB"/>
           </a:solidFill>
           <a:ln>
             <a:noFill/>
@@ -46796,9 +47093,10 @@
             <a:r>
               <a:rPr sz="1100" b="0">
                 <a:solidFill>
-                  <a:srgbClr val="1E1E1E"/>
+                  <a:srgbClr val="000000"/>
                 </a:solidFill>
-                <a:latin typeface="Microsoft JhengHei"/>
+                <a:latin typeface="Arial"/>
+                <a:ea typeface="微軟正黑體"/>
               </a:rPr>
               <a:t>車損照片／醫療單據偽造偵測 PoC</a:t>
             </a:r>
@@ -46807,7 +47105,7 @@
       </p:sp>
       <p:sp>
         <p:nvSpPr>
-          <p:cNvPr id="58" name="Rectangle 57"/>
+          <p:cNvPr id="62" name="Rectangle 61"/>
           <p:cNvSpPr/>
           <p:nvPr/>
         </p:nvSpPr>
@@ -46855,7 +47153,8 @@
                 <a:solidFill>
                   <a:srgbClr val="FD5108"/>
                 </a:solidFill>
-                <a:latin typeface="Microsoft JhengHei"/>
+                <a:latin typeface="Arial"/>
+                <a:ea typeface="微軟正黑體"/>
               </a:rPr>
               <a:t>第二波</a:t>
             </a:r>
@@ -46864,7 +47163,7 @@
       </p:sp>
       <p:sp>
         <p:nvSpPr>
-          <p:cNvPr id="59" name="Rectangle 58"/>
+          <p:cNvPr id="63" name="Rectangle 62"/>
           <p:cNvSpPr/>
           <p:nvPr/>
         </p:nvSpPr>
@@ -46908,18 +47207,20 @@
             <a:r>
               <a:rPr sz="900" b="1">
                 <a:solidFill>
-                  <a:srgbClr val="6B6B6B"/>
+                  <a:srgbClr val="595959"/>
                 </a:solidFill>
-                <a:latin typeface="Microsoft JhengHei"/>
+                <a:latin typeface="Arial"/>
+                <a:ea typeface="微軟正黑體"/>
               </a:rPr>
               <a:t>來源：</a:t>
             </a:r>
             <a:r>
               <a:rPr sz="900" b="0" u="sng">
                 <a:solidFill>
-                  <a:srgbClr val="1F5FBF"/>
+                  <a:srgbClr val="595959"/>
                 </a:solidFill>
-                <a:latin typeface="Microsoft JhengHei"/>
+                <a:latin typeface="Arial"/>
+                <a:ea typeface="微軟正黑體"/>
                 <a:hlinkClick r:id="rId2"/>
               </a:rPr>
               <a:t>金管會 AI 指引</a:t>
@@ -46927,18 +47228,20 @@
             <a:r>
               <a:rPr sz="900" b="0">
                 <a:solidFill>
-                  <a:srgbClr val="6B6B6B"/>
+                  <a:srgbClr val="595959"/>
                 </a:solidFill>
-                <a:latin typeface="Microsoft JhengHei"/>
+                <a:latin typeface="Arial"/>
+                <a:ea typeface="微軟正黑體"/>
               </a:rPr>
               <a:t>　</a:t>
             </a:r>
             <a:r>
               <a:rPr sz="900" b="0" u="sng">
                 <a:solidFill>
-                  <a:srgbClr val="1F5FBF"/>
+                  <a:srgbClr val="595959"/>
                 </a:solidFill>
-                <a:latin typeface="Microsoft JhengHei"/>
+                <a:latin typeface="Arial"/>
+                <a:ea typeface="微軟正黑體"/>
                 <a:hlinkClick r:id="rId8"/>
               </a:rPr>
               <a:t>理律：AI 指引解析</a:t>
@@ -46946,18 +47249,20 @@
             <a:r>
               <a:rPr sz="900" b="0">
                 <a:solidFill>
-                  <a:srgbClr val="6B6B6B"/>
+                  <a:srgbClr val="595959"/>
                 </a:solidFill>
-                <a:latin typeface="Microsoft JhengHei"/>
+                <a:latin typeface="Arial"/>
+                <a:ea typeface="微軟正黑體"/>
               </a:rPr>
               <a:t>　</a:t>
             </a:r>
             <a:r>
               <a:rPr sz="900" b="0" u="sng">
                 <a:solidFill>
-                  <a:srgbClr val="1F5FBF"/>
+                  <a:srgbClr val="595959"/>
                 </a:solidFill>
-                <a:latin typeface="Microsoft JhengHei"/>
+                <a:latin typeface="Arial"/>
+                <a:ea typeface="微軟正黑體"/>
                 <a:hlinkClick r:id="rId3"/>
               </a:rPr>
               <a:t>金管會委外修正</a:t>
@@ -46965,18 +47270,20 @@
             <a:r>
               <a:rPr sz="900" b="0">
                 <a:solidFill>
-                  <a:srgbClr val="6B6B6B"/>
+                  <a:srgbClr val="595959"/>
                 </a:solidFill>
-                <a:latin typeface="Microsoft JhengHei"/>
+                <a:latin typeface="Arial"/>
+                <a:ea typeface="微軟正黑體"/>
               </a:rPr>
               <a:t>　</a:t>
             </a:r>
             <a:r>
               <a:rPr sz="900" b="0" u="sng">
                 <a:solidFill>
-                  <a:srgbClr val="1F5FBF"/>
+                  <a:srgbClr val="595959"/>
                 </a:solidFill>
-                <a:latin typeface="Microsoft JhengHei"/>
+                <a:latin typeface="Arial"/>
+                <a:ea typeface="微軟正黑體"/>
                 <a:hlinkClick r:id="rId4"/>
               </a:rPr>
               <a:t>理律：委外新辦法</a:t>
@@ -46984,18 +47291,20 @@
             <a:r>
               <a:rPr sz="900" b="0">
                 <a:solidFill>
-                  <a:srgbClr val="6B6B6B"/>
+                  <a:srgbClr val="595959"/>
                 </a:solidFill>
-                <a:latin typeface="Microsoft JhengHei"/>
+                <a:latin typeface="Arial"/>
+                <a:ea typeface="微軟正黑體"/>
               </a:rPr>
               <a:t>　</a:t>
             </a:r>
             <a:r>
               <a:rPr sz="900" b="0" u="sng">
                 <a:solidFill>
-                  <a:srgbClr val="1F5FBF"/>
+                  <a:srgbClr val="595959"/>
                 </a:solidFill>
-                <a:latin typeface="Microsoft JhengHei"/>
+                <a:latin typeface="Arial"/>
+                <a:ea typeface="微軟正黑體"/>
                 <a:hlinkClick r:id="rId9"/>
               </a:rPr>
               <a:t>公會雲端自律規範</a:t>
@@ -47003,18 +47312,20 @@
             <a:r>
               <a:rPr sz="900" b="0">
                 <a:solidFill>
-                  <a:srgbClr val="6B6B6B"/>
+                  <a:srgbClr val="595959"/>
                 </a:solidFill>
-                <a:latin typeface="Microsoft JhengHei"/>
+                <a:latin typeface="Arial"/>
+                <a:ea typeface="微軟正黑體"/>
               </a:rPr>
               <a:t>　</a:t>
             </a:r>
             <a:r>
               <a:rPr sz="900" b="0" u="sng">
                 <a:solidFill>
-                  <a:srgbClr val="1F5FBF"/>
+                  <a:srgbClr val="595959"/>
                 </a:solidFill>
-                <a:latin typeface="Microsoft JhengHei"/>
+                <a:latin typeface="Arial"/>
+                <a:ea typeface="微軟正黑體"/>
                 <a:hlinkClick r:id="rId5"/>
               </a:rPr>
               <a:t>資誠 IFRS 17 關鍵議題</a:t>
@@ -47022,18 +47333,20 @@
             <a:r>
               <a:rPr sz="900" b="0">
                 <a:solidFill>
-                  <a:srgbClr val="6B6B6B"/>
+                  <a:srgbClr val="595959"/>
                 </a:solidFill>
-                <a:latin typeface="Microsoft JhengHei"/>
+                <a:latin typeface="Arial"/>
+                <a:ea typeface="微軟正黑體"/>
               </a:rPr>
               <a:t>　</a:t>
             </a:r>
             <a:r>
               <a:rPr sz="900" b="0" u="sng">
                 <a:solidFill>
-                  <a:srgbClr val="1F5FBF"/>
+                  <a:srgbClr val="595959"/>
                 </a:solidFill>
-                <a:latin typeface="Microsoft JhengHei"/>
+                <a:latin typeface="Arial"/>
+                <a:ea typeface="微軟正黑體"/>
                 <a:hlinkClick r:id="rId10"/>
               </a:rPr>
               <a:t>NAIC 工作小組</a:t>
@@ -47041,18 +47354,20 @@
             <a:r>
               <a:rPr sz="900" b="0">
                 <a:solidFill>
-                  <a:srgbClr val="6B6B6B"/>
+                  <a:srgbClr val="595959"/>
                 </a:solidFill>
-                <a:latin typeface="Microsoft JhengHei"/>
+                <a:latin typeface="Arial"/>
+                <a:ea typeface="微軟正黑體"/>
               </a:rPr>
               <a:t>　</a:t>
             </a:r>
             <a:r>
               <a:rPr sz="900" b="0" u="sng">
                 <a:solidFill>
-                  <a:srgbClr val="1F5FBF"/>
+                  <a:srgbClr val="595959"/>
                 </a:solidFill>
-                <a:latin typeface="Microsoft JhengHei"/>
+                <a:latin typeface="Arial"/>
+                <a:ea typeface="微軟正黑體"/>
                 <a:hlinkClick r:id="rId7"/>
               </a:rPr>
               <a:t>MAS AI 指引</a:t>
@@ -47094,17 +47409,119 @@
           <a:lstStyle/>
           <a:p>
             <a:r>
-              <a:rPr sz="2000">
-                <a:latin typeface="Microsoft JhengHei"/>
+              <a:rPr sz="2000" b="1">
+                <a:latin typeface="Georgia"/>
+                <a:ea typeface="微軟正黑體"/>
               </a:rPr>
-              <a:t>MBB 與四大都在推代理型 AI 藍圖或平台；我們的空間在在地確信、IFRS 17 資料與駐點人力</a:t>
-            </a:r>
-          </a:p>
-        </p:txBody>
-      </p:sp>
-      <p:sp>
-        <p:nvSpPr>
-          <p:cNvPr id="3" name="Rectangle 2"/>
+              <a:t>MBB 與四大都在推代理型 AI 藍圖；我們以在地確信、IFRS 17 資料與駐點人力區隔</a:t>
+            </a:r>
+          </a:p>
+        </p:txBody>
+      </p:sp>
+      <p:sp>
+        <p:nvSpPr>
+          <p:cNvPr id="4" name="Footer Placeholder 4">
+            <a:extLst>
+              <a:ext uri="{FF2B5EF4-FFF2-40B4-BE49-F238E27FC236}">
+                <a16:creationId xmlns:a16="http://schemas.microsoft.com/office/drawing/2014/main" id="{E57B29C1-93EA-1886-CD27-23CE023225D9}"/>
+              </a:ext>
+            </a:extLst>
+          </p:cNvPr>
+          <p:cNvSpPr>
+            <a:spLocks noGrp="1"/>
+          </p:cNvSpPr>
+          <p:nvPr>
+            <p:ph type="ftr" sz="quarter" idx="3"/>
+          </p:nvPr>
+        </p:nvSpPr>
+        <p:spPr>
+          <a:xfrm>
+            <a:off x="1066800" y="6497441"/>
+            <a:ext cx="8814816" cy="161583"/>
+          </a:xfrm>
+          <a:prstGeom prst="rect">
+            <a:avLst/>
+          </a:prstGeom>
+        </p:spPr>
+        <p:txBody>
+          <a:bodyPr vert="horz" wrap="square" lIns="0" tIns="0" rIns="0" bIns="0" rtlCol="0" anchor="b" anchorCtr="0">
+            <a:spAutoFit/>
+          </a:bodyPr>
+          <a:lstStyle>
+            <a:lvl1pPr algn="l">
+              <a:defRPr sz="1050" b="0">
+                <a:solidFill>
+                  <a:sysClr val="windowText" lastClr="000000"/>
+                </a:solidFill>
+                <a:latin typeface="+mn-lt"/>
+                <a:cs typeface="Arial" panose="020B0604020202020204" pitchFamily="34" charset="0"/>
+              </a:defRPr>
+            </a:lvl1pPr>
+          </a:lstStyle>
+          <a:p>
+            <a:r>
+              <a:rPr>
+                <a:latin typeface="Arial"/>
+                <a:ea typeface="微軟正黑體"/>
+              </a:rPr>
+              <a:t>內部討論稿｜僅供 FSC1 保險組內部使用｜資料來源為公開研究，點選來源可開啟原文</a:t>
+            </a:r>
+          </a:p>
+        </p:txBody>
+      </p:sp>
+      <p:sp>
+        <p:nvSpPr>
+          <p:cNvPr id="6" name="Slide Number Placeholder 13">
+            <a:extLst>
+              <a:ext uri="{FF2B5EF4-FFF2-40B4-BE49-F238E27FC236}">
+                <a16:creationId xmlns:a16="http://schemas.microsoft.com/office/drawing/2014/main" id="{D15FEAD4-DFB9-ED08-EBEE-A4E5DE31E318}"/>
+              </a:ext>
+            </a:extLst>
+          </p:cNvPr>
+          <p:cNvSpPr>
+            <a:spLocks noGrp="1"/>
+          </p:cNvSpPr>
+          <p:nvPr>
+            <p:ph type="sldNum" sz="quarter" idx="4"/>
+          </p:nvPr>
+        </p:nvSpPr>
+        <p:spPr>
+          <a:xfrm>
+            <a:off x="11503818" y="6501384"/>
+            <a:ext cx="298209" cy="161583"/>
+          </a:xfrm>
+          <a:prstGeom prst="rect">
+            <a:avLst/>
+          </a:prstGeom>
+        </p:spPr>
+        <p:txBody>
+          <a:bodyPr vert="horz" wrap="square" lIns="0" tIns="0" rIns="0" bIns="0" rtlCol="0" anchor="b" anchorCtr="0">
+            <a:spAutoFit/>
+          </a:bodyPr>
+          <a:lstStyle>
+            <a:lvl1pPr algn="r">
+              <a:defRPr sz="1050">
+                <a:solidFill>
+                  <a:schemeClr val="tx1"/>
+                </a:solidFill>
+                <a:latin typeface="+mn-lt"/>
+                <a:cs typeface="Arial" panose="020B0604020202020204" pitchFamily="34" charset="0"/>
+              </a:defRPr>
+            </a:lvl1pPr>
+          </a:lstStyle>
+          <a:p>
+            <a:fld id="{3E6AC032-1535-134B-A583-D5E1DDD0D167}" type="slidenum">
+              <a:rPr lang="en-US" smtClean="0"/>
+              <a:pPr/>
+              <a:t>‹#›</a:t>
+            </a:fld>
+            <a:endParaRPr lang="en-US"/>
+          </a:p>
+        </p:txBody>
+      </p:sp>
+      <p:sp>
+        <p:nvSpPr>
+          <p:cNvPr id="7" name="Rectangle 6"/>
           <p:cNvSpPr/>
           <p:nvPr/>
         </p:nvSpPr>
@@ -47152,7 +47569,8 @@
                 <a:solidFill>
                   <a:srgbClr val="FFFFFF"/>
                 </a:solidFill>
-                <a:latin typeface="Microsoft JhengHei"/>
+                <a:latin typeface="Arial"/>
+                <a:ea typeface="微軟正黑體"/>
               </a:rPr>
               <a:t>機構</a:t>
             </a:r>
@@ -47161,7 +47579,7 @@
       </p:sp>
       <p:sp>
         <p:nvSpPr>
-          <p:cNvPr id="4" name="Rectangle 3"/>
+          <p:cNvPr id="8" name="Rectangle 7"/>
           <p:cNvSpPr/>
           <p:nvPr/>
         </p:nvSpPr>
@@ -47209,7 +47627,8 @@
                 <a:solidFill>
                   <a:srgbClr val="FFFFFF"/>
                 </a:solidFill>
-                <a:latin typeface="Microsoft JhengHei"/>
+                <a:latin typeface="Arial"/>
+                <a:ea typeface="微軟正黑體"/>
               </a:rPr>
               <a:t>保險 AI 主力產品／方法</a:t>
             </a:r>
@@ -47218,7 +47637,7 @@
       </p:sp>
       <p:sp>
         <p:nvSpPr>
-          <p:cNvPr id="5" name="Rectangle 4"/>
+          <p:cNvPr id="9" name="Rectangle 8"/>
           <p:cNvSpPr/>
           <p:nvPr/>
         </p:nvSpPr>
@@ -47266,7 +47685,8 @@
                 <a:solidFill>
                   <a:srgbClr val="FFFFFF"/>
                 </a:solidFill>
-                <a:latin typeface="Microsoft JhengHei"/>
+                <a:latin typeface="Arial"/>
+                <a:ea typeface="微軟正黑體"/>
               </a:rPr>
               <a:t>主攻</a:t>
             </a:r>
@@ -47275,7 +47695,7 @@
       </p:sp>
       <p:sp>
         <p:nvSpPr>
-          <p:cNvPr id="6" name="Rectangle 5"/>
+          <p:cNvPr id="10" name="Rectangle 9"/>
           <p:cNvSpPr/>
           <p:nvPr/>
         </p:nvSpPr>
@@ -47323,7 +47743,8 @@
                 <a:solidFill>
                   <a:srgbClr val="FFFFFF"/>
                 </a:solidFill>
-                <a:latin typeface="Microsoft JhengHei"/>
+                <a:latin typeface="Arial"/>
+                <a:ea typeface="微軟正黑體"/>
               </a:rPr>
               <a:t>可能侷限（推論）</a:t>
             </a:r>
@@ -47332,7 +47753,7 @@
       </p:sp>
       <p:sp>
         <p:nvSpPr>
-          <p:cNvPr id="7" name="Rectangle 6"/>
+          <p:cNvPr id="11" name="Rectangle 10"/>
           <p:cNvSpPr/>
           <p:nvPr/>
         </p:nvSpPr>
@@ -47380,7 +47801,8 @@
                 <a:solidFill>
                   <a:srgbClr val="FFFFFF"/>
                 </a:solidFill>
-                <a:latin typeface="Microsoft JhengHei"/>
+                <a:latin typeface="Arial"/>
+                <a:ea typeface="微軟正黑體"/>
               </a:rPr>
               <a:t>官網／原文</a:t>
             </a:r>
@@ -47389,7 +47811,7 @@
       </p:sp>
       <p:sp>
         <p:nvSpPr>
-          <p:cNvPr id="8" name="Rectangle 7"/>
+          <p:cNvPr id="12" name="Rectangle 11"/>
           <p:cNvSpPr/>
           <p:nvPr/>
         </p:nvSpPr>
@@ -47402,7 +47824,7 @@
             <a:avLst/>
           </a:prstGeom>
           <a:solidFill>
-            <a:srgbClr val="F3F3F3"/>
+            <a:srgbClr val="EBEBEB"/>
           </a:solidFill>
           <a:ln>
             <a:noFill/>
@@ -47435,9 +47857,10 @@
             <a:r>
               <a:rPr sz="1150" b="1">
                 <a:solidFill>
-                  <a:srgbClr val="1E1E1E"/>
+                  <a:srgbClr val="000000"/>
                 </a:solidFill>
-                <a:latin typeface="Microsoft JhengHei"/>
+                <a:latin typeface="Arial"/>
+                <a:ea typeface="微軟正黑體"/>
               </a:rPr>
               <a:t>McKinsey</a:t>
             </a:r>
@@ -47451,9 +47874,10 @@
             <a:r>
               <a:rPr sz="900" b="0">
                 <a:solidFill>
-                  <a:srgbClr val="6B6B6B"/>
+                  <a:srgbClr val="595959"/>
                 </a:solidFill>
-                <a:latin typeface="Microsoft JhengHei"/>
+                <a:latin typeface="Arial"/>
+                <a:ea typeface="微軟正黑體"/>
               </a:rPr>
               <a:t>MBB</a:t>
             </a:r>
@@ -47462,7 +47886,7 @@
       </p:sp>
       <p:sp>
         <p:nvSpPr>
-          <p:cNvPr id="9" name="Rectangle 8"/>
+          <p:cNvPr id="13" name="Rectangle 12"/>
           <p:cNvSpPr/>
           <p:nvPr/>
         </p:nvSpPr>
@@ -47475,7 +47899,7 @@
             <a:avLst/>
           </a:prstGeom>
           <a:solidFill>
-            <a:srgbClr val="F3F3F3"/>
+            <a:srgbClr val="EBEBEB"/>
           </a:solidFill>
           <a:ln>
             <a:noFill/>
@@ -47508,9 +47932,10 @@
             <a:r>
               <a:rPr sz="1000" b="0">
                 <a:solidFill>
-                  <a:srgbClr val="1E1E1E"/>
+                  <a:srgbClr val="000000"/>
                 </a:solidFill>
-                <a:latin typeface="Microsoft JhengHei"/>
+                <a:latin typeface="Arial"/>
+                <a:ea typeface="微軟正黑體"/>
               </a:rPr>
               <a:t>核保作業系統 UWOS：45 項能力、6 大領域；代理型 AI 核心現代化（原子化代理能力庫）</a:t>
             </a:r>
@@ -47519,7 +47944,7 @@
       </p:sp>
       <p:sp>
         <p:nvSpPr>
-          <p:cNvPr id="10" name="Rectangle 9"/>
+          <p:cNvPr id="14" name="Rectangle 13"/>
           <p:cNvSpPr/>
           <p:nvPr/>
         </p:nvSpPr>
@@ -47532,7 +47957,7 @@
             <a:avLst/>
           </a:prstGeom>
           <a:solidFill>
-            <a:srgbClr val="F3F3F3"/>
+            <a:srgbClr val="EBEBEB"/>
           </a:solidFill>
           <a:ln>
             <a:noFill/>
@@ -47565,9 +47990,10 @@
             <a:r>
               <a:rPr sz="1000" b="0">
                 <a:solidFill>
-                  <a:srgbClr val="1E1E1E"/>
+                  <a:srgbClr val="000000"/>
                 </a:solidFill>
-                <a:latin typeface="Microsoft JhengHei"/>
+                <a:latin typeface="Arial"/>
+                <a:ea typeface="微軟正黑體"/>
               </a:rPr>
               <a:t>商業與專業險核保、核心重寫</a:t>
             </a:r>
@@ -47576,7 +48002,7 @@
       </p:sp>
       <p:sp>
         <p:nvSpPr>
-          <p:cNvPr id="11" name="Rectangle 10"/>
+          <p:cNvPr id="15" name="Rectangle 14"/>
           <p:cNvSpPr/>
           <p:nvPr/>
         </p:nvSpPr>
@@ -47589,7 +48015,7 @@
             <a:avLst/>
           </a:prstGeom>
           <a:solidFill>
-            <a:srgbClr val="F3F3F3"/>
+            <a:srgbClr val="EBEBEB"/>
           </a:solidFill>
           <a:ln>
             <a:noFill/>
@@ -47622,9 +48048,10 @@
             <a:r>
               <a:rPr sz="1000" b="0">
                 <a:solidFill>
-                  <a:srgbClr val="1E1E1E"/>
+                  <a:srgbClr val="000000"/>
                 </a:solidFill>
-                <a:latin typeface="Microsoft JhengHei"/>
+                <a:latin typeface="Arial"/>
+                <a:ea typeface="微軟正黑體"/>
               </a:rPr>
               <a:t>在台缺在地法規確信與長期駐點人力</a:t>
             </a:r>
@@ -47633,7 +48060,7 @@
       </p:sp>
       <p:sp>
         <p:nvSpPr>
-          <p:cNvPr id="12" name="Rectangle 11"/>
+          <p:cNvPr id="16" name="Rectangle 15"/>
           <p:cNvSpPr/>
           <p:nvPr/>
         </p:nvSpPr>
@@ -47646,7 +48073,7 @@
             <a:avLst/>
           </a:prstGeom>
           <a:solidFill>
-            <a:srgbClr val="F3F3F3"/>
+            <a:srgbClr val="EBEBEB"/>
           </a:solidFill>
           <a:ln>
             <a:noFill/>
@@ -47679,9 +48106,10 @@
             <a:r>
               <a:rPr sz="950" b="0" u="sng">
                 <a:solidFill>
-                  <a:srgbClr val="1F5FBF"/>
+                  <a:srgbClr val="000000"/>
                 </a:solidFill>
-                <a:latin typeface="Microsoft JhengHei"/>
+                <a:latin typeface="Arial"/>
+                <a:ea typeface="微軟正黑體"/>
                 <a:hlinkClick r:id="rId2"/>
               </a:rPr>
               <a:t>UWOS</a:t>
@@ -47696,9 +48124,10 @@
             <a:r>
               <a:rPr sz="950" b="0" u="sng">
                 <a:solidFill>
-                  <a:srgbClr val="1F5FBF"/>
+                  <a:srgbClr val="000000"/>
                 </a:solidFill>
-                <a:latin typeface="Microsoft JhengHei"/>
+                <a:latin typeface="Arial"/>
+                <a:ea typeface="微軟正黑體"/>
                 <a:hlinkClick r:id="rId3"/>
               </a:rPr>
               <a:t>核心現代化</a:t>
@@ -47708,7 +48137,7 @@
       </p:sp>
       <p:sp>
         <p:nvSpPr>
-          <p:cNvPr id="13" name="Rectangle 12"/>
+          <p:cNvPr id="17" name="Rectangle 16"/>
           <p:cNvSpPr/>
           <p:nvPr/>
         </p:nvSpPr>
@@ -47754,9 +48183,10 @@
             <a:r>
               <a:rPr sz="1150" b="1">
                 <a:solidFill>
-                  <a:srgbClr val="1E1E1E"/>
+                  <a:srgbClr val="000000"/>
                 </a:solidFill>
-                <a:latin typeface="Microsoft JhengHei"/>
+                <a:latin typeface="Arial"/>
+                <a:ea typeface="微軟正黑體"/>
               </a:rPr>
               <a:t>BCG</a:t>
             </a:r>
@@ -47770,9 +48200,10 @@
             <a:r>
               <a:rPr sz="900" b="0">
                 <a:solidFill>
-                  <a:srgbClr val="6B6B6B"/>
+                  <a:srgbClr val="595959"/>
                 </a:solidFill>
-                <a:latin typeface="Microsoft JhengHei"/>
+                <a:latin typeface="Arial"/>
+                <a:ea typeface="微軟正黑體"/>
               </a:rPr>
               <a:t>MBB</a:t>
             </a:r>
@@ -47781,7 +48212,7 @@
       </p:sp>
       <p:sp>
         <p:nvSpPr>
-          <p:cNvPr id="14" name="Rectangle 13"/>
+          <p:cNvPr id="18" name="Rectangle 17"/>
           <p:cNvSpPr/>
           <p:nvPr/>
         </p:nvSpPr>
@@ -47827,9 +48258,10 @@
             <a:r>
               <a:rPr sz="1000" b="0">
                 <a:solidFill>
-                  <a:srgbClr val="1E1E1E"/>
+                  <a:srgbClr val="000000"/>
                 </a:solidFill>
-                <a:latin typeface="Microsoft JhengHei"/>
+                <a:latin typeface="Arial"/>
+                <a:ea typeface="微軟正黑體"/>
               </a:rPr>
               <a:t>「AI-First 產險公司」三階段藍圖；亞太保險代理型 AI 白皮書（資源 70% 放在人與變革）</a:t>
             </a:r>
@@ -47838,7 +48270,7 @@
       </p:sp>
       <p:sp>
         <p:nvSpPr>
-          <p:cNvPr id="15" name="Rectangle 14"/>
+          <p:cNvPr id="19" name="Rectangle 18"/>
           <p:cNvSpPr/>
           <p:nvPr/>
         </p:nvSpPr>
@@ -47884,9 +48316,10 @@
             <a:r>
               <a:rPr sz="1000" b="0">
                 <a:solidFill>
-                  <a:srgbClr val="1E1E1E"/>
+                  <a:srgbClr val="000000"/>
                 </a:solidFill>
-                <a:latin typeface="Microsoft JhengHei"/>
+                <a:latin typeface="Arial"/>
+                <a:ea typeface="微軟正黑體"/>
               </a:rPr>
               <a:t>策略藍圖、組織變革</a:t>
             </a:r>
@@ -47895,7 +48328,7 @@
       </p:sp>
       <p:sp>
         <p:nvSpPr>
-          <p:cNvPr id="16" name="Rectangle 15"/>
+          <p:cNvPr id="20" name="Rectangle 19"/>
           <p:cNvSpPr/>
           <p:nvPr/>
         </p:nvSpPr>
@@ -47941,9 +48374,10 @@
             <a:r>
               <a:rPr sz="1000" b="0">
                 <a:solidFill>
-                  <a:srgbClr val="1E1E1E"/>
+                  <a:srgbClr val="000000"/>
                 </a:solidFill>
-                <a:latin typeface="Microsoft JhengHei"/>
+                <a:latin typeface="Arial"/>
+                <a:ea typeface="微軟正黑體"/>
               </a:rPr>
               <a:t>偏策略與變革設計，系統落地多需另找夥伴</a:t>
             </a:r>
@@ -47952,7 +48386,7 @@
       </p:sp>
       <p:sp>
         <p:nvSpPr>
-          <p:cNvPr id="17" name="Rectangle 16"/>
+          <p:cNvPr id="21" name="Rectangle 20"/>
           <p:cNvSpPr/>
           <p:nvPr/>
         </p:nvSpPr>
@@ -47998,9 +48432,10 @@
             <a:r>
               <a:rPr sz="950" b="0" u="sng">
                 <a:solidFill>
-                  <a:srgbClr val="1F5FBF"/>
+                  <a:srgbClr val="000000"/>
                 </a:solidFill>
-                <a:latin typeface="Microsoft JhengHei"/>
+                <a:latin typeface="Arial"/>
+                <a:ea typeface="微軟正黑體"/>
                 <a:hlinkClick r:id="rId4"/>
               </a:rPr>
               <a:t>亞太白皮書</a:t>
@@ -48015,9 +48450,10 @@
             <a:r>
               <a:rPr sz="950" b="0" u="sng">
                 <a:solidFill>
-                  <a:srgbClr val="1F5FBF"/>
+                  <a:srgbClr val="000000"/>
                 </a:solidFill>
-                <a:latin typeface="Microsoft JhengHei"/>
+                <a:latin typeface="Arial"/>
+                <a:ea typeface="微軟正黑體"/>
                 <a:hlinkClick r:id="rId5"/>
               </a:rPr>
               <a:t>產險藍圖</a:t>
@@ -48027,7 +48463,7 @@
       </p:sp>
       <p:sp>
         <p:nvSpPr>
-          <p:cNvPr id="18" name="Rectangle 17"/>
+          <p:cNvPr id="22" name="Rectangle 21"/>
           <p:cNvSpPr/>
           <p:nvPr/>
         </p:nvSpPr>
@@ -48040,7 +48476,7 @@
             <a:avLst/>
           </a:prstGeom>
           <a:solidFill>
-            <a:srgbClr val="F3F3F3"/>
+            <a:srgbClr val="EBEBEB"/>
           </a:solidFill>
           <a:ln>
             <a:noFill/>
@@ -48073,9 +48509,10 @@
             <a:r>
               <a:rPr sz="1150" b="1">
                 <a:solidFill>
-                  <a:srgbClr val="1E1E1E"/>
+                  <a:srgbClr val="000000"/>
                 </a:solidFill>
-                <a:latin typeface="Microsoft JhengHei"/>
+                <a:latin typeface="Arial"/>
+                <a:ea typeface="微軟正黑體"/>
               </a:rPr>
               <a:t>Bain</a:t>
             </a:r>
@@ -48089,9 +48526,10 @@
             <a:r>
               <a:rPr sz="900" b="0">
                 <a:solidFill>
-                  <a:srgbClr val="6B6B6B"/>
+                  <a:srgbClr val="595959"/>
                 </a:solidFill>
-                <a:latin typeface="Microsoft JhengHei"/>
+                <a:latin typeface="Arial"/>
+                <a:ea typeface="微軟正黑體"/>
               </a:rPr>
               <a:t>MBB</a:t>
             </a:r>
@@ -48100,7 +48538,7 @@
       </p:sp>
       <p:sp>
         <p:nvSpPr>
-          <p:cNvPr id="19" name="Rectangle 18"/>
+          <p:cNvPr id="23" name="Rectangle 22"/>
           <p:cNvSpPr/>
           <p:nvPr/>
         </p:nvSpPr>
@@ -48113,7 +48551,7 @@
             <a:avLst/>
           </a:prstGeom>
           <a:solidFill>
-            <a:srgbClr val="F3F3F3"/>
+            <a:srgbClr val="EBEBEB"/>
           </a:solidFill>
           <a:ln>
             <a:noFill/>
@@ -48146,9 +48584,10 @@
             <a:r>
               <a:rPr sz="1000" b="0">
                 <a:solidFill>
-                  <a:srgbClr val="1E1E1E"/>
+                  <a:srgbClr val="000000"/>
                 </a:solidFill>
-                <a:latin typeface="Microsoft JhengHei"/>
+                <a:latin typeface="Arial"/>
+                <a:ea typeface="微軟正黑體"/>
               </a:rPr>
               <a:t>亞太保險公司以 AI 重塑理賠與客服案例；保險通路 GenAI 年效益逾 500 億美元（2024）</a:t>
             </a:r>
@@ -48157,7 +48596,7 @@
       </p:sp>
       <p:sp>
         <p:nvSpPr>
-          <p:cNvPr id="20" name="Rectangle 19"/>
+          <p:cNvPr id="24" name="Rectangle 23"/>
           <p:cNvSpPr/>
           <p:nvPr/>
         </p:nvSpPr>
@@ -48170,7 +48609,7 @@
             <a:avLst/>
           </a:prstGeom>
           <a:solidFill>
-            <a:srgbClr val="F3F3F3"/>
+            <a:srgbClr val="EBEBEB"/>
           </a:solidFill>
           <a:ln>
             <a:noFill/>
@@ -48203,9 +48642,10 @@
             <a:r>
               <a:rPr sz="1000" b="0">
                 <a:solidFill>
-                  <a:srgbClr val="1E1E1E"/>
+                  <a:srgbClr val="000000"/>
                 </a:solidFill>
-                <a:latin typeface="Microsoft JhengHei"/>
+                <a:latin typeface="Arial"/>
+                <a:ea typeface="微軟正黑體"/>
               </a:rPr>
               <a:t>理賠、客服、通路</a:t>
             </a:r>
@@ -48214,7 +48654,7 @@
       </p:sp>
       <p:sp>
         <p:nvSpPr>
-          <p:cNvPr id="21" name="Rectangle 20"/>
+          <p:cNvPr id="25" name="Rectangle 24"/>
           <p:cNvSpPr/>
           <p:nvPr/>
         </p:nvSpPr>
@@ -48227,7 +48667,7 @@
             <a:avLst/>
           </a:prstGeom>
           <a:solidFill>
-            <a:srgbClr val="F3F3F3"/>
+            <a:srgbClr val="EBEBEB"/>
           </a:solidFill>
           <a:ln>
             <a:noFill/>
@@ -48260,9 +48700,10 @@
             <a:r>
               <a:rPr sz="1000" b="0">
                 <a:solidFill>
-                  <a:srgbClr val="1E1E1E"/>
+                  <a:srgbClr val="000000"/>
                 </a:solidFill>
-                <a:latin typeface="Microsoft JhengHei"/>
+                <a:latin typeface="Arial"/>
+                <a:ea typeface="微軟正黑體"/>
               </a:rPr>
               <a:t>在台交付規模較小，大型核心導入人力有限</a:t>
             </a:r>
@@ -48271,7 +48712,7 @@
       </p:sp>
       <p:sp>
         <p:nvSpPr>
-          <p:cNvPr id="22" name="Rectangle 21"/>
+          <p:cNvPr id="26" name="Rectangle 25"/>
           <p:cNvSpPr/>
           <p:nvPr/>
         </p:nvSpPr>
@@ -48284,7 +48725,7 @@
             <a:avLst/>
           </a:prstGeom>
           <a:solidFill>
-            <a:srgbClr val="F3F3F3"/>
+            <a:srgbClr val="EBEBEB"/>
           </a:solidFill>
           <a:ln>
             <a:noFill/>
@@ -48317,9 +48758,10 @@
             <a:r>
               <a:rPr sz="950" b="0" u="sng">
                 <a:solidFill>
-                  <a:srgbClr val="1F5FBF"/>
+                  <a:srgbClr val="000000"/>
                 </a:solidFill>
-                <a:latin typeface="Microsoft JhengHei"/>
+                <a:latin typeface="Arial"/>
+                <a:ea typeface="微軟正黑體"/>
                 <a:hlinkClick r:id="rId6"/>
               </a:rPr>
               <a:t>案例</a:t>
@@ -48334,9 +48776,10 @@
             <a:r>
               <a:rPr sz="950" b="0" u="sng">
                 <a:solidFill>
-                  <a:srgbClr val="1F5FBF"/>
+                  <a:srgbClr val="000000"/>
                 </a:solidFill>
-                <a:latin typeface="Microsoft JhengHei"/>
+                <a:latin typeface="Arial"/>
+                <a:ea typeface="微軟正黑體"/>
                 <a:hlinkClick r:id="rId7"/>
               </a:rPr>
               <a:t>通路研究</a:t>
@@ -48346,7 +48789,7 @@
       </p:sp>
       <p:cxnSp>
         <p:nvCxnSpPr>
-          <p:cNvPr id="23" name="Connector 22"/>
+          <p:cNvPr id="27" name="Connector 26"/>
           <p:cNvCxnSpPr/>
           <p:nvPr/>
         </p:nvCxnSpPr>
@@ -48381,7 +48824,7 @@
       </p:cxnSp>
       <p:sp>
         <p:nvSpPr>
-          <p:cNvPr id="24" name="Rectangle 23"/>
+          <p:cNvPr id="28" name="Rectangle 27"/>
           <p:cNvSpPr/>
           <p:nvPr/>
         </p:nvSpPr>
@@ -48427,9 +48870,10 @@
             <a:r>
               <a:rPr sz="1150" b="1">
                 <a:solidFill>
-                  <a:srgbClr val="1E1E1E"/>
+                  <a:srgbClr val="000000"/>
                 </a:solidFill>
-                <a:latin typeface="Microsoft JhengHei"/>
+                <a:latin typeface="Arial"/>
+                <a:ea typeface="微軟正黑體"/>
               </a:rPr>
               <a:t>Deloitte</a:t>
             </a:r>
@@ -48443,9 +48887,10 @@
             <a:r>
               <a:rPr sz="900" b="0">
                 <a:solidFill>
-                  <a:srgbClr val="6B6B6B"/>
+                  <a:srgbClr val="595959"/>
                 </a:solidFill>
-                <a:latin typeface="Microsoft JhengHei"/>
+                <a:latin typeface="Arial"/>
+                <a:ea typeface="微軟正黑體"/>
               </a:rPr>
               <a:t>四大</a:t>
             </a:r>
@@ -48454,7 +48899,7 @@
       </p:sp>
       <p:sp>
         <p:nvSpPr>
-          <p:cNvPr id="25" name="Rectangle 24"/>
+          <p:cNvPr id="29" name="Rectangle 28"/>
           <p:cNvSpPr/>
           <p:nvPr/>
         </p:nvSpPr>
@@ -48500,9 +48945,10 @@
             <a:r>
               <a:rPr sz="1000" b="0">
                 <a:solidFill>
-                  <a:srgbClr val="1E1E1E"/>
+                  <a:srgbClr val="000000"/>
                 </a:solidFill>
-                <a:latin typeface="Microsoft JhengHei"/>
+                <a:latin typeface="微軟正黑體"/>
+                <a:ea typeface="微軟正黑體"/>
               </a:rPr>
               <a:t>Agentic AI Blueprint for Insurance：產險／壽險分類，評估→設計→試點→規模化，預建＋客製代理</a:t>
             </a:r>
@@ -48511,7 +48957,7 @@
       </p:sp>
       <p:sp>
         <p:nvSpPr>
-          <p:cNvPr id="26" name="Rectangle 25"/>
+          <p:cNvPr id="30" name="Rectangle 29"/>
           <p:cNvSpPr/>
           <p:nvPr/>
         </p:nvSpPr>
@@ -48557,9 +49003,10 @@
             <a:r>
               <a:rPr sz="1000" b="0">
                 <a:solidFill>
-                  <a:srgbClr val="1E1E1E"/>
+                  <a:srgbClr val="000000"/>
                 </a:solidFill>
-                <a:latin typeface="Microsoft JhengHei"/>
+                <a:latin typeface="Arial"/>
+                <a:ea typeface="微軟正黑體"/>
               </a:rPr>
               <a:t>全價值鏈代理型 AI 轉型</a:t>
             </a:r>
@@ -48568,7 +49015,7 @@
       </p:sp>
       <p:sp>
         <p:nvSpPr>
-          <p:cNvPr id="27" name="Rectangle 26"/>
+          <p:cNvPr id="31" name="Rectangle 30"/>
           <p:cNvSpPr/>
           <p:nvPr/>
         </p:nvSpPr>
@@ -48614,9 +49061,10 @@
             <a:r>
               <a:rPr sz="1000" b="0">
                 <a:solidFill>
-                  <a:srgbClr val="1E1E1E"/>
+                  <a:srgbClr val="000000"/>
                 </a:solidFill>
-                <a:latin typeface="Microsoft JhengHei"/>
+                <a:latin typeface="Arial"/>
+                <a:ea typeface="微軟正黑體"/>
               </a:rPr>
               <a:t>預建代理套到台灣客製化舊核心與繁中條款需調適</a:t>
             </a:r>
@@ -48625,7 +49073,7 @@
       </p:sp>
       <p:sp>
         <p:nvSpPr>
-          <p:cNvPr id="28" name="Rectangle 27"/>
+          <p:cNvPr id="32" name="Rectangle 31"/>
           <p:cNvSpPr/>
           <p:nvPr/>
         </p:nvSpPr>
@@ -48671,9 +49119,10 @@
             <a:r>
               <a:rPr sz="950" b="0" u="sng">
                 <a:solidFill>
-                  <a:srgbClr val="1F5FBF"/>
+                  <a:srgbClr val="000000"/>
                 </a:solidFill>
-                <a:latin typeface="Microsoft JhengHei"/>
+                <a:latin typeface="Arial"/>
+                <a:ea typeface="微軟正黑體"/>
                 <a:hlinkClick r:id="rId8"/>
               </a:rPr>
               <a:t>Blueprint</a:t>
@@ -48688,9 +49137,10 @@
             <a:r>
               <a:rPr sz="950" b="0" u="sng">
                 <a:solidFill>
-                  <a:srgbClr val="1F5FBF"/>
+                  <a:srgbClr val="000000"/>
                 </a:solidFill>
-                <a:latin typeface="Microsoft JhengHei"/>
+                <a:latin typeface="Arial"/>
+                <a:ea typeface="微軟正黑體"/>
                 <a:hlinkClick r:id="rId9"/>
               </a:rPr>
               <a:t>亞太壽險</a:t>
@@ -48700,7 +49150,7 @@
       </p:sp>
       <p:sp>
         <p:nvSpPr>
-          <p:cNvPr id="29" name="Rectangle 28"/>
+          <p:cNvPr id="33" name="Rectangle 32"/>
           <p:cNvSpPr/>
           <p:nvPr/>
         </p:nvSpPr>
@@ -48713,7 +49163,7 @@
             <a:avLst/>
           </a:prstGeom>
           <a:solidFill>
-            <a:srgbClr val="F3F3F3"/>
+            <a:srgbClr val="EBEBEB"/>
           </a:solidFill>
           <a:ln>
             <a:noFill/>
@@ -48746,9 +49196,10 @@
             <a:r>
               <a:rPr sz="1150" b="1">
                 <a:solidFill>
-                  <a:srgbClr val="1E1E1E"/>
+                  <a:srgbClr val="000000"/>
                 </a:solidFill>
-                <a:latin typeface="Microsoft JhengHei"/>
+                <a:latin typeface="Arial"/>
+                <a:ea typeface="微軟正黑體"/>
               </a:rPr>
               <a:t>EY</a:t>
             </a:r>
@@ -48762,9 +49213,10 @@
             <a:r>
               <a:rPr sz="900" b="0">
                 <a:solidFill>
-                  <a:srgbClr val="6B6B6B"/>
+                  <a:srgbClr val="595959"/>
                 </a:solidFill>
-                <a:latin typeface="Microsoft JhengHei"/>
+                <a:latin typeface="Arial"/>
+                <a:ea typeface="微軟正黑體"/>
               </a:rPr>
               <a:t>四大</a:t>
             </a:r>
@@ -48773,7 +49225,7 @@
       </p:sp>
       <p:sp>
         <p:nvSpPr>
-          <p:cNvPr id="30" name="Rectangle 29"/>
+          <p:cNvPr id="34" name="Rectangle 33"/>
           <p:cNvSpPr/>
           <p:nvPr/>
         </p:nvSpPr>
@@ -48786,7 +49238,7 @@
             <a:avLst/>
           </a:prstGeom>
           <a:solidFill>
-            <a:srgbClr val="F3F3F3"/>
+            <a:srgbClr val="EBEBEB"/>
           </a:solidFill>
           <a:ln>
             <a:noFill/>
@@ -48819,9 +49271,10 @@
             <a:r>
               <a:rPr sz="1000" b="0">
                 <a:solidFill>
-                  <a:srgbClr val="1E1E1E"/>
+                  <a:srgbClr val="000000"/>
                 </a:solidFill>
-                <a:latin typeface="Microsoft JhengHei"/>
+                <a:latin typeface="Arial"/>
+                <a:ea typeface="微軟正黑體"/>
               </a:rPr>
               <a:t>EY Nexus for Insurance：雲原生平台，快速推出新商品與品牌，串接 650+ 保險科技</a:t>
             </a:r>
@@ -48830,7 +49283,7 @@
       </p:sp>
       <p:sp>
         <p:nvSpPr>
-          <p:cNvPr id="31" name="Rectangle 30"/>
+          <p:cNvPr id="35" name="Rectangle 34"/>
           <p:cNvSpPr/>
           <p:nvPr/>
         </p:nvSpPr>
@@ -48843,7 +49296,7 @@
             <a:avLst/>
           </a:prstGeom>
           <a:solidFill>
-            <a:srgbClr val="F3F3F3"/>
+            <a:srgbClr val="EBEBEB"/>
           </a:solidFill>
           <a:ln>
             <a:noFill/>
@@ -48876,9 +49329,10 @@
             <a:r>
               <a:rPr sz="1000" b="0">
                 <a:solidFill>
-                  <a:srgbClr val="1E1E1E"/>
+                  <a:srgbClr val="000000"/>
                 </a:solidFill>
-                <a:latin typeface="Microsoft JhengHei"/>
+                <a:latin typeface="Arial"/>
+                <a:ea typeface="微軟正黑體"/>
               </a:rPr>
               <a:t>新商品、嵌入式通路、核心延伸</a:t>
             </a:r>
@@ -48887,7 +49341,7 @@
       </p:sp>
       <p:sp>
         <p:nvSpPr>
-          <p:cNvPr id="32" name="Rectangle 31"/>
+          <p:cNvPr id="36" name="Rectangle 35"/>
           <p:cNvSpPr/>
           <p:nvPr/>
         </p:nvSpPr>
@@ -48900,7 +49354,7 @@
             <a:avLst/>
           </a:prstGeom>
           <a:solidFill>
-            <a:srgbClr val="F3F3F3"/>
+            <a:srgbClr val="EBEBEB"/>
           </a:solidFill>
           <a:ln>
             <a:noFill/>
@@ -48933,9 +49387,10 @@
             <a:r>
               <a:rPr sz="1000" b="0">
                 <a:solidFill>
-                  <a:srgbClr val="1E1E1E"/>
+                  <a:srgbClr val="000000"/>
                 </a:solidFill>
-                <a:latin typeface="Microsoft JhengHei"/>
+                <a:latin typeface="Arial"/>
+                <a:ea typeface="微軟正黑體"/>
               </a:rPr>
               <a:t>偏新業務上線，舊核心遷移與 IFRS 17 整合難只靠平台</a:t>
             </a:r>
@@ -48944,7 +49399,7 @@
       </p:sp>
       <p:sp>
         <p:nvSpPr>
-          <p:cNvPr id="33" name="Rectangle 32"/>
+          <p:cNvPr id="37" name="Rectangle 36"/>
           <p:cNvSpPr/>
           <p:nvPr/>
         </p:nvSpPr>
@@ -48957,7 +49412,7 @@
             <a:avLst/>
           </a:prstGeom>
           <a:solidFill>
-            <a:srgbClr val="F3F3F3"/>
+            <a:srgbClr val="EBEBEB"/>
           </a:solidFill>
           <a:ln>
             <a:noFill/>
@@ -48990,9 +49445,10 @@
             <a:r>
               <a:rPr sz="950" b="0" u="sng">
                 <a:solidFill>
-                  <a:srgbClr val="1F5FBF"/>
+                  <a:srgbClr val="000000"/>
                 </a:solidFill>
-                <a:latin typeface="Microsoft JhengHei"/>
+                <a:latin typeface="Arial"/>
+                <a:ea typeface="微軟正黑體"/>
                 <a:hlinkClick r:id="rId10"/>
               </a:rPr>
               <a:t>Nexus</a:t>
@@ -49002,7 +49458,7 @@
       </p:sp>
       <p:sp>
         <p:nvSpPr>
-          <p:cNvPr id="34" name="Rectangle 33"/>
+          <p:cNvPr id="38" name="Rectangle 37"/>
           <p:cNvSpPr/>
           <p:nvPr/>
         </p:nvSpPr>
@@ -49048,9 +49504,10 @@
             <a:r>
               <a:rPr sz="1150" b="1">
                 <a:solidFill>
-                  <a:srgbClr val="1E1E1E"/>
+                  <a:srgbClr val="000000"/>
                 </a:solidFill>
-                <a:latin typeface="Microsoft JhengHei"/>
+                <a:latin typeface="Arial"/>
+                <a:ea typeface="微軟正黑體"/>
               </a:rPr>
               <a:t>KPMG</a:t>
             </a:r>
@@ -49064,9 +49521,10 @@
             <a:r>
               <a:rPr sz="900" b="0">
                 <a:solidFill>
-                  <a:srgbClr val="6B6B6B"/>
+                  <a:srgbClr val="595959"/>
                 </a:solidFill>
-                <a:latin typeface="Microsoft JhengHei"/>
+                <a:latin typeface="Arial"/>
+                <a:ea typeface="微軟正黑體"/>
               </a:rPr>
               <a:t>四大</a:t>
             </a:r>
@@ -49075,7 +49533,7 @@
       </p:sp>
       <p:sp>
         <p:nvSpPr>
-          <p:cNvPr id="35" name="Rectangle 34"/>
+          <p:cNvPr id="39" name="Rectangle 38"/>
           <p:cNvSpPr/>
           <p:nvPr/>
         </p:nvSpPr>
@@ -49121,9 +49579,10 @@
             <a:r>
               <a:rPr sz="1000" b="0">
                 <a:solidFill>
-                  <a:srgbClr val="1E1E1E"/>
+                  <a:srgbClr val="000000"/>
                 </a:solidFill>
-                <a:latin typeface="Microsoft JhengHei"/>
+                <a:latin typeface="Arial"/>
+                <a:ea typeface="微軟正黑體"/>
               </a:rPr>
               <a:t>Intelligent Insurance：AI 價值三階段導入；Trusted AI 十大支柱治理框架</a:t>
             </a:r>
@@ -49132,7 +49591,7 @@
       </p:sp>
       <p:sp>
         <p:nvSpPr>
-          <p:cNvPr id="36" name="Rectangle 35"/>
+          <p:cNvPr id="40" name="Rectangle 39"/>
           <p:cNvSpPr/>
           <p:nvPr/>
         </p:nvSpPr>
@@ -49178,9 +49637,10 @@
             <a:r>
               <a:rPr sz="1000" b="0">
                 <a:solidFill>
-                  <a:srgbClr val="1E1E1E"/>
+                  <a:srgbClr val="000000"/>
                 </a:solidFill>
-                <a:latin typeface="Microsoft JhengHei"/>
+                <a:latin typeface="Arial"/>
+                <a:ea typeface="微軟正黑體"/>
               </a:rPr>
               <a:t>AI 導入路徑與治理</a:t>
             </a:r>
@@ -49189,7 +49649,7 @@
       </p:sp>
       <p:sp>
         <p:nvSpPr>
-          <p:cNvPr id="37" name="Rectangle 36"/>
+          <p:cNvPr id="41" name="Rectangle 40"/>
           <p:cNvSpPr/>
           <p:nvPr/>
         </p:nvSpPr>
@@ -49235,9 +49695,10 @@
             <a:r>
               <a:rPr sz="1000" b="0">
                 <a:solidFill>
-                  <a:srgbClr val="1E1E1E"/>
+                  <a:srgbClr val="000000"/>
                 </a:solidFill>
-                <a:latin typeface="Microsoft JhengHei"/>
+                <a:latin typeface="Arial"/>
+                <a:ea typeface="微軟正黑體"/>
               </a:rPr>
               <a:t>公開資料未見保險專屬代理型產品</a:t>
             </a:r>
@@ -49246,7 +49707,7 @@
       </p:sp>
       <p:sp>
         <p:nvSpPr>
-          <p:cNvPr id="38" name="Rectangle 37"/>
+          <p:cNvPr id="42" name="Rectangle 41"/>
           <p:cNvSpPr/>
           <p:nvPr/>
         </p:nvSpPr>
@@ -49292,9 +49753,10 @@
             <a:r>
               <a:rPr sz="950" b="0" u="sng">
                 <a:solidFill>
-                  <a:srgbClr val="1F5FBF"/>
+                  <a:srgbClr val="000000"/>
                 </a:solidFill>
-                <a:latin typeface="Microsoft JhengHei"/>
+                <a:latin typeface="Arial"/>
+                <a:ea typeface="微軟正黑體"/>
                 <a:hlinkClick r:id="rId11"/>
               </a:rPr>
               <a:t>Intelligent Insurance</a:t>
@@ -49309,9 +49771,10 @@
             <a:r>
               <a:rPr sz="950" b="0" u="sng">
                 <a:solidFill>
-                  <a:srgbClr val="1F5FBF"/>
+                  <a:srgbClr val="000000"/>
                 </a:solidFill>
-                <a:latin typeface="Microsoft JhengHei"/>
+                <a:latin typeface="Arial"/>
+                <a:ea typeface="微軟正黑體"/>
                 <a:hlinkClick r:id="rId12"/>
               </a:rPr>
               <a:t>Trusted AI</a:t>
@@ -49321,7 +49784,7 @@
       </p:sp>
       <p:sp>
         <p:nvSpPr>
-          <p:cNvPr id="39" name="Rectangle 38"/>
+          <p:cNvPr id="43" name="Rectangle 42"/>
           <p:cNvSpPr/>
           <p:nvPr/>
         </p:nvSpPr>
@@ -49369,7 +49832,8 @@
                 <a:solidFill>
                   <a:srgbClr val="FD5108"/>
                 </a:solidFill>
-                <a:latin typeface="Microsoft JhengHei"/>
+                <a:latin typeface="Arial"/>
+                <a:ea typeface="微軟正黑體"/>
               </a:rPr>
               <a:t>PwC（所內）</a:t>
             </a:r>
@@ -49383,9 +49847,10 @@
             <a:r>
               <a:rPr sz="900" b="0">
                 <a:solidFill>
-                  <a:srgbClr val="6B6B6B"/>
+                  <a:srgbClr val="595959"/>
                 </a:solidFill>
-                <a:latin typeface="Microsoft JhengHei"/>
+                <a:latin typeface="Arial"/>
+                <a:ea typeface="微軟正黑體"/>
               </a:rPr>
               <a:t>四大</a:t>
             </a:r>
@@ -49394,7 +49859,7 @@
       </p:sp>
       <p:sp>
         <p:nvSpPr>
-          <p:cNvPr id="40" name="Rectangle 39"/>
+          <p:cNvPr id="44" name="Rectangle 43"/>
           <p:cNvSpPr/>
           <p:nvPr/>
         </p:nvSpPr>
@@ -49440,9 +49905,10 @@
             <a:r>
               <a:rPr sz="1000" b="0">
                 <a:solidFill>
-                  <a:srgbClr val="1E1E1E"/>
+                  <a:srgbClr val="000000"/>
                 </a:solidFill>
-                <a:latin typeface="Microsoft JhengHei"/>
+                <a:latin typeface="Arial"/>
+                <a:ea typeface="微軟正黑體"/>
               </a:rPr>
               <a:t>Agent OS 代理編排平台（跨廠商串接、權限控管、監督儀表板）；IFRS 17／TW-ICS 與 AI 治理服務</a:t>
             </a:r>
@@ -49451,7 +49917,7 @@
       </p:sp>
       <p:sp>
         <p:nvSpPr>
-          <p:cNvPr id="41" name="Rectangle 40"/>
+          <p:cNvPr id="45" name="Rectangle 44"/>
           <p:cNvSpPr/>
           <p:nvPr/>
         </p:nvSpPr>
@@ -49497,9 +49963,10 @@
             <a:r>
               <a:rPr sz="1000" b="0">
                 <a:solidFill>
-                  <a:srgbClr val="1E1E1E"/>
+                  <a:srgbClr val="000000"/>
                 </a:solidFill>
-                <a:latin typeface="Microsoft JhengHei"/>
+                <a:latin typeface="Arial"/>
+                <a:ea typeface="微軟正黑體"/>
               </a:rPr>
               <a:t>治理＋財務資料＋落地</a:t>
             </a:r>
@@ -49508,7 +49975,7 @@
       </p:sp>
       <p:sp>
         <p:nvSpPr>
-          <p:cNvPr id="42" name="Rectangle 41"/>
+          <p:cNvPr id="46" name="Rectangle 45"/>
           <p:cNvSpPr/>
           <p:nvPr/>
         </p:nvSpPr>
@@ -49554,9 +50021,10 @@
             <a:r>
               <a:rPr sz="1000" b="0">
                 <a:solidFill>
-                  <a:srgbClr val="1E1E1E"/>
+                  <a:srgbClr val="000000"/>
                 </a:solidFill>
-                <a:latin typeface="Microsoft JhengHei"/>
+                <a:latin typeface="Arial"/>
+                <a:ea typeface="微軟正黑體"/>
               </a:rPr>
               <a:t>可協作：把 Agent OS 與確信能力帶進第一波服務包</a:t>
             </a:r>
@@ -49565,7 +50033,7 @@
       </p:sp>
       <p:sp>
         <p:nvSpPr>
-          <p:cNvPr id="43" name="Rectangle 42"/>
+          <p:cNvPr id="47" name="Rectangle 46"/>
           <p:cNvSpPr/>
           <p:nvPr/>
         </p:nvSpPr>
@@ -49611,9 +50079,10 @@
             <a:r>
               <a:rPr sz="950" b="0" u="sng">
                 <a:solidFill>
-                  <a:srgbClr val="1F5FBF"/>
+                  <a:srgbClr val="000000"/>
                 </a:solidFill>
-                <a:latin typeface="Microsoft JhengHei"/>
+                <a:latin typeface="Arial"/>
+                <a:ea typeface="微軟正黑體"/>
                 <a:hlinkClick r:id="rId13"/>
               </a:rPr>
               <a:t>Agent OS</a:t>
@@ -49628,9 +50097,10 @@
             <a:r>
               <a:rPr sz="950" b="0" u="sng">
                 <a:solidFill>
-                  <a:srgbClr val="1F5FBF"/>
+                  <a:srgbClr val="000000"/>
                 </a:solidFill>
-                <a:latin typeface="Microsoft JhengHei"/>
+                <a:latin typeface="Arial"/>
+                <a:ea typeface="微軟正黑體"/>
                 <a:hlinkClick r:id="rId14"/>
               </a:rPr>
               <a:t>IFRS 17</a:t>
@@ -49640,7 +50110,7 @@
       </p:sp>
       <p:sp>
         <p:nvSpPr>
-          <p:cNvPr id="44" name="Rectangle 43"/>
+          <p:cNvPr id="48" name="Rectangle 47"/>
           <p:cNvSpPr/>
           <p:nvPr/>
         </p:nvSpPr>
@@ -49684,9 +50154,10 @@
             <a:r>
               <a:rPr sz="900" b="0">
                 <a:solidFill>
-                  <a:srgbClr val="6B6B6B"/>
+                  <a:srgbClr val="595959"/>
                 </a:solidFill>
-                <a:latin typeface="Microsoft JhengHei"/>
+                <a:latin typeface="Arial"/>
+                <a:ea typeface="微軟正黑體"/>
               </a:rPr>
               <a:t>「可能侷限」為依公開資料的推論，僅供內部討論，對外勿點名競爭者。點選右欄可開啟各機構官網或原文。</a:t>
             </a:r>

</xml_diff>